<commit_message>
Add funded-balance slide from the supplied balance grid
New slide 7 charts the balance matrix for customers with balance > 0:
THB 5.48bn across 320.1k funded customers.

The headline is bigger than the Save Max story it follows. THB 3.83bn -
70% of the entire deposit book - sits with rate-sensitive customers,
held by just 7.8% of funded customers, and Save Max is only 12.5% of
that book. 97% of the rate-sensitive balance is with High or Very High
stickiness customers, the same pattern as Save Max at eight times the
size, leaving THB 99m genuinely fragile.

Also flags that only 4 customers land in the Medium rate-sensitivity
band, so the score is effectively binary - worth knowing before the
cut-offs are recalibrated after maturity.

Co-Authored-By: Claude Opus 5 <noreply@anthropic.com>
Claude-Session: https://claude.ai/code/session_01VKpfo226Go9vQJYa4eoC1d
</commit_message>
<xml_diff>
--- a/Deposit_Stickiness_Framework.pptx
+++ b/Deposit_Stickiness_Framework.pptx
@@ -11,9 +11,10 @@
     <p:sldId id="259" r:id="rId5"/>
     <p:sldId id="260" r:id="rId6"/>
     <p:sldId id="261" r:id="rId7"/>
+    <p:sldId id="262" r:id="rId8"/>
   </p:sldIdLst>
   <p:notesMasterIdLst>
-    <p:notesMasterId r:id="rId8"/>
+    <p:notesMasterId r:id="rId9"/>
   </p:notesMasterIdLst>
   <p:sldSz cx="12192000" cy="6858000"/>
   <p:notesSz cx="6858000" cy="12192000"/>
@@ -971,6 +972,94 @@
             <a:fld id="{F7021451-1387-4CA6-816F-3879F97B5CBC}" type="slidenum">
               <a:rPr lang="en-US"/>
               <a:t>6</a:t>
+            </a:fld>
+            <a:endParaRPr lang="en-US"/>
+          </a:p>
+        </p:txBody>
+      </p:sp>
+    </p:spTree>
+    <p:extLst>
+      <p:ext uri="{BB962C8B-B14F-4D97-AF65-F5344CB8AC3E}">
+        <p14:creationId xmlns:p14="http://schemas.microsoft.com/office/powerpoint/2010/main" val="1024086991"/>
+      </p:ext>
+    </p:extLst>
+  </p:cSld>
+  <p:clrMapOvr>
+    <a:masterClrMapping/>
+  </p:clrMapOvr>
+</p:notes>
+</file>
+
+<file path=ppt/notesSlides/notesSlide7.xml><?xml version="1.0" encoding="utf-8"?>
+<p:notes xmlns:a="http://schemas.openxmlformats.org/drawingml/2006/main" xmlns:r="http://schemas.openxmlformats.org/officeDocument/2006/relationships" xmlns:p="http://schemas.openxmlformats.org/presentationml/2006/main">
+  <p:cSld>
+    <p:spTree>
+      <p:nvGrpSpPr>
+        <p:cNvPr id="1" name=""/>
+        <p:cNvGrpSpPr/>
+        <p:nvPr/>
+      </p:nvGrpSpPr>
+      <p:grpSpPr>
+        <a:xfrm>
+          <a:off x="0" y="0"/>
+          <a:ext cx="0" cy="0"/>
+          <a:chOff x="0" y="0"/>
+          <a:chExt cx="0" cy="0"/>
+        </a:xfrm>
+      </p:grpSpPr>
+      <p:sp>
+        <p:nvSpPr>
+          <p:cNvPr id="2" name="Slide Image Placeholder 1"/>
+          <p:cNvSpPr>
+            <a:spLocks noGrp="1" noRot="1" noChangeAspect="1"/>
+          </p:cNvSpPr>
+          <p:nvPr>
+            <p:ph type="sldImg"/>
+          </p:nvPr>
+        </p:nvSpPr>
+        <p:spPr/>
+      </p:sp>
+      <p:sp>
+        <p:nvSpPr>
+          <p:cNvPr id="3" name="Notes Placeholder 2"/>
+          <p:cNvSpPr>
+            <a:spLocks noGrp="1"/>
+          </p:cNvSpPr>
+          <p:nvPr>
+            <p:ph type="body" idx="1"/>
+          </p:nvPr>
+        </p:nvSpPr>
+        <p:spPr/>
+        <p:txBody>
+          <a:bodyPr/>
+          <a:lstStyle/>
+          <a:p>
+            <a:r>
+              <a:rPr lang="en-US" dirty="0"/>
+              <a:t>Total funded balance THB 5,477,500,353 across 320,109 customers, average THB 17,111. Rate-sensitive balance THB 3,830,436,985 (70%) held by only 24,971 customers (8% of the funded base). Save Max is THB 685,023,126, just 13% of the book, so rate-sensitivity exposure extends well beyond the maturing product. Balance concentrates hard: High and Very High stickiness hold 96% of balance on 49% of funded customers. Only 4 customers land in the Medium rate-sensitivity band, so the score is effectively binary - worth revisiting when the cut-offs are recalibrated after maturity.</a:t>
+            </a:r>
+            <a:endParaRPr lang="en-US" dirty="0"/>
+          </a:p>
+        </p:txBody>
+      </p:sp>
+      <p:sp>
+        <p:nvSpPr>
+          <p:cNvPr id="4" name="Slide Number Placeholder 3"/>
+          <p:cNvSpPr>
+            <a:spLocks noGrp="1"/>
+          </p:cNvSpPr>
+          <p:nvPr>
+            <p:ph type="sldNum" sz="quarter" idx="10"/>
+          </p:nvPr>
+        </p:nvSpPr>
+        <p:spPr/>
+        <p:txBody>
+          <a:bodyPr/>
+          <a:lstStyle/>
+          <a:p>
+            <a:fld id="{F7021451-1387-4CA6-816F-3879F97B5CBC}" type="slidenum">
+              <a:rPr lang="en-US"/>
+              <a:t>7</a:t>
             </a:fld>
             <a:endParaRPr lang="en-US"/>
           </a:p>
@@ -21016,6 +21105,4058 @@
 </p:sld>
 </file>
 
+<file path=ppt/slides/slide7.xml><?xml version="1.0" encoding="utf-8"?>
+<p:sld xmlns:a="http://schemas.openxmlformats.org/drawingml/2006/main" xmlns:r="http://schemas.openxmlformats.org/officeDocument/2006/relationships" xmlns:p="http://schemas.openxmlformats.org/presentationml/2006/main">
+  <p:cSld name="Slide 7">
+    <p:bg>
+      <p:bgPr>
+        <a:solidFill>
+          <a:srgbClr val="FFFFFF"/>
+        </a:solidFill>
+      </p:bgPr>
+    </p:bg>
+    <p:spTree>
+      <p:nvGrpSpPr>
+        <p:cNvPr id="1" name=""/>
+        <p:cNvGrpSpPr/>
+        <p:nvPr/>
+      </p:nvGrpSpPr>
+      <p:grpSpPr>
+        <a:xfrm>
+          <a:off x="0" y="0"/>
+          <a:ext cx="0" cy="0"/>
+          <a:chOff x="0" y="0"/>
+          <a:chExt cx="0" cy="0"/>
+        </a:xfrm>
+      </p:grpSpPr>
+      <p:sp>
+        <p:nvSpPr>
+          <p:cNvPr id="2" name="Text 0"/>
+          <p:cNvSpPr/>
+          <p:nvPr/>
+        </p:nvSpPr>
+        <p:spPr>
+          <a:xfrm>
+            <a:off x="530352" y="283464"/>
+            <a:ext cx="11274552" cy="384048"/>
+          </a:xfrm>
+          <a:prstGeom prst="rect">
+            <a:avLst/>
+          </a:prstGeom>
+          <a:noFill/>
+          <a:ln/>
+        </p:spPr>
+        <p:txBody>
+          <a:bodyPr wrap="square" lIns="0" tIns="0" rIns="0" bIns="0" rtlCol="0" anchor="ctr"/>
+          <a:lstStyle/>
+          <a:p>
+            <a:pPr indent="0" marL="0">
+              <a:buNone/>
+            </a:pPr>
+            <a:r>
+              <a:rPr lang="en-US" sz="2200" b="1" dirty="0">
+                <a:solidFill>
+                  <a:srgbClr val="045D66"/>
+                </a:solidFill>
+                <a:latin typeface="Graphik TH" pitchFamily="34" charset="0"/>
+                <a:ea typeface="Graphik TH" pitchFamily="34" charset="-122"/>
+                <a:cs typeface="Graphik TH" pitchFamily="34" charset="-120"/>
+              </a:rPr>
+              <a:t>Funded balance : THB 5.48bn — 70% of it is rate-sensitive</a:t>
+            </a:r>
+            <a:endParaRPr lang="en-US" sz="2200" dirty="0"/>
+          </a:p>
+        </p:txBody>
+      </p:sp>
+      <p:sp>
+        <p:nvSpPr>
+          <p:cNvPr id="3" name="Text 1"/>
+          <p:cNvSpPr/>
+          <p:nvPr/>
+        </p:nvSpPr>
+        <p:spPr>
+          <a:xfrm>
+            <a:off x="530352" y="713232"/>
+            <a:ext cx="11274552" cy="237744"/>
+          </a:xfrm>
+          <a:prstGeom prst="rect">
+            <a:avLst/>
+          </a:prstGeom>
+          <a:noFill/>
+          <a:ln/>
+        </p:spPr>
+        <p:txBody>
+          <a:bodyPr wrap="square" lIns="0" tIns="0" rIns="0" bIns="0" rtlCol="0" anchor="ctr"/>
+          <a:lstStyle/>
+          <a:p>
+            <a:pPr indent="0" marL="0">
+              <a:buNone/>
+            </a:pPr>
+            <a:r>
+              <a:rPr lang="en-US" sz="1150" i="1" dirty="0">
+                <a:solidFill>
+                  <a:srgbClr val="6B6B6B"/>
+                </a:solidFill>
+                <a:latin typeface="Graphik TH" pitchFamily="34" charset="0"/>
+                <a:ea typeface="Graphik TH" pitchFamily="34" charset="-122"/>
+                <a:cs typeface="Graphik TH" pitchFamily="34" charset="-120"/>
+              </a:rPr>
+              <a:t>*Customers with balance &gt; 0. Only 4 customers score Medium rate sensitivity, so that band is effectively empty — the score is close to binary.</a:t>
+            </a:r>
+            <a:endParaRPr lang="en-US" sz="1150" dirty="0"/>
+          </a:p>
+        </p:txBody>
+      </p:sp>
+      <p:sp>
+        <p:nvSpPr>
+          <p:cNvPr id="4" name="Text 2"/>
+          <p:cNvSpPr/>
+          <p:nvPr/>
+        </p:nvSpPr>
+        <p:spPr>
+          <a:xfrm>
+            <a:off x="548640" y="996696"/>
+            <a:ext cx="11064240" cy="237744"/>
+          </a:xfrm>
+          <a:prstGeom prst="rect">
+            <a:avLst/>
+          </a:prstGeom>
+          <a:noFill/>
+          <a:ln/>
+        </p:spPr>
+        <p:txBody>
+          <a:bodyPr wrap="square" lIns="0" tIns="0" rIns="0" bIns="0" rtlCol="0" anchor="ctr"/>
+          <a:lstStyle/>
+          <a:p>
+            <a:pPr indent="0" marL="0">
+              <a:buNone/>
+            </a:pPr>
+            <a:r>
+              <a:rPr lang="en-US" sz="1300" b="1" dirty="0">
+                <a:solidFill>
+                  <a:srgbClr val="045D66"/>
+                </a:solidFill>
+                <a:latin typeface="Graphik TH" pitchFamily="34" charset="0"/>
+                <a:ea typeface="Graphik TH" pitchFamily="34" charset="-122"/>
+                <a:cs typeface="Graphik TH" pitchFamily="34" charset="-120"/>
+              </a:rPr>
+              <a:t>Total THB 5.48bn   ·   Rate-sensitive THB 3.83bn (70%)   ·   Save Max THB 0.69bn — 13% of the book</a:t>
+            </a:r>
+            <a:endParaRPr lang="en-US" sz="1300" dirty="0"/>
+          </a:p>
+        </p:txBody>
+      </p:sp>
+      <p:sp>
+        <p:nvSpPr>
+          <p:cNvPr id="5" name="Text 3"/>
+          <p:cNvSpPr/>
+          <p:nvPr/>
+        </p:nvSpPr>
+        <p:spPr>
+          <a:xfrm>
+            <a:off x="548640" y="1280160"/>
+            <a:ext cx="11064240" cy="274320"/>
+          </a:xfrm>
+          <a:prstGeom prst="rect">
+            <a:avLst/>
+          </a:prstGeom>
+          <a:noFill/>
+          <a:ln/>
+        </p:spPr>
+        <p:txBody>
+          <a:bodyPr wrap="square" lIns="0" tIns="0" rIns="0" bIns="0" rtlCol="0" anchor="ctr"/>
+          <a:lstStyle/>
+          <a:p>
+            <a:pPr indent="0" marL="0">
+              <a:buNone/>
+            </a:pPr>
+            <a:r>
+              <a:rPr lang="en-US" sz="1400" dirty="0">
+                <a:solidFill>
+                  <a:srgbClr val="16233D"/>
+                </a:solidFill>
+                <a:latin typeface="Graphik TH" pitchFamily="34" charset="0"/>
+                <a:ea typeface="Graphik TH" pitchFamily="34" charset="-122"/>
+                <a:cs typeface="Graphik TH" pitchFamily="34" charset="-120"/>
+              </a:rPr>
+              <a:t>Seven baht in ten across the deposit book is rate-sensitive — the exposure runs far wider than Save Max.</a:t>
+            </a:r>
+            <a:endParaRPr lang="en-US" sz="1400" dirty="0"/>
+          </a:p>
+        </p:txBody>
+      </p:sp>
+      <p:sp>
+        <p:nvSpPr>
+          <p:cNvPr id="6" name="Shape 4"/>
+          <p:cNvSpPr/>
+          <p:nvPr/>
+        </p:nvSpPr>
+        <p:spPr>
+          <a:xfrm>
+            <a:off x="530352" y="1645920"/>
+            <a:ext cx="2647188" cy="987552"/>
+          </a:xfrm>
+          <a:prstGeom prst="roundRect">
+            <a:avLst>
+              <a:gd name="adj" fmla="val 8333"/>
+            </a:avLst>
+          </a:prstGeom>
+          <a:solidFill>
+            <a:srgbClr val="F1F4F9"/>
+          </a:solidFill>
+          <a:ln/>
+        </p:spPr>
+      </p:sp>
+      <p:sp>
+        <p:nvSpPr>
+          <p:cNvPr id="7" name="Text 5"/>
+          <p:cNvSpPr/>
+          <p:nvPr/>
+        </p:nvSpPr>
+        <p:spPr>
+          <a:xfrm>
+            <a:off x="749808" y="1719072"/>
+            <a:ext cx="2208276" cy="402336"/>
+          </a:xfrm>
+          <a:prstGeom prst="rect">
+            <a:avLst/>
+          </a:prstGeom>
+          <a:noFill/>
+          <a:ln/>
+        </p:spPr>
+        <p:txBody>
+          <a:bodyPr wrap="square" lIns="0" tIns="0" rIns="0" bIns="0" rtlCol="0" anchor="ctr"/>
+          <a:lstStyle/>
+          <a:p>
+            <a:pPr indent="0" marL="0">
+              <a:buNone/>
+            </a:pPr>
+            <a:r>
+              <a:rPr lang="en-US" sz="2400" b="1" dirty="0">
+                <a:solidFill>
+                  <a:srgbClr val="00A896"/>
+                </a:solidFill>
+                <a:latin typeface="Graphik TH" pitchFamily="34" charset="0"/>
+                <a:ea typeface="Graphik TH" pitchFamily="34" charset="-122"/>
+                <a:cs typeface="Graphik TH" pitchFamily="34" charset="-120"/>
+              </a:rPr>
+              <a:t>THB 5.48bn</a:t>
+            </a:r>
+            <a:endParaRPr lang="en-US" sz="2400" dirty="0"/>
+          </a:p>
+        </p:txBody>
+      </p:sp>
+      <p:sp>
+        <p:nvSpPr>
+          <p:cNvPr id="8" name="Text 6"/>
+          <p:cNvSpPr/>
+          <p:nvPr/>
+        </p:nvSpPr>
+        <p:spPr>
+          <a:xfrm>
+            <a:off x="749808" y="2121408"/>
+            <a:ext cx="2208276" cy="237744"/>
+          </a:xfrm>
+          <a:prstGeom prst="rect">
+            <a:avLst/>
+          </a:prstGeom>
+          <a:noFill/>
+          <a:ln/>
+        </p:spPr>
+        <p:txBody>
+          <a:bodyPr wrap="square" lIns="0" tIns="0" rIns="0" bIns="0" rtlCol="0" anchor="t"/>
+          <a:lstStyle/>
+          <a:p>
+            <a:pPr indent="0" marL="0">
+              <a:buNone/>
+            </a:pPr>
+            <a:r>
+              <a:rPr lang="en-US" sz="1150" b="1" dirty="0">
+                <a:solidFill>
+                  <a:srgbClr val="16233D"/>
+                </a:solidFill>
+                <a:latin typeface="Graphik TH" pitchFamily="34" charset="0"/>
+                <a:ea typeface="Graphik TH" pitchFamily="34" charset="-122"/>
+                <a:cs typeface="Graphik TH" pitchFamily="34" charset="-120"/>
+              </a:rPr>
+              <a:t>total deposit balance</a:t>
+            </a:r>
+            <a:endParaRPr lang="en-US" sz="1150" dirty="0"/>
+          </a:p>
+        </p:txBody>
+      </p:sp>
+      <p:sp>
+        <p:nvSpPr>
+          <p:cNvPr id="9" name="Text 7"/>
+          <p:cNvSpPr/>
+          <p:nvPr/>
+        </p:nvSpPr>
+        <p:spPr>
+          <a:xfrm>
+            <a:off x="749808" y="2350008"/>
+            <a:ext cx="2208276" cy="237744"/>
+          </a:xfrm>
+          <a:prstGeom prst="rect">
+            <a:avLst/>
+          </a:prstGeom>
+          <a:noFill/>
+          <a:ln/>
+        </p:spPr>
+        <p:txBody>
+          <a:bodyPr wrap="square" lIns="0" tIns="0" rIns="0" bIns="0" rtlCol="0" anchor="t"/>
+          <a:lstStyle/>
+          <a:p>
+            <a:pPr indent="0" marL="0">
+              <a:buNone/>
+            </a:pPr>
+            <a:r>
+              <a:rPr lang="en-US" sz="950" dirty="0">
+                <a:solidFill>
+                  <a:srgbClr val="6B7A90"/>
+                </a:solidFill>
+                <a:latin typeface="Graphik TH" pitchFamily="34" charset="0"/>
+                <a:ea typeface="Graphik TH" pitchFamily="34" charset="-122"/>
+                <a:cs typeface="Graphik TH" pitchFamily="34" charset="-120"/>
+              </a:rPr>
+              <a:t>320.1k funded customers</a:t>
+            </a:r>
+            <a:endParaRPr lang="en-US" sz="950" dirty="0"/>
+          </a:p>
+        </p:txBody>
+      </p:sp>
+      <p:sp>
+        <p:nvSpPr>
+          <p:cNvPr id="10" name="Shape 8"/>
+          <p:cNvSpPr/>
+          <p:nvPr/>
+        </p:nvSpPr>
+        <p:spPr>
+          <a:xfrm>
+            <a:off x="3406140" y="1645920"/>
+            <a:ext cx="2647188" cy="987552"/>
+          </a:xfrm>
+          <a:prstGeom prst="roundRect">
+            <a:avLst>
+              <a:gd name="adj" fmla="val 8333"/>
+            </a:avLst>
+          </a:prstGeom>
+          <a:solidFill>
+            <a:srgbClr val="F1F4F9"/>
+          </a:solidFill>
+          <a:ln/>
+        </p:spPr>
+      </p:sp>
+      <p:sp>
+        <p:nvSpPr>
+          <p:cNvPr id="11" name="Text 9"/>
+          <p:cNvSpPr/>
+          <p:nvPr/>
+        </p:nvSpPr>
+        <p:spPr>
+          <a:xfrm>
+            <a:off x="3625596" y="1719072"/>
+            <a:ext cx="2208276" cy="402336"/>
+          </a:xfrm>
+          <a:prstGeom prst="rect">
+            <a:avLst/>
+          </a:prstGeom>
+          <a:noFill/>
+          <a:ln/>
+        </p:spPr>
+        <p:txBody>
+          <a:bodyPr wrap="square" lIns="0" tIns="0" rIns="0" bIns="0" rtlCol="0" anchor="ctr"/>
+          <a:lstStyle/>
+          <a:p>
+            <a:pPr indent="0" marL="0">
+              <a:buNone/>
+            </a:pPr>
+            <a:r>
+              <a:rPr lang="en-US" sz="2400" b="1" dirty="0">
+                <a:solidFill>
+                  <a:srgbClr val="C00000"/>
+                </a:solidFill>
+                <a:latin typeface="Graphik TH" pitchFamily="34" charset="0"/>
+                <a:ea typeface="Graphik TH" pitchFamily="34" charset="-122"/>
+                <a:cs typeface="Graphik TH" pitchFamily="34" charset="-120"/>
+              </a:rPr>
+              <a:t>THB 3.83bn</a:t>
+            </a:r>
+            <a:endParaRPr lang="en-US" sz="2400" dirty="0"/>
+          </a:p>
+        </p:txBody>
+      </p:sp>
+      <p:sp>
+        <p:nvSpPr>
+          <p:cNvPr id="12" name="Text 10"/>
+          <p:cNvSpPr/>
+          <p:nvPr/>
+        </p:nvSpPr>
+        <p:spPr>
+          <a:xfrm>
+            <a:off x="3625596" y="2121408"/>
+            <a:ext cx="2208276" cy="237744"/>
+          </a:xfrm>
+          <a:prstGeom prst="rect">
+            <a:avLst/>
+          </a:prstGeom>
+          <a:noFill/>
+          <a:ln/>
+        </p:spPr>
+        <p:txBody>
+          <a:bodyPr wrap="square" lIns="0" tIns="0" rIns="0" bIns="0" rtlCol="0" anchor="t"/>
+          <a:lstStyle/>
+          <a:p>
+            <a:pPr indent="0" marL="0">
+              <a:buNone/>
+            </a:pPr>
+            <a:r>
+              <a:rPr lang="en-US" sz="1150" b="1" dirty="0">
+                <a:solidFill>
+                  <a:srgbClr val="16233D"/>
+                </a:solidFill>
+                <a:latin typeface="Graphik TH" pitchFamily="34" charset="0"/>
+                <a:ea typeface="Graphik TH" pitchFamily="34" charset="-122"/>
+                <a:cs typeface="Graphik TH" pitchFamily="34" charset="-120"/>
+              </a:rPr>
+              <a:t>rate-sensitive balance</a:t>
+            </a:r>
+            <a:endParaRPr lang="en-US" sz="1150" dirty="0"/>
+          </a:p>
+        </p:txBody>
+      </p:sp>
+      <p:sp>
+        <p:nvSpPr>
+          <p:cNvPr id="13" name="Text 11"/>
+          <p:cNvSpPr/>
+          <p:nvPr/>
+        </p:nvSpPr>
+        <p:spPr>
+          <a:xfrm>
+            <a:off x="3625596" y="2350008"/>
+            <a:ext cx="2208276" cy="237744"/>
+          </a:xfrm>
+          <a:prstGeom prst="rect">
+            <a:avLst/>
+          </a:prstGeom>
+          <a:noFill/>
+          <a:ln/>
+        </p:spPr>
+        <p:txBody>
+          <a:bodyPr wrap="square" lIns="0" tIns="0" rIns="0" bIns="0" rtlCol="0" anchor="t"/>
+          <a:lstStyle/>
+          <a:p>
+            <a:pPr indent="0" marL="0">
+              <a:buNone/>
+            </a:pPr>
+            <a:r>
+              <a:rPr lang="en-US" sz="950" dirty="0">
+                <a:solidFill>
+                  <a:srgbClr val="6B7A90"/>
+                </a:solidFill>
+                <a:latin typeface="Graphik TH" pitchFamily="34" charset="0"/>
+                <a:ea typeface="Graphik TH" pitchFamily="34" charset="-122"/>
+                <a:cs typeface="Graphik TH" pitchFamily="34" charset="-120"/>
+              </a:rPr>
+              <a:t>70% of the book · RS ≥ 60</a:t>
+            </a:r>
+            <a:endParaRPr lang="en-US" sz="950" dirty="0"/>
+          </a:p>
+        </p:txBody>
+      </p:sp>
+      <p:sp>
+        <p:nvSpPr>
+          <p:cNvPr id="14" name="Shape 12"/>
+          <p:cNvSpPr/>
+          <p:nvPr/>
+        </p:nvSpPr>
+        <p:spPr>
+          <a:xfrm>
+            <a:off x="6281928" y="1645920"/>
+            <a:ext cx="2647188" cy="987552"/>
+          </a:xfrm>
+          <a:prstGeom prst="roundRect">
+            <a:avLst>
+              <a:gd name="adj" fmla="val 8333"/>
+            </a:avLst>
+          </a:prstGeom>
+          <a:solidFill>
+            <a:srgbClr val="F1F4F9"/>
+          </a:solidFill>
+          <a:ln/>
+        </p:spPr>
+      </p:sp>
+      <p:sp>
+        <p:nvSpPr>
+          <p:cNvPr id="15" name="Text 13"/>
+          <p:cNvSpPr/>
+          <p:nvPr/>
+        </p:nvSpPr>
+        <p:spPr>
+          <a:xfrm>
+            <a:off x="6501384" y="1719072"/>
+            <a:ext cx="2208276" cy="402336"/>
+          </a:xfrm>
+          <a:prstGeom prst="rect">
+            <a:avLst/>
+          </a:prstGeom>
+          <a:noFill/>
+          <a:ln/>
+        </p:spPr>
+        <p:txBody>
+          <a:bodyPr wrap="square" lIns="0" tIns="0" rIns="0" bIns="0" rtlCol="0" anchor="ctr"/>
+          <a:lstStyle/>
+          <a:p>
+            <a:pPr indent="0" marL="0">
+              <a:buNone/>
+            </a:pPr>
+            <a:r>
+              <a:rPr lang="en-US" sz="2400" b="1" dirty="0">
+                <a:solidFill>
+                  <a:srgbClr val="00A896"/>
+                </a:solidFill>
+                <a:latin typeface="Graphik TH" pitchFamily="34" charset="0"/>
+                <a:ea typeface="Graphik TH" pitchFamily="34" charset="-122"/>
+                <a:cs typeface="Graphik TH" pitchFamily="34" charset="-120"/>
+              </a:rPr>
+              <a:t>96%</a:t>
+            </a:r>
+            <a:endParaRPr lang="en-US" sz="2400" dirty="0"/>
+          </a:p>
+        </p:txBody>
+      </p:sp>
+      <p:sp>
+        <p:nvSpPr>
+          <p:cNvPr id="16" name="Text 14"/>
+          <p:cNvSpPr/>
+          <p:nvPr/>
+        </p:nvSpPr>
+        <p:spPr>
+          <a:xfrm>
+            <a:off x="6501384" y="2121408"/>
+            <a:ext cx="2208276" cy="237744"/>
+          </a:xfrm>
+          <a:prstGeom prst="rect">
+            <a:avLst/>
+          </a:prstGeom>
+          <a:noFill/>
+          <a:ln/>
+        </p:spPr>
+        <p:txBody>
+          <a:bodyPr wrap="square" lIns="0" tIns="0" rIns="0" bIns="0" rtlCol="0" anchor="t"/>
+          <a:lstStyle/>
+          <a:p>
+            <a:pPr indent="0" marL="0">
+              <a:buNone/>
+            </a:pPr>
+            <a:r>
+              <a:rPr lang="en-US" sz="1150" b="1" dirty="0">
+                <a:solidFill>
+                  <a:srgbClr val="16233D"/>
+                </a:solidFill>
+                <a:latin typeface="Graphik TH" pitchFamily="34" charset="0"/>
+                <a:ea typeface="Graphik TH" pitchFamily="34" charset="-122"/>
+                <a:cs typeface="Graphik TH" pitchFamily="34" charset="-120"/>
+              </a:rPr>
+              <a:t>of balance in sticky tiers</a:t>
+            </a:r>
+            <a:endParaRPr lang="en-US" sz="1150" dirty="0"/>
+          </a:p>
+        </p:txBody>
+      </p:sp>
+      <p:sp>
+        <p:nvSpPr>
+          <p:cNvPr id="17" name="Text 15"/>
+          <p:cNvSpPr/>
+          <p:nvPr/>
+        </p:nvSpPr>
+        <p:spPr>
+          <a:xfrm>
+            <a:off x="6501384" y="2350008"/>
+            <a:ext cx="2208276" cy="237744"/>
+          </a:xfrm>
+          <a:prstGeom prst="rect">
+            <a:avLst/>
+          </a:prstGeom>
+          <a:noFill/>
+          <a:ln/>
+        </p:spPr>
+        <p:txBody>
+          <a:bodyPr wrap="square" lIns="0" tIns="0" rIns="0" bIns="0" rtlCol="0" anchor="t"/>
+          <a:lstStyle/>
+          <a:p>
+            <a:pPr indent="0" marL="0">
+              <a:buNone/>
+            </a:pPr>
+            <a:r>
+              <a:rPr lang="en-US" sz="950" dirty="0">
+                <a:solidFill>
+                  <a:srgbClr val="6B7A90"/>
+                </a:solidFill>
+                <a:latin typeface="Graphik TH" pitchFamily="34" charset="0"/>
+                <a:ea typeface="Graphik TH" pitchFamily="34" charset="-122"/>
+                <a:cs typeface="Graphik TH" pitchFamily="34" charset="-120"/>
+              </a:rPr>
+              <a:t>High + Very High stickiness</a:t>
+            </a:r>
+            <a:endParaRPr lang="en-US" sz="950" dirty="0"/>
+          </a:p>
+        </p:txBody>
+      </p:sp>
+      <p:sp>
+        <p:nvSpPr>
+          <p:cNvPr id="18" name="Shape 16"/>
+          <p:cNvSpPr/>
+          <p:nvPr/>
+        </p:nvSpPr>
+        <p:spPr>
+          <a:xfrm>
+            <a:off x="9157716" y="1645920"/>
+            <a:ext cx="2647188" cy="987552"/>
+          </a:xfrm>
+          <a:prstGeom prst="roundRect">
+            <a:avLst>
+              <a:gd name="adj" fmla="val 8333"/>
+            </a:avLst>
+          </a:prstGeom>
+          <a:solidFill>
+            <a:srgbClr val="F1F4F9"/>
+          </a:solidFill>
+          <a:ln/>
+        </p:spPr>
+      </p:sp>
+      <p:sp>
+        <p:nvSpPr>
+          <p:cNvPr id="19" name="Text 17"/>
+          <p:cNvSpPr/>
+          <p:nvPr/>
+        </p:nvSpPr>
+        <p:spPr>
+          <a:xfrm>
+            <a:off x="9377172" y="1719072"/>
+            <a:ext cx="2208276" cy="402336"/>
+          </a:xfrm>
+          <a:prstGeom prst="rect">
+            <a:avLst/>
+          </a:prstGeom>
+          <a:noFill/>
+          <a:ln/>
+        </p:spPr>
+        <p:txBody>
+          <a:bodyPr wrap="square" lIns="0" tIns="0" rIns="0" bIns="0" rtlCol="0" anchor="ctr"/>
+          <a:lstStyle/>
+          <a:p>
+            <a:pPr indent="0" marL="0">
+              <a:buNone/>
+            </a:pPr>
+            <a:r>
+              <a:rPr lang="en-US" sz="2400" b="1" dirty="0">
+                <a:solidFill>
+                  <a:srgbClr val="C00000"/>
+                </a:solidFill>
+                <a:latin typeface="Graphik TH" pitchFamily="34" charset="0"/>
+                <a:ea typeface="Graphik TH" pitchFamily="34" charset="-122"/>
+                <a:cs typeface="Graphik TH" pitchFamily="34" charset="-120"/>
+              </a:rPr>
+              <a:t>THB 99m</a:t>
+            </a:r>
+            <a:endParaRPr lang="en-US" sz="2400" dirty="0"/>
+          </a:p>
+        </p:txBody>
+      </p:sp>
+      <p:sp>
+        <p:nvSpPr>
+          <p:cNvPr id="20" name="Text 18"/>
+          <p:cNvSpPr/>
+          <p:nvPr/>
+        </p:nvSpPr>
+        <p:spPr>
+          <a:xfrm>
+            <a:off x="9377172" y="2121408"/>
+            <a:ext cx="2208276" cy="237744"/>
+          </a:xfrm>
+          <a:prstGeom prst="rect">
+            <a:avLst/>
+          </a:prstGeom>
+          <a:noFill/>
+          <a:ln/>
+        </p:spPr>
+        <p:txBody>
+          <a:bodyPr wrap="square" lIns="0" tIns="0" rIns="0" bIns="0" rtlCol="0" anchor="t"/>
+          <a:lstStyle/>
+          <a:p>
+            <a:pPr indent="0" marL="0">
+              <a:buNone/>
+            </a:pPr>
+            <a:r>
+              <a:rPr lang="en-US" sz="1150" b="1" dirty="0">
+                <a:solidFill>
+                  <a:srgbClr val="16233D"/>
+                </a:solidFill>
+                <a:latin typeface="Graphik TH" pitchFamily="34" charset="0"/>
+                <a:ea typeface="Graphik TH" pitchFamily="34" charset="-122"/>
+                <a:cs typeface="Graphik TH" pitchFamily="34" charset="-120"/>
+              </a:rPr>
+              <a:t>fragile subset</a:t>
+            </a:r>
+            <a:endParaRPr lang="en-US" sz="1150" dirty="0"/>
+          </a:p>
+        </p:txBody>
+      </p:sp>
+      <p:sp>
+        <p:nvSpPr>
+          <p:cNvPr id="21" name="Text 19"/>
+          <p:cNvSpPr/>
+          <p:nvPr/>
+        </p:nvSpPr>
+        <p:spPr>
+          <a:xfrm>
+            <a:off x="9377172" y="2350008"/>
+            <a:ext cx="2208276" cy="237744"/>
+          </a:xfrm>
+          <a:prstGeom prst="rect">
+            <a:avLst/>
+          </a:prstGeom>
+          <a:noFill/>
+          <a:ln/>
+        </p:spPr>
+        <p:txBody>
+          <a:bodyPr wrap="square" lIns="0" tIns="0" rIns="0" bIns="0" rtlCol="0" anchor="t"/>
+          <a:lstStyle/>
+          <a:p>
+            <a:pPr indent="0" marL="0">
+              <a:buNone/>
+            </a:pPr>
+            <a:r>
+              <a:rPr lang="en-US" sz="950" dirty="0">
+                <a:solidFill>
+                  <a:srgbClr val="6B7A90"/>
+                </a:solidFill>
+                <a:latin typeface="Graphik TH" pitchFamily="34" charset="0"/>
+                <a:ea typeface="Graphik TH" pitchFamily="34" charset="-122"/>
+                <a:cs typeface="Graphik TH" pitchFamily="34" charset="-120"/>
+              </a:rPr>
+              <a:t>stickiness &lt; 60 and RS ≥ 60</a:t>
+            </a:r>
+            <a:endParaRPr lang="en-US" sz="950" dirty="0"/>
+          </a:p>
+        </p:txBody>
+      </p:sp>
+      <p:sp>
+        <p:nvSpPr>
+          <p:cNvPr id="22" name="Shape 20"/>
+          <p:cNvSpPr/>
+          <p:nvPr/>
+        </p:nvSpPr>
+        <p:spPr>
+          <a:xfrm>
+            <a:off x="530352" y="2798064"/>
+            <a:ext cx="6720840" cy="2322576"/>
+          </a:xfrm>
+          <a:prstGeom prst="roundRect">
+            <a:avLst>
+              <a:gd name="adj" fmla="val 3543"/>
+            </a:avLst>
+          </a:prstGeom>
+          <a:solidFill>
+            <a:srgbClr val="F1F4F9"/>
+          </a:solidFill>
+          <a:ln/>
+        </p:spPr>
+      </p:sp>
+      <p:sp>
+        <p:nvSpPr>
+          <p:cNvPr id="23" name="Text 21"/>
+          <p:cNvSpPr/>
+          <p:nvPr/>
+        </p:nvSpPr>
+        <p:spPr>
+          <a:xfrm>
+            <a:off x="786384" y="2944368"/>
+            <a:ext cx="6208776" cy="274320"/>
+          </a:xfrm>
+          <a:prstGeom prst="rect">
+            <a:avLst/>
+          </a:prstGeom>
+          <a:noFill/>
+          <a:ln/>
+        </p:spPr>
+        <p:txBody>
+          <a:bodyPr wrap="square" lIns="0" tIns="0" rIns="0" bIns="0" rtlCol="0" anchor="ctr"/>
+          <a:lstStyle/>
+          <a:p>
+            <a:pPr indent="0" marL="0">
+              <a:buNone/>
+            </a:pPr>
+            <a:r>
+              <a:rPr lang="en-US" sz="1400" b="1" dirty="0">
+                <a:solidFill>
+                  <a:srgbClr val="16233D"/>
+                </a:solidFill>
+                <a:latin typeface="Cambria" pitchFamily="34" charset="0"/>
+                <a:ea typeface="Cambria" pitchFamily="34" charset="-122"/>
+                <a:cs typeface="Cambria" pitchFamily="34" charset="-120"/>
+              </a:rPr>
+              <a:t>Balance (THB m)</a:t>
+            </a:r>
+            <a:endParaRPr lang="en-US" sz="1400" dirty="0"/>
+          </a:p>
+        </p:txBody>
+      </p:sp>
+      <p:sp>
+        <p:nvSpPr>
+          <p:cNvPr id="24" name="Text 22"/>
+          <p:cNvSpPr/>
+          <p:nvPr/>
+        </p:nvSpPr>
+        <p:spPr>
+          <a:xfrm>
+            <a:off x="786384" y="3218688"/>
+            <a:ext cx="6208776" cy="237744"/>
+          </a:xfrm>
+          <a:prstGeom prst="rect">
+            <a:avLst/>
+          </a:prstGeom>
+          <a:noFill/>
+          <a:ln/>
+        </p:spPr>
+        <p:txBody>
+          <a:bodyPr wrap="square" lIns="0" tIns="0" rIns="0" bIns="0" rtlCol="0" anchor="ctr"/>
+          <a:lstStyle/>
+          <a:p>
+            <a:pPr indent="0" marL="0">
+              <a:buNone/>
+            </a:pPr>
+            <a:r>
+              <a:rPr lang="en-US" sz="950" dirty="0">
+                <a:solidFill>
+                  <a:srgbClr val="6B7A90"/>
+                </a:solidFill>
+                <a:latin typeface="Graphik TH" pitchFamily="34" charset="0"/>
+                <a:ea typeface="Graphik TH" pitchFamily="34" charset="-122"/>
+                <a:cs typeface="Graphik TH" pitchFamily="34" charset="-120"/>
+              </a:rPr>
+              <a:t>Rows: stickiness · columns: rate sensitivity</a:t>
+            </a:r>
+            <a:endParaRPr lang="en-US" sz="950" dirty="0"/>
+          </a:p>
+        </p:txBody>
+      </p:sp>
+      <p:graphicFrame>
+        <p:nvGraphicFramePr>
+          <p:cNvPr id="8" name="Table 0"/>
+          <p:cNvGraphicFramePr>
+            <a:graphicFrameLocks noGrp="1"/>
+          </p:cNvGraphicFramePr>
+          <p:nvPr>
+            <p:extLst>
+              <p:ext uri="{D42A27DB-BD31-4B8C-83A1-F6EECF244321}">
+                <p14:modId xmlns:p14="http://schemas.microsoft.com/office/powerpoint/2010/main" val="1579011935"/>
+              </p:ext>
+            </p:extLst>
+          </p:nvPr>
+        </p:nvGraphicFramePr>
+        <p:xfrm>
+          <a:off x="749808" y="3401568"/>
+          <a:ext cx="6281928" cy="914400"/>
+        </p:xfrm>
+        <a:graphic>
+          <a:graphicData uri="http://schemas.openxmlformats.org/drawingml/2006/table">
+            <a:tbl>
+              <a:tblPr/>
+              <a:tblGrid>
+                <a:gridCol w="1382024"/>
+                <a:gridCol w="979981"/>
+                <a:gridCol w="979981"/>
+                <a:gridCol w="979981"/>
+                <a:gridCol w="979981"/>
+                <a:gridCol w="979981"/>
+              </a:tblGrid>
+              <a:tr h="274320">
+                <a:tc>
+                  <a:txBody>
+                    <a:bodyPr/>
+                    <a:lstStyle/>
+                    <a:p>
+                      <a:pPr algn="l" indent="0" marL="0">
+                        <a:buNone/>
+                      </a:pPr>
+                      <a:r>
+                        <a:rPr lang="en-US" sz="900" b="1" dirty="0">
+                          <a:solidFill>
+                            <a:srgbClr val="FFFFFF"/>
+                          </a:solidFill>
+                          <a:latin typeface="Graphik TH" pitchFamily="34" charset="0"/>
+                          <a:ea typeface="Graphik TH" pitchFamily="34" charset="-122"/>
+                          <a:cs typeface="Graphik TH" pitchFamily="34" charset="-120"/>
+                        </a:rPr>
+                        <a:t>Stickiness</a:t>
+                      </a:r>
+                      <a:endParaRPr lang="en-US" sz="900" dirty="0">
+                        <a:latin typeface="Graphik TH" charset="0"/>
+                        <a:ea typeface="Graphik TH" charset="0"/>
+                        <a:cs typeface="Graphik TH" charset="0"/>
+                      </a:endParaRPr>
+                    </a:p>
+                  </a:txBody>
+                  <a:tcPr marL="73152" marR="73152" marT="18288" marB="18288" anchor="ctr">
+                    <a:lnL w="6350" cap="flat" cmpd="sng" algn="ctr">
+                      <a:solidFill>
+                        <a:srgbClr val="D8DFE9"/>
+                      </a:solidFill>
+                      <a:prstDash val="solid"/>
+                      <a:round/>
+                      <a:headEnd type="none" w="med" len="med"/>
+                      <a:tailEnd type="none" w="med" len="med"/>
+                    </a:lnL>
+                    <a:lnR w="6350" cap="flat" cmpd="sng" algn="ctr">
+                      <a:solidFill>
+                        <a:srgbClr val="D8DFE9"/>
+                      </a:solidFill>
+                      <a:prstDash val="solid"/>
+                      <a:round/>
+                      <a:headEnd type="none" w="med" len="med"/>
+                      <a:tailEnd type="none" w="med" len="med"/>
+                    </a:lnR>
+                    <a:lnT w="6350" cap="flat" cmpd="sng" algn="ctr">
+                      <a:solidFill>
+                        <a:srgbClr val="D8DFE9"/>
+                      </a:solidFill>
+                      <a:prstDash val="solid"/>
+                      <a:round/>
+                      <a:headEnd type="none" w="med" len="med"/>
+                      <a:tailEnd type="none" w="med" len="med"/>
+                    </a:lnT>
+                    <a:lnB w="6350" cap="flat" cmpd="sng" algn="ctr">
+                      <a:solidFill>
+                        <a:srgbClr val="D8DFE9"/>
+                      </a:solidFill>
+                      <a:prstDash val="solid"/>
+                      <a:round/>
+                      <a:headEnd type="none" w="med" len="med"/>
+                      <a:tailEnd type="none" w="med" len="med"/>
+                    </a:lnB>
+                    <a:solidFill>
+                      <a:srgbClr val="045D66"/>
+                    </a:solidFill>
+                  </a:tcPr>
+                </a:tc>
+                <a:tc>
+                  <a:txBody>
+                    <a:bodyPr/>
+                    <a:lstStyle/>
+                    <a:p>
+                      <a:pPr algn="ctr" indent="0" marL="0">
+                        <a:buNone/>
+                      </a:pPr>
+                      <a:r>
+                        <a:rPr lang="en-US" sz="900" b="1" dirty="0">
+                          <a:solidFill>
+                            <a:srgbClr val="FFFFFF"/>
+                          </a:solidFill>
+                          <a:latin typeface="Graphik TH" pitchFamily="34" charset="0"/>
+                          <a:ea typeface="Graphik TH" pitchFamily="34" charset="-122"/>
+                          <a:cs typeface="Graphik TH" pitchFamily="34" charset="-120"/>
+                        </a:rPr>
+                        <a:t>Very Low</a:t>
+                      </a:r>
+                      <a:endParaRPr lang="en-US" sz="900" dirty="0">
+                        <a:latin typeface="Graphik TH" charset="0"/>
+                        <a:ea typeface="Graphik TH" charset="0"/>
+                        <a:cs typeface="Graphik TH" charset="0"/>
+                      </a:endParaRPr>
+                    </a:p>
+                  </a:txBody>
+                  <a:tcPr marL="73152" marR="73152" marT="18288" marB="18288" anchor="ctr">
+                    <a:lnL w="6350" cap="flat" cmpd="sng" algn="ctr">
+                      <a:solidFill>
+                        <a:srgbClr val="D8DFE9"/>
+                      </a:solidFill>
+                      <a:prstDash val="solid"/>
+                      <a:round/>
+                      <a:headEnd type="none" w="med" len="med"/>
+                      <a:tailEnd type="none" w="med" len="med"/>
+                    </a:lnL>
+                    <a:lnR w="6350" cap="flat" cmpd="sng" algn="ctr">
+                      <a:solidFill>
+                        <a:srgbClr val="D8DFE9"/>
+                      </a:solidFill>
+                      <a:prstDash val="solid"/>
+                      <a:round/>
+                      <a:headEnd type="none" w="med" len="med"/>
+                      <a:tailEnd type="none" w="med" len="med"/>
+                    </a:lnR>
+                    <a:lnT w="6350" cap="flat" cmpd="sng" algn="ctr">
+                      <a:solidFill>
+                        <a:srgbClr val="D8DFE9"/>
+                      </a:solidFill>
+                      <a:prstDash val="solid"/>
+                      <a:round/>
+                      <a:headEnd type="none" w="med" len="med"/>
+                      <a:tailEnd type="none" w="med" len="med"/>
+                    </a:lnT>
+                    <a:lnB w="6350" cap="flat" cmpd="sng" algn="ctr">
+                      <a:solidFill>
+                        <a:srgbClr val="D8DFE9"/>
+                      </a:solidFill>
+                      <a:prstDash val="solid"/>
+                      <a:round/>
+                      <a:headEnd type="none" w="med" len="med"/>
+                      <a:tailEnd type="none" w="med" len="med"/>
+                    </a:lnB>
+                    <a:solidFill>
+                      <a:srgbClr val="045D66"/>
+                    </a:solidFill>
+                  </a:tcPr>
+                </a:tc>
+                <a:tc>
+                  <a:txBody>
+                    <a:bodyPr/>
+                    <a:lstStyle/>
+                    <a:p>
+                      <a:pPr algn="ctr" indent="0" marL="0">
+                        <a:buNone/>
+                      </a:pPr>
+                      <a:r>
+                        <a:rPr lang="en-US" sz="900" b="1" dirty="0">
+                          <a:solidFill>
+                            <a:srgbClr val="FFFFFF"/>
+                          </a:solidFill>
+                          <a:latin typeface="Graphik TH" pitchFamily="34" charset="0"/>
+                          <a:ea typeface="Graphik TH" pitchFamily="34" charset="-122"/>
+                          <a:cs typeface="Graphik TH" pitchFamily="34" charset="-120"/>
+                        </a:rPr>
+                        <a:t>Low</a:t>
+                      </a:r>
+                      <a:endParaRPr lang="en-US" sz="900" dirty="0">
+                        <a:latin typeface="Graphik TH" charset="0"/>
+                        <a:ea typeface="Graphik TH" charset="0"/>
+                        <a:cs typeface="Graphik TH" charset="0"/>
+                      </a:endParaRPr>
+                    </a:p>
+                  </a:txBody>
+                  <a:tcPr marL="73152" marR="73152" marT="18288" marB="18288" anchor="ctr">
+                    <a:lnL w="6350" cap="flat" cmpd="sng" algn="ctr">
+                      <a:solidFill>
+                        <a:srgbClr val="D8DFE9"/>
+                      </a:solidFill>
+                      <a:prstDash val="solid"/>
+                      <a:round/>
+                      <a:headEnd type="none" w="med" len="med"/>
+                      <a:tailEnd type="none" w="med" len="med"/>
+                    </a:lnL>
+                    <a:lnR w="6350" cap="flat" cmpd="sng" algn="ctr">
+                      <a:solidFill>
+                        <a:srgbClr val="D8DFE9"/>
+                      </a:solidFill>
+                      <a:prstDash val="solid"/>
+                      <a:round/>
+                      <a:headEnd type="none" w="med" len="med"/>
+                      <a:tailEnd type="none" w="med" len="med"/>
+                    </a:lnR>
+                    <a:lnT w="6350" cap="flat" cmpd="sng" algn="ctr">
+                      <a:solidFill>
+                        <a:srgbClr val="D8DFE9"/>
+                      </a:solidFill>
+                      <a:prstDash val="solid"/>
+                      <a:round/>
+                      <a:headEnd type="none" w="med" len="med"/>
+                      <a:tailEnd type="none" w="med" len="med"/>
+                    </a:lnT>
+                    <a:lnB w="6350" cap="flat" cmpd="sng" algn="ctr">
+                      <a:solidFill>
+                        <a:srgbClr val="D8DFE9"/>
+                      </a:solidFill>
+                      <a:prstDash val="solid"/>
+                      <a:round/>
+                      <a:headEnd type="none" w="med" len="med"/>
+                      <a:tailEnd type="none" w="med" len="med"/>
+                    </a:lnB>
+                    <a:solidFill>
+                      <a:srgbClr val="045D66"/>
+                    </a:solidFill>
+                  </a:tcPr>
+                </a:tc>
+                <a:tc>
+                  <a:txBody>
+                    <a:bodyPr/>
+                    <a:lstStyle/>
+                    <a:p>
+                      <a:pPr algn="ctr" indent="0" marL="0">
+                        <a:buNone/>
+                      </a:pPr>
+                      <a:r>
+                        <a:rPr lang="en-US" sz="900" b="1" dirty="0">
+                          <a:solidFill>
+                            <a:srgbClr val="FFFFFF"/>
+                          </a:solidFill>
+                          <a:latin typeface="Graphik TH" pitchFamily="34" charset="0"/>
+                          <a:ea typeface="Graphik TH" pitchFamily="34" charset="-122"/>
+                          <a:cs typeface="Graphik TH" pitchFamily="34" charset="-120"/>
+                        </a:rPr>
+                        <a:t>Medium</a:t>
+                      </a:r>
+                      <a:endParaRPr lang="en-US" sz="900" dirty="0">
+                        <a:latin typeface="Graphik TH" charset="0"/>
+                        <a:ea typeface="Graphik TH" charset="0"/>
+                        <a:cs typeface="Graphik TH" charset="0"/>
+                      </a:endParaRPr>
+                    </a:p>
+                  </a:txBody>
+                  <a:tcPr marL="73152" marR="73152" marT="18288" marB="18288" anchor="ctr">
+                    <a:lnL w="6350" cap="flat" cmpd="sng" algn="ctr">
+                      <a:solidFill>
+                        <a:srgbClr val="D8DFE9"/>
+                      </a:solidFill>
+                      <a:prstDash val="solid"/>
+                      <a:round/>
+                      <a:headEnd type="none" w="med" len="med"/>
+                      <a:tailEnd type="none" w="med" len="med"/>
+                    </a:lnL>
+                    <a:lnR w="6350" cap="flat" cmpd="sng" algn="ctr">
+                      <a:solidFill>
+                        <a:srgbClr val="D8DFE9"/>
+                      </a:solidFill>
+                      <a:prstDash val="solid"/>
+                      <a:round/>
+                      <a:headEnd type="none" w="med" len="med"/>
+                      <a:tailEnd type="none" w="med" len="med"/>
+                    </a:lnR>
+                    <a:lnT w="6350" cap="flat" cmpd="sng" algn="ctr">
+                      <a:solidFill>
+                        <a:srgbClr val="D8DFE9"/>
+                      </a:solidFill>
+                      <a:prstDash val="solid"/>
+                      <a:round/>
+                      <a:headEnd type="none" w="med" len="med"/>
+                      <a:tailEnd type="none" w="med" len="med"/>
+                    </a:lnT>
+                    <a:lnB w="6350" cap="flat" cmpd="sng" algn="ctr">
+                      <a:solidFill>
+                        <a:srgbClr val="D8DFE9"/>
+                      </a:solidFill>
+                      <a:prstDash val="solid"/>
+                      <a:round/>
+                      <a:headEnd type="none" w="med" len="med"/>
+                      <a:tailEnd type="none" w="med" len="med"/>
+                    </a:lnB>
+                    <a:solidFill>
+                      <a:srgbClr val="045D66"/>
+                    </a:solidFill>
+                  </a:tcPr>
+                </a:tc>
+                <a:tc>
+                  <a:txBody>
+                    <a:bodyPr/>
+                    <a:lstStyle/>
+                    <a:p>
+                      <a:pPr algn="ctr" indent="0" marL="0">
+                        <a:buNone/>
+                      </a:pPr>
+                      <a:r>
+                        <a:rPr lang="en-US" sz="900" b="1" dirty="0">
+                          <a:solidFill>
+                            <a:srgbClr val="FFFFFF"/>
+                          </a:solidFill>
+                          <a:latin typeface="Graphik TH" pitchFamily="34" charset="0"/>
+                          <a:ea typeface="Graphik TH" pitchFamily="34" charset="-122"/>
+                          <a:cs typeface="Graphik TH" pitchFamily="34" charset="-120"/>
+                        </a:rPr>
+                        <a:t>High</a:t>
+                      </a:r>
+                      <a:endParaRPr lang="en-US" sz="900" dirty="0">
+                        <a:latin typeface="Graphik TH" charset="0"/>
+                        <a:ea typeface="Graphik TH" charset="0"/>
+                        <a:cs typeface="Graphik TH" charset="0"/>
+                      </a:endParaRPr>
+                    </a:p>
+                  </a:txBody>
+                  <a:tcPr marL="73152" marR="73152" marT="18288" marB="18288" anchor="ctr">
+                    <a:lnL w="6350" cap="flat" cmpd="sng" algn="ctr">
+                      <a:solidFill>
+                        <a:srgbClr val="D8DFE9"/>
+                      </a:solidFill>
+                      <a:prstDash val="solid"/>
+                      <a:round/>
+                      <a:headEnd type="none" w="med" len="med"/>
+                      <a:tailEnd type="none" w="med" len="med"/>
+                    </a:lnL>
+                    <a:lnR w="6350" cap="flat" cmpd="sng" algn="ctr">
+                      <a:solidFill>
+                        <a:srgbClr val="D8DFE9"/>
+                      </a:solidFill>
+                      <a:prstDash val="solid"/>
+                      <a:round/>
+                      <a:headEnd type="none" w="med" len="med"/>
+                      <a:tailEnd type="none" w="med" len="med"/>
+                    </a:lnR>
+                    <a:lnT w="6350" cap="flat" cmpd="sng" algn="ctr">
+                      <a:solidFill>
+                        <a:srgbClr val="D8DFE9"/>
+                      </a:solidFill>
+                      <a:prstDash val="solid"/>
+                      <a:round/>
+                      <a:headEnd type="none" w="med" len="med"/>
+                      <a:tailEnd type="none" w="med" len="med"/>
+                    </a:lnT>
+                    <a:lnB w="6350" cap="flat" cmpd="sng" algn="ctr">
+                      <a:solidFill>
+                        <a:srgbClr val="D8DFE9"/>
+                      </a:solidFill>
+                      <a:prstDash val="solid"/>
+                      <a:round/>
+                      <a:headEnd type="none" w="med" len="med"/>
+                      <a:tailEnd type="none" w="med" len="med"/>
+                    </a:lnB>
+                    <a:solidFill>
+                      <a:srgbClr val="045D66"/>
+                    </a:solidFill>
+                  </a:tcPr>
+                </a:tc>
+                <a:tc>
+                  <a:txBody>
+                    <a:bodyPr/>
+                    <a:lstStyle/>
+                    <a:p>
+                      <a:pPr algn="ctr" indent="0" marL="0">
+                        <a:buNone/>
+                      </a:pPr>
+                      <a:r>
+                        <a:rPr lang="en-US" sz="900" b="1" dirty="0">
+                          <a:solidFill>
+                            <a:srgbClr val="FFFFFF"/>
+                          </a:solidFill>
+                          <a:latin typeface="Graphik TH" pitchFamily="34" charset="0"/>
+                          <a:ea typeface="Graphik TH" pitchFamily="34" charset="-122"/>
+                          <a:cs typeface="Graphik TH" pitchFamily="34" charset="-120"/>
+                        </a:rPr>
+                        <a:t>Very High</a:t>
+                      </a:r>
+                      <a:endParaRPr lang="en-US" sz="900" dirty="0">
+                        <a:latin typeface="Graphik TH" charset="0"/>
+                        <a:ea typeface="Graphik TH" charset="0"/>
+                        <a:cs typeface="Graphik TH" charset="0"/>
+                      </a:endParaRPr>
+                    </a:p>
+                  </a:txBody>
+                  <a:tcPr marL="73152" marR="73152" marT="18288" marB="18288" anchor="ctr">
+                    <a:lnL w="6350" cap="flat" cmpd="sng" algn="ctr">
+                      <a:solidFill>
+                        <a:srgbClr val="D8DFE9"/>
+                      </a:solidFill>
+                      <a:prstDash val="solid"/>
+                      <a:round/>
+                      <a:headEnd type="none" w="med" len="med"/>
+                      <a:tailEnd type="none" w="med" len="med"/>
+                    </a:lnL>
+                    <a:lnR w="6350" cap="flat" cmpd="sng" algn="ctr">
+                      <a:solidFill>
+                        <a:srgbClr val="D8DFE9"/>
+                      </a:solidFill>
+                      <a:prstDash val="solid"/>
+                      <a:round/>
+                      <a:headEnd type="none" w="med" len="med"/>
+                      <a:tailEnd type="none" w="med" len="med"/>
+                    </a:lnR>
+                    <a:lnT w="6350" cap="flat" cmpd="sng" algn="ctr">
+                      <a:solidFill>
+                        <a:srgbClr val="D8DFE9"/>
+                      </a:solidFill>
+                      <a:prstDash val="solid"/>
+                      <a:round/>
+                      <a:headEnd type="none" w="med" len="med"/>
+                      <a:tailEnd type="none" w="med" len="med"/>
+                    </a:lnT>
+                    <a:lnB w="6350" cap="flat" cmpd="sng" algn="ctr">
+                      <a:solidFill>
+                        <a:srgbClr val="D8DFE9"/>
+                      </a:solidFill>
+                      <a:prstDash val="solid"/>
+                      <a:round/>
+                      <a:headEnd type="none" w="med" len="med"/>
+                      <a:tailEnd type="none" w="med" len="med"/>
+                    </a:lnB>
+                    <a:solidFill>
+                      <a:srgbClr val="045D66"/>
+                    </a:solidFill>
+                  </a:tcPr>
+                </a:tc>
+              </a:tr>
+              <a:tr h="274320">
+                <a:tc>
+                  <a:txBody>
+                    <a:bodyPr/>
+                    <a:lstStyle/>
+                    <a:p>
+                      <a:pPr algn="l" indent="0" marL="0">
+                        <a:buNone/>
+                      </a:pPr>
+                      <a:r>
+                        <a:rPr lang="en-US" sz="950" b="1" dirty="0">
+                          <a:solidFill>
+                            <a:srgbClr val="16233D"/>
+                          </a:solidFill>
+                          <a:latin typeface="Graphik TH" pitchFamily="34" charset="0"/>
+                          <a:ea typeface="Graphik TH" pitchFamily="34" charset="-122"/>
+                          <a:cs typeface="Graphik TH" pitchFamily="34" charset="-120"/>
+                        </a:rPr>
+                        <a:t>Very High</a:t>
+                      </a:r>
+                      <a:endParaRPr lang="en-US" sz="950" dirty="0">
+                        <a:latin typeface="Graphik TH" charset="0"/>
+                        <a:ea typeface="Graphik TH" charset="0"/>
+                        <a:cs typeface="Graphik TH" charset="0"/>
+                      </a:endParaRPr>
+                    </a:p>
+                  </a:txBody>
+                  <a:tcPr marL="73152" marR="73152" marT="18288" marB="18288" anchor="ctr">
+                    <a:lnL w="6350" cap="flat" cmpd="sng" algn="ctr">
+                      <a:solidFill>
+                        <a:srgbClr val="D8DFE9"/>
+                      </a:solidFill>
+                      <a:prstDash val="solid"/>
+                      <a:round/>
+                      <a:headEnd type="none" w="med" len="med"/>
+                      <a:tailEnd type="none" w="med" len="med"/>
+                    </a:lnL>
+                    <a:lnR w="6350" cap="flat" cmpd="sng" algn="ctr">
+                      <a:solidFill>
+                        <a:srgbClr val="D8DFE9"/>
+                      </a:solidFill>
+                      <a:prstDash val="solid"/>
+                      <a:round/>
+                      <a:headEnd type="none" w="med" len="med"/>
+                      <a:tailEnd type="none" w="med" len="med"/>
+                    </a:lnR>
+                    <a:lnT w="6350" cap="flat" cmpd="sng" algn="ctr">
+                      <a:solidFill>
+                        <a:srgbClr val="D8DFE9"/>
+                      </a:solidFill>
+                      <a:prstDash val="solid"/>
+                      <a:round/>
+                      <a:headEnd type="none" w="med" len="med"/>
+                      <a:tailEnd type="none" w="med" len="med"/>
+                    </a:lnT>
+                    <a:lnB w="6350" cap="flat" cmpd="sng" algn="ctr">
+                      <a:solidFill>
+                        <a:srgbClr val="D8DFE9"/>
+                      </a:solidFill>
+                      <a:prstDash val="solid"/>
+                      <a:round/>
+                      <a:headEnd type="none" w="med" len="med"/>
+                      <a:tailEnd type="none" w="med" len="med"/>
+                    </a:lnB>
+                    <a:solidFill>
+                      <a:srgbClr val="F1F4F9"/>
+                    </a:solidFill>
+                  </a:tcPr>
+                </a:tc>
+                <a:tc>
+                  <a:txBody>
+                    <a:bodyPr/>
+                    <a:lstStyle/>
+                    <a:p>
+                      <a:pPr algn="r" indent="0" marL="0">
+                        <a:buNone/>
+                      </a:pPr>
+                      <a:r>
+                        <a:rPr lang="en-US" sz="950" dirty="0">
+                          <a:solidFill>
+                            <a:srgbClr val="16233D"/>
+                          </a:solidFill>
+                          <a:latin typeface="Graphik TH" pitchFamily="34" charset="0"/>
+                          <a:ea typeface="Graphik TH" pitchFamily="34" charset="-122"/>
+                          <a:cs typeface="Graphik TH" pitchFamily="34" charset="-120"/>
+                        </a:rPr>
+                        <a:t>346.4</a:t>
+                      </a:r>
+                      <a:endParaRPr lang="en-US" sz="950" dirty="0">
+                        <a:latin typeface="Graphik TH" charset="0"/>
+                        <a:ea typeface="Graphik TH" charset="0"/>
+                        <a:cs typeface="Graphik TH" charset="0"/>
+                      </a:endParaRPr>
+                    </a:p>
+                  </a:txBody>
+                  <a:tcPr marL="73152" marR="73152" marT="18288" marB="18288" anchor="ctr">
+                    <a:lnL w="6350" cap="flat" cmpd="sng" algn="ctr">
+                      <a:solidFill>
+                        <a:srgbClr val="D8DFE9"/>
+                      </a:solidFill>
+                      <a:prstDash val="solid"/>
+                      <a:round/>
+                      <a:headEnd type="none" w="med" len="med"/>
+                      <a:tailEnd type="none" w="med" len="med"/>
+                    </a:lnL>
+                    <a:lnR w="6350" cap="flat" cmpd="sng" algn="ctr">
+                      <a:solidFill>
+                        <a:srgbClr val="D8DFE9"/>
+                      </a:solidFill>
+                      <a:prstDash val="solid"/>
+                      <a:round/>
+                      <a:headEnd type="none" w="med" len="med"/>
+                      <a:tailEnd type="none" w="med" len="med"/>
+                    </a:lnR>
+                    <a:lnT w="6350" cap="flat" cmpd="sng" algn="ctr">
+                      <a:solidFill>
+                        <a:srgbClr val="D8DFE9"/>
+                      </a:solidFill>
+                      <a:prstDash val="solid"/>
+                      <a:round/>
+                      <a:headEnd type="none" w="med" len="med"/>
+                      <a:tailEnd type="none" w="med" len="med"/>
+                    </a:lnT>
+                    <a:lnB w="6350" cap="flat" cmpd="sng" algn="ctr">
+                      <a:solidFill>
+                        <a:srgbClr val="D8DFE9"/>
+                      </a:solidFill>
+                      <a:prstDash val="solid"/>
+                      <a:round/>
+                      <a:headEnd type="none" w="med" len="med"/>
+                      <a:tailEnd type="none" w="med" len="med"/>
+                    </a:lnB>
+                    <a:solidFill>
+                      <a:srgbClr val="FFFFFF"/>
+                    </a:solidFill>
+                  </a:tcPr>
+                </a:tc>
+                <a:tc>
+                  <a:txBody>
+                    <a:bodyPr/>
+                    <a:lstStyle/>
+                    <a:p>
+                      <a:pPr algn="r" indent="0" marL="0">
+                        <a:buNone/>
+                      </a:pPr>
+                      <a:r>
+                        <a:rPr lang="en-US" sz="950" dirty="0">
+                          <a:solidFill>
+                            <a:srgbClr val="16233D"/>
+                          </a:solidFill>
+                          <a:latin typeface="Graphik TH" pitchFamily="34" charset="0"/>
+                          <a:ea typeface="Graphik TH" pitchFamily="34" charset="-122"/>
+                          <a:cs typeface="Graphik TH" pitchFamily="34" charset="-120"/>
+                        </a:rPr>
+                        <a:t>591.0</a:t>
+                      </a:r>
+                      <a:endParaRPr lang="en-US" sz="950" dirty="0">
+                        <a:latin typeface="Graphik TH" charset="0"/>
+                        <a:ea typeface="Graphik TH" charset="0"/>
+                        <a:cs typeface="Graphik TH" charset="0"/>
+                      </a:endParaRPr>
+                    </a:p>
+                  </a:txBody>
+                  <a:tcPr marL="73152" marR="73152" marT="18288" marB="18288" anchor="ctr">
+                    <a:lnL w="6350" cap="flat" cmpd="sng" algn="ctr">
+                      <a:solidFill>
+                        <a:srgbClr val="D8DFE9"/>
+                      </a:solidFill>
+                      <a:prstDash val="solid"/>
+                      <a:round/>
+                      <a:headEnd type="none" w="med" len="med"/>
+                      <a:tailEnd type="none" w="med" len="med"/>
+                    </a:lnL>
+                    <a:lnR w="6350" cap="flat" cmpd="sng" algn="ctr">
+                      <a:solidFill>
+                        <a:srgbClr val="D8DFE9"/>
+                      </a:solidFill>
+                      <a:prstDash val="solid"/>
+                      <a:round/>
+                      <a:headEnd type="none" w="med" len="med"/>
+                      <a:tailEnd type="none" w="med" len="med"/>
+                    </a:lnR>
+                    <a:lnT w="6350" cap="flat" cmpd="sng" algn="ctr">
+                      <a:solidFill>
+                        <a:srgbClr val="D8DFE9"/>
+                      </a:solidFill>
+                      <a:prstDash val="solid"/>
+                      <a:round/>
+                      <a:headEnd type="none" w="med" len="med"/>
+                      <a:tailEnd type="none" w="med" len="med"/>
+                    </a:lnT>
+                    <a:lnB w="6350" cap="flat" cmpd="sng" algn="ctr">
+                      <a:solidFill>
+                        <a:srgbClr val="D8DFE9"/>
+                      </a:solidFill>
+                      <a:prstDash val="solid"/>
+                      <a:round/>
+                      <a:headEnd type="none" w="med" len="med"/>
+                      <a:tailEnd type="none" w="med" len="med"/>
+                    </a:lnB>
+                    <a:solidFill>
+                      <a:srgbClr val="FFFFFF"/>
+                    </a:solidFill>
+                  </a:tcPr>
+                </a:tc>
+                <a:tc>
+                  <a:txBody>
+                    <a:bodyPr/>
+                    <a:lstStyle/>
+                    <a:p>
+                      <a:pPr algn="r" indent="0" marL="0">
+                        <a:buNone/>
+                      </a:pPr>
+                      <a:r>
+                        <a:rPr lang="en-US" sz="950" dirty="0">
+                          <a:solidFill>
+                            <a:srgbClr val="16233D"/>
+                          </a:solidFill>
+                          <a:latin typeface="Graphik TH" pitchFamily="34" charset="0"/>
+                          <a:ea typeface="Graphik TH" pitchFamily="34" charset="-122"/>
+                          <a:cs typeface="Graphik TH" pitchFamily="34" charset="-120"/>
+                        </a:rPr>
+                        <a:t>3.3</a:t>
+                      </a:r>
+                      <a:endParaRPr lang="en-US" sz="950" dirty="0">
+                        <a:latin typeface="Graphik TH" charset="0"/>
+                        <a:ea typeface="Graphik TH" charset="0"/>
+                        <a:cs typeface="Graphik TH" charset="0"/>
+                      </a:endParaRPr>
+                    </a:p>
+                  </a:txBody>
+                  <a:tcPr marL="73152" marR="73152" marT="18288" marB="18288" anchor="ctr">
+                    <a:lnL w="6350" cap="flat" cmpd="sng" algn="ctr">
+                      <a:solidFill>
+                        <a:srgbClr val="D8DFE9"/>
+                      </a:solidFill>
+                      <a:prstDash val="solid"/>
+                      <a:round/>
+                      <a:headEnd type="none" w="med" len="med"/>
+                      <a:tailEnd type="none" w="med" len="med"/>
+                    </a:lnL>
+                    <a:lnR w="6350" cap="flat" cmpd="sng" algn="ctr">
+                      <a:solidFill>
+                        <a:srgbClr val="D8DFE9"/>
+                      </a:solidFill>
+                      <a:prstDash val="solid"/>
+                      <a:round/>
+                      <a:headEnd type="none" w="med" len="med"/>
+                      <a:tailEnd type="none" w="med" len="med"/>
+                    </a:lnR>
+                    <a:lnT w="6350" cap="flat" cmpd="sng" algn="ctr">
+                      <a:solidFill>
+                        <a:srgbClr val="D8DFE9"/>
+                      </a:solidFill>
+                      <a:prstDash val="solid"/>
+                      <a:round/>
+                      <a:headEnd type="none" w="med" len="med"/>
+                      <a:tailEnd type="none" w="med" len="med"/>
+                    </a:lnT>
+                    <a:lnB w="6350" cap="flat" cmpd="sng" algn="ctr">
+                      <a:solidFill>
+                        <a:srgbClr val="D8DFE9"/>
+                      </a:solidFill>
+                      <a:prstDash val="solid"/>
+                      <a:round/>
+                      <a:headEnd type="none" w="med" len="med"/>
+                      <a:tailEnd type="none" w="med" len="med"/>
+                    </a:lnB>
+                    <a:solidFill>
+                      <a:srgbClr val="FFFFFF"/>
+                    </a:solidFill>
+                  </a:tcPr>
+                </a:tc>
+                <a:tc>
+                  <a:txBody>
+                    <a:bodyPr/>
+                    <a:lstStyle/>
+                    <a:p>
+                      <a:pPr algn="r" indent="0" marL="0">
+                        <a:buNone/>
+                      </a:pPr>
+                      <a:r>
+                        <a:rPr lang="en-US" sz="950" b="1" dirty="0">
+                          <a:solidFill>
+                            <a:srgbClr val="C00000"/>
+                          </a:solidFill>
+                          <a:latin typeface="Graphik TH" pitchFamily="34" charset="0"/>
+                          <a:ea typeface="Graphik TH" pitchFamily="34" charset="-122"/>
+                          <a:cs typeface="Graphik TH" pitchFamily="34" charset="-120"/>
+                        </a:rPr>
+                        <a:t>464.2</a:t>
+                      </a:r>
+                      <a:endParaRPr lang="en-US" sz="950" dirty="0">
+                        <a:latin typeface="Graphik TH" charset="0"/>
+                        <a:ea typeface="Graphik TH" charset="0"/>
+                        <a:cs typeface="Graphik TH" charset="0"/>
+                      </a:endParaRPr>
+                    </a:p>
+                  </a:txBody>
+                  <a:tcPr marL="73152" marR="73152" marT="18288" marB="18288" anchor="ctr">
+                    <a:lnL w="6350" cap="flat" cmpd="sng" algn="ctr">
+                      <a:solidFill>
+                        <a:srgbClr val="D8DFE9"/>
+                      </a:solidFill>
+                      <a:prstDash val="solid"/>
+                      <a:round/>
+                      <a:headEnd type="none" w="med" len="med"/>
+                      <a:tailEnd type="none" w="med" len="med"/>
+                    </a:lnL>
+                    <a:lnR w="6350" cap="flat" cmpd="sng" algn="ctr">
+                      <a:solidFill>
+                        <a:srgbClr val="D8DFE9"/>
+                      </a:solidFill>
+                      <a:prstDash val="solid"/>
+                      <a:round/>
+                      <a:headEnd type="none" w="med" len="med"/>
+                      <a:tailEnd type="none" w="med" len="med"/>
+                    </a:lnR>
+                    <a:lnT w="6350" cap="flat" cmpd="sng" algn="ctr">
+                      <a:solidFill>
+                        <a:srgbClr val="D8DFE9"/>
+                      </a:solidFill>
+                      <a:prstDash val="solid"/>
+                      <a:round/>
+                      <a:headEnd type="none" w="med" len="med"/>
+                      <a:tailEnd type="none" w="med" len="med"/>
+                    </a:lnT>
+                    <a:lnB w="6350" cap="flat" cmpd="sng" algn="ctr">
+                      <a:solidFill>
+                        <a:srgbClr val="D8DFE9"/>
+                      </a:solidFill>
+                      <a:prstDash val="solid"/>
+                      <a:round/>
+                      <a:headEnd type="none" w="med" len="med"/>
+                      <a:tailEnd type="none" w="med" len="med"/>
+                    </a:lnB>
+                    <a:solidFill>
+                      <a:srgbClr val="F7DEDE"/>
+                    </a:solidFill>
+                  </a:tcPr>
+                </a:tc>
+                <a:tc>
+                  <a:txBody>
+                    <a:bodyPr/>
+                    <a:lstStyle/>
+                    <a:p>
+                      <a:pPr algn="r" indent="0" marL="0">
+                        <a:buNone/>
+                      </a:pPr>
+                      <a:r>
+                        <a:rPr lang="en-US" sz="950" b="1" dirty="0">
+                          <a:solidFill>
+                            <a:srgbClr val="C00000"/>
+                          </a:solidFill>
+                          <a:latin typeface="Graphik TH" pitchFamily="34" charset="0"/>
+                          <a:ea typeface="Graphik TH" pitchFamily="34" charset="-122"/>
+                          <a:cs typeface="Graphik TH" pitchFamily="34" charset="-120"/>
+                        </a:rPr>
+                        <a:t>1,258.9</a:t>
+                      </a:r>
+                      <a:endParaRPr lang="en-US" sz="950" dirty="0">
+                        <a:latin typeface="Graphik TH" charset="0"/>
+                        <a:ea typeface="Graphik TH" charset="0"/>
+                        <a:cs typeface="Graphik TH" charset="0"/>
+                      </a:endParaRPr>
+                    </a:p>
+                  </a:txBody>
+                  <a:tcPr marL="73152" marR="73152" marT="18288" marB="18288" anchor="ctr">
+                    <a:lnL w="6350" cap="flat" cmpd="sng" algn="ctr">
+                      <a:solidFill>
+                        <a:srgbClr val="D8DFE9"/>
+                      </a:solidFill>
+                      <a:prstDash val="solid"/>
+                      <a:round/>
+                      <a:headEnd type="none" w="med" len="med"/>
+                      <a:tailEnd type="none" w="med" len="med"/>
+                    </a:lnL>
+                    <a:lnR w="6350" cap="flat" cmpd="sng" algn="ctr">
+                      <a:solidFill>
+                        <a:srgbClr val="D8DFE9"/>
+                      </a:solidFill>
+                      <a:prstDash val="solid"/>
+                      <a:round/>
+                      <a:headEnd type="none" w="med" len="med"/>
+                      <a:tailEnd type="none" w="med" len="med"/>
+                    </a:lnR>
+                    <a:lnT w="6350" cap="flat" cmpd="sng" algn="ctr">
+                      <a:solidFill>
+                        <a:srgbClr val="D8DFE9"/>
+                      </a:solidFill>
+                      <a:prstDash val="solid"/>
+                      <a:round/>
+                      <a:headEnd type="none" w="med" len="med"/>
+                      <a:tailEnd type="none" w="med" len="med"/>
+                    </a:lnT>
+                    <a:lnB w="6350" cap="flat" cmpd="sng" algn="ctr">
+                      <a:solidFill>
+                        <a:srgbClr val="D8DFE9"/>
+                      </a:solidFill>
+                      <a:prstDash val="solid"/>
+                      <a:round/>
+                      <a:headEnd type="none" w="med" len="med"/>
+                      <a:tailEnd type="none" w="med" len="med"/>
+                    </a:lnB>
+                    <a:solidFill>
+                      <a:srgbClr val="F7DEDE"/>
+                    </a:solidFill>
+                  </a:tcPr>
+                </a:tc>
+              </a:tr>
+              <a:tr h="274320">
+                <a:tc>
+                  <a:txBody>
+                    <a:bodyPr/>
+                    <a:lstStyle/>
+                    <a:p>
+                      <a:pPr algn="l" indent="0" marL="0">
+                        <a:buNone/>
+                      </a:pPr>
+                      <a:r>
+                        <a:rPr lang="en-US" sz="950" b="1" dirty="0">
+                          <a:solidFill>
+                            <a:srgbClr val="16233D"/>
+                          </a:solidFill>
+                          <a:latin typeface="Graphik TH" pitchFamily="34" charset="0"/>
+                          <a:ea typeface="Graphik TH" pitchFamily="34" charset="-122"/>
+                          <a:cs typeface="Graphik TH" pitchFamily="34" charset="-120"/>
+                        </a:rPr>
+                        <a:t>High</a:t>
+                      </a:r>
+                      <a:endParaRPr lang="en-US" sz="950" dirty="0">
+                        <a:latin typeface="Graphik TH" charset="0"/>
+                        <a:ea typeface="Graphik TH" charset="0"/>
+                        <a:cs typeface="Graphik TH" charset="0"/>
+                      </a:endParaRPr>
+                    </a:p>
+                  </a:txBody>
+                  <a:tcPr marL="73152" marR="73152" marT="18288" marB="18288" anchor="ctr">
+                    <a:lnL w="6350" cap="flat" cmpd="sng" algn="ctr">
+                      <a:solidFill>
+                        <a:srgbClr val="D8DFE9"/>
+                      </a:solidFill>
+                      <a:prstDash val="solid"/>
+                      <a:round/>
+                      <a:headEnd type="none" w="med" len="med"/>
+                      <a:tailEnd type="none" w="med" len="med"/>
+                    </a:lnL>
+                    <a:lnR w="6350" cap="flat" cmpd="sng" algn="ctr">
+                      <a:solidFill>
+                        <a:srgbClr val="D8DFE9"/>
+                      </a:solidFill>
+                      <a:prstDash val="solid"/>
+                      <a:round/>
+                      <a:headEnd type="none" w="med" len="med"/>
+                      <a:tailEnd type="none" w="med" len="med"/>
+                    </a:lnR>
+                    <a:lnT w="6350" cap="flat" cmpd="sng" algn="ctr">
+                      <a:solidFill>
+                        <a:srgbClr val="D8DFE9"/>
+                      </a:solidFill>
+                      <a:prstDash val="solid"/>
+                      <a:round/>
+                      <a:headEnd type="none" w="med" len="med"/>
+                      <a:tailEnd type="none" w="med" len="med"/>
+                    </a:lnT>
+                    <a:lnB w="6350" cap="flat" cmpd="sng" algn="ctr">
+                      <a:solidFill>
+                        <a:srgbClr val="D8DFE9"/>
+                      </a:solidFill>
+                      <a:prstDash val="solid"/>
+                      <a:round/>
+                      <a:headEnd type="none" w="med" len="med"/>
+                      <a:tailEnd type="none" w="med" len="med"/>
+                    </a:lnB>
+                    <a:solidFill>
+                      <a:srgbClr val="F1F4F9"/>
+                    </a:solidFill>
+                  </a:tcPr>
+                </a:tc>
+                <a:tc>
+                  <a:txBody>
+                    <a:bodyPr/>
+                    <a:lstStyle/>
+                    <a:p>
+                      <a:pPr algn="r" indent="0" marL="0">
+                        <a:buNone/>
+                      </a:pPr>
+                      <a:r>
+                        <a:rPr lang="en-US" sz="950" dirty="0">
+                          <a:solidFill>
+                            <a:srgbClr val="16233D"/>
+                          </a:solidFill>
+                          <a:latin typeface="Graphik TH" pitchFamily="34" charset="0"/>
+                          <a:ea typeface="Graphik TH" pitchFamily="34" charset="-122"/>
+                          <a:cs typeface="Graphik TH" pitchFamily="34" charset="-120"/>
+                        </a:rPr>
+                        <a:t>263.9</a:t>
+                      </a:r>
+                      <a:endParaRPr lang="en-US" sz="950" dirty="0">
+                        <a:latin typeface="Graphik TH" charset="0"/>
+                        <a:ea typeface="Graphik TH" charset="0"/>
+                        <a:cs typeface="Graphik TH" charset="0"/>
+                      </a:endParaRPr>
+                    </a:p>
+                  </a:txBody>
+                  <a:tcPr marL="73152" marR="73152" marT="18288" marB="18288" anchor="ctr">
+                    <a:lnL w="6350" cap="flat" cmpd="sng" algn="ctr">
+                      <a:solidFill>
+                        <a:srgbClr val="D8DFE9"/>
+                      </a:solidFill>
+                      <a:prstDash val="solid"/>
+                      <a:round/>
+                      <a:headEnd type="none" w="med" len="med"/>
+                      <a:tailEnd type="none" w="med" len="med"/>
+                    </a:lnL>
+                    <a:lnR w="6350" cap="flat" cmpd="sng" algn="ctr">
+                      <a:solidFill>
+                        <a:srgbClr val="D8DFE9"/>
+                      </a:solidFill>
+                      <a:prstDash val="solid"/>
+                      <a:round/>
+                      <a:headEnd type="none" w="med" len="med"/>
+                      <a:tailEnd type="none" w="med" len="med"/>
+                    </a:lnR>
+                    <a:lnT w="6350" cap="flat" cmpd="sng" algn="ctr">
+                      <a:solidFill>
+                        <a:srgbClr val="D8DFE9"/>
+                      </a:solidFill>
+                      <a:prstDash val="solid"/>
+                      <a:round/>
+                      <a:headEnd type="none" w="med" len="med"/>
+                      <a:tailEnd type="none" w="med" len="med"/>
+                    </a:lnT>
+                    <a:lnB w="6350" cap="flat" cmpd="sng" algn="ctr">
+                      <a:solidFill>
+                        <a:srgbClr val="D8DFE9"/>
+                      </a:solidFill>
+                      <a:prstDash val="solid"/>
+                      <a:round/>
+                      <a:headEnd type="none" w="med" len="med"/>
+                      <a:tailEnd type="none" w="med" len="med"/>
+                    </a:lnB>
+                    <a:solidFill>
+                      <a:srgbClr val="FFFFFF"/>
+                    </a:solidFill>
+                  </a:tcPr>
+                </a:tc>
+                <a:tc>
+                  <a:txBody>
+                    <a:bodyPr/>
+                    <a:lstStyle/>
+                    <a:p>
+                      <a:pPr algn="r" indent="0" marL="0">
+                        <a:buNone/>
+                      </a:pPr>
+                      <a:r>
+                        <a:rPr lang="en-US" sz="950" dirty="0">
+                          <a:solidFill>
+                            <a:srgbClr val="16233D"/>
+                          </a:solidFill>
+                          <a:latin typeface="Graphik TH" pitchFamily="34" charset="0"/>
+                          <a:ea typeface="Graphik TH" pitchFamily="34" charset="-122"/>
+                          <a:cs typeface="Graphik TH" pitchFamily="34" charset="-120"/>
+                        </a:rPr>
+                        <a:t>310.8</a:t>
+                      </a:r>
+                      <a:endParaRPr lang="en-US" sz="950" dirty="0">
+                        <a:latin typeface="Graphik TH" charset="0"/>
+                        <a:ea typeface="Graphik TH" charset="0"/>
+                        <a:cs typeface="Graphik TH" charset="0"/>
+                      </a:endParaRPr>
+                    </a:p>
+                  </a:txBody>
+                  <a:tcPr marL="73152" marR="73152" marT="18288" marB="18288" anchor="ctr">
+                    <a:lnL w="6350" cap="flat" cmpd="sng" algn="ctr">
+                      <a:solidFill>
+                        <a:srgbClr val="D8DFE9"/>
+                      </a:solidFill>
+                      <a:prstDash val="solid"/>
+                      <a:round/>
+                      <a:headEnd type="none" w="med" len="med"/>
+                      <a:tailEnd type="none" w="med" len="med"/>
+                    </a:lnL>
+                    <a:lnR w="6350" cap="flat" cmpd="sng" algn="ctr">
+                      <a:solidFill>
+                        <a:srgbClr val="D8DFE9"/>
+                      </a:solidFill>
+                      <a:prstDash val="solid"/>
+                      <a:round/>
+                      <a:headEnd type="none" w="med" len="med"/>
+                      <a:tailEnd type="none" w="med" len="med"/>
+                    </a:lnR>
+                    <a:lnT w="6350" cap="flat" cmpd="sng" algn="ctr">
+                      <a:solidFill>
+                        <a:srgbClr val="D8DFE9"/>
+                      </a:solidFill>
+                      <a:prstDash val="solid"/>
+                      <a:round/>
+                      <a:headEnd type="none" w="med" len="med"/>
+                      <a:tailEnd type="none" w="med" len="med"/>
+                    </a:lnT>
+                    <a:lnB w="6350" cap="flat" cmpd="sng" algn="ctr">
+                      <a:solidFill>
+                        <a:srgbClr val="D8DFE9"/>
+                      </a:solidFill>
+                      <a:prstDash val="solid"/>
+                      <a:round/>
+                      <a:headEnd type="none" w="med" len="med"/>
+                      <a:tailEnd type="none" w="med" len="med"/>
+                    </a:lnB>
+                    <a:solidFill>
+                      <a:srgbClr val="FFFFFF"/>
+                    </a:solidFill>
+                  </a:tcPr>
+                </a:tc>
+                <a:tc>
+                  <a:txBody>
+                    <a:bodyPr/>
+                    <a:lstStyle/>
+                    <a:p>
+                      <a:pPr algn="r" indent="0" marL="0">
+                        <a:buNone/>
+                      </a:pPr>
+                      <a:r>
+                        <a:rPr lang="en-US" sz="950" dirty="0">
+                          <a:solidFill>
+                            <a:srgbClr val="16233D"/>
+                          </a:solidFill>
+                          <a:latin typeface="Graphik TH" pitchFamily="34" charset="0"/>
+                          <a:ea typeface="Graphik TH" pitchFamily="34" charset="-122"/>
+                          <a:cs typeface="Graphik TH" pitchFamily="34" charset="-120"/>
+                        </a:rPr>
+                        <a:t>3.0</a:t>
+                      </a:r>
+                      <a:endParaRPr lang="en-US" sz="950" dirty="0">
+                        <a:latin typeface="Graphik TH" charset="0"/>
+                        <a:ea typeface="Graphik TH" charset="0"/>
+                        <a:cs typeface="Graphik TH" charset="0"/>
+                      </a:endParaRPr>
+                    </a:p>
+                  </a:txBody>
+                  <a:tcPr marL="73152" marR="73152" marT="18288" marB="18288" anchor="ctr">
+                    <a:lnL w="6350" cap="flat" cmpd="sng" algn="ctr">
+                      <a:solidFill>
+                        <a:srgbClr val="D8DFE9"/>
+                      </a:solidFill>
+                      <a:prstDash val="solid"/>
+                      <a:round/>
+                      <a:headEnd type="none" w="med" len="med"/>
+                      <a:tailEnd type="none" w="med" len="med"/>
+                    </a:lnL>
+                    <a:lnR w="6350" cap="flat" cmpd="sng" algn="ctr">
+                      <a:solidFill>
+                        <a:srgbClr val="D8DFE9"/>
+                      </a:solidFill>
+                      <a:prstDash val="solid"/>
+                      <a:round/>
+                      <a:headEnd type="none" w="med" len="med"/>
+                      <a:tailEnd type="none" w="med" len="med"/>
+                    </a:lnR>
+                    <a:lnT w="6350" cap="flat" cmpd="sng" algn="ctr">
+                      <a:solidFill>
+                        <a:srgbClr val="D8DFE9"/>
+                      </a:solidFill>
+                      <a:prstDash val="solid"/>
+                      <a:round/>
+                      <a:headEnd type="none" w="med" len="med"/>
+                      <a:tailEnd type="none" w="med" len="med"/>
+                    </a:lnT>
+                    <a:lnB w="6350" cap="flat" cmpd="sng" algn="ctr">
+                      <a:solidFill>
+                        <a:srgbClr val="D8DFE9"/>
+                      </a:solidFill>
+                      <a:prstDash val="solid"/>
+                      <a:round/>
+                      <a:headEnd type="none" w="med" len="med"/>
+                      <a:tailEnd type="none" w="med" len="med"/>
+                    </a:lnB>
+                    <a:solidFill>
+                      <a:srgbClr val="FFFFFF"/>
+                    </a:solidFill>
+                  </a:tcPr>
+                </a:tc>
+                <a:tc>
+                  <a:txBody>
+                    <a:bodyPr/>
+                    <a:lstStyle/>
+                    <a:p>
+                      <a:pPr algn="r" indent="0" marL="0">
+                        <a:buNone/>
+                      </a:pPr>
+                      <a:r>
+                        <a:rPr lang="en-US" sz="950" b="1" dirty="0">
+                          <a:solidFill>
+                            <a:srgbClr val="C00000"/>
+                          </a:solidFill>
+                          <a:latin typeface="Graphik TH" pitchFamily="34" charset="0"/>
+                          <a:ea typeface="Graphik TH" pitchFamily="34" charset="-122"/>
+                          <a:cs typeface="Graphik TH" pitchFamily="34" charset="-120"/>
+                        </a:rPr>
+                        <a:t>693.0</a:t>
+                      </a:r>
+                      <a:endParaRPr lang="en-US" sz="950" dirty="0">
+                        <a:latin typeface="Graphik TH" charset="0"/>
+                        <a:ea typeface="Graphik TH" charset="0"/>
+                        <a:cs typeface="Graphik TH" charset="0"/>
+                      </a:endParaRPr>
+                    </a:p>
+                  </a:txBody>
+                  <a:tcPr marL="73152" marR="73152" marT="18288" marB="18288" anchor="ctr">
+                    <a:lnL w="6350" cap="flat" cmpd="sng" algn="ctr">
+                      <a:solidFill>
+                        <a:srgbClr val="D8DFE9"/>
+                      </a:solidFill>
+                      <a:prstDash val="solid"/>
+                      <a:round/>
+                      <a:headEnd type="none" w="med" len="med"/>
+                      <a:tailEnd type="none" w="med" len="med"/>
+                    </a:lnL>
+                    <a:lnR w="6350" cap="flat" cmpd="sng" algn="ctr">
+                      <a:solidFill>
+                        <a:srgbClr val="D8DFE9"/>
+                      </a:solidFill>
+                      <a:prstDash val="solid"/>
+                      <a:round/>
+                      <a:headEnd type="none" w="med" len="med"/>
+                      <a:tailEnd type="none" w="med" len="med"/>
+                    </a:lnR>
+                    <a:lnT w="6350" cap="flat" cmpd="sng" algn="ctr">
+                      <a:solidFill>
+                        <a:srgbClr val="D8DFE9"/>
+                      </a:solidFill>
+                      <a:prstDash val="solid"/>
+                      <a:round/>
+                      <a:headEnd type="none" w="med" len="med"/>
+                      <a:tailEnd type="none" w="med" len="med"/>
+                    </a:lnT>
+                    <a:lnB w="6350" cap="flat" cmpd="sng" algn="ctr">
+                      <a:solidFill>
+                        <a:srgbClr val="D8DFE9"/>
+                      </a:solidFill>
+                      <a:prstDash val="solid"/>
+                      <a:round/>
+                      <a:headEnd type="none" w="med" len="med"/>
+                      <a:tailEnd type="none" w="med" len="med"/>
+                    </a:lnB>
+                    <a:solidFill>
+                      <a:srgbClr val="F7DEDE"/>
+                    </a:solidFill>
+                  </a:tcPr>
+                </a:tc>
+                <a:tc>
+                  <a:txBody>
+                    <a:bodyPr/>
+                    <a:lstStyle/>
+                    <a:p>
+                      <a:pPr algn="r" indent="0" marL="0">
+                        <a:buNone/>
+                      </a:pPr>
+                      <a:r>
+                        <a:rPr lang="en-US" sz="950" b="1" dirty="0">
+                          <a:solidFill>
+                            <a:srgbClr val="C00000"/>
+                          </a:solidFill>
+                          <a:latin typeface="Graphik TH" pitchFamily="34" charset="0"/>
+                          <a:ea typeface="Graphik TH" pitchFamily="34" charset="-122"/>
+                          <a:cs typeface="Graphik TH" pitchFamily="34" charset="-120"/>
+                        </a:rPr>
+                        <a:t>1,314.8</a:t>
+                      </a:r>
+                      <a:endParaRPr lang="en-US" sz="950" dirty="0">
+                        <a:latin typeface="Graphik TH" charset="0"/>
+                        <a:ea typeface="Graphik TH" charset="0"/>
+                        <a:cs typeface="Graphik TH" charset="0"/>
+                      </a:endParaRPr>
+                    </a:p>
+                  </a:txBody>
+                  <a:tcPr marL="73152" marR="73152" marT="18288" marB="18288" anchor="ctr">
+                    <a:lnL w="6350" cap="flat" cmpd="sng" algn="ctr">
+                      <a:solidFill>
+                        <a:srgbClr val="D8DFE9"/>
+                      </a:solidFill>
+                      <a:prstDash val="solid"/>
+                      <a:round/>
+                      <a:headEnd type="none" w="med" len="med"/>
+                      <a:tailEnd type="none" w="med" len="med"/>
+                    </a:lnL>
+                    <a:lnR w="6350" cap="flat" cmpd="sng" algn="ctr">
+                      <a:solidFill>
+                        <a:srgbClr val="D8DFE9"/>
+                      </a:solidFill>
+                      <a:prstDash val="solid"/>
+                      <a:round/>
+                      <a:headEnd type="none" w="med" len="med"/>
+                      <a:tailEnd type="none" w="med" len="med"/>
+                    </a:lnR>
+                    <a:lnT w="6350" cap="flat" cmpd="sng" algn="ctr">
+                      <a:solidFill>
+                        <a:srgbClr val="D8DFE9"/>
+                      </a:solidFill>
+                      <a:prstDash val="solid"/>
+                      <a:round/>
+                      <a:headEnd type="none" w="med" len="med"/>
+                      <a:tailEnd type="none" w="med" len="med"/>
+                    </a:lnT>
+                    <a:lnB w="6350" cap="flat" cmpd="sng" algn="ctr">
+                      <a:solidFill>
+                        <a:srgbClr val="D8DFE9"/>
+                      </a:solidFill>
+                      <a:prstDash val="solid"/>
+                      <a:round/>
+                      <a:headEnd type="none" w="med" len="med"/>
+                      <a:tailEnd type="none" w="med" len="med"/>
+                    </a:lnB>
+                    <a:solidFill>
+                      <a:srgbClr val="F7DEDE"/>
+                    </a:solidFill>
+                  </a:tcPr>
+                </a:tc>
+              </a:tr>
+              <a:tr h="274320">
+                <a:tc>
+                  <a:txBody>
+                    <a:bodyPr/>
+                    <a:lstStyle/>
+                    <a:p>
+                      <a:pPr algn="l" indent="0" marL="0">
+                        <a:buNone/>
+                      </a:pPr>
+                      <a:r>
+                        <a:rPr lang="en-US" sz="950" b="1" dirty="0">
+                          <a:solidFill>
+                            <a:srgbClr val="16233D"/>
+                          </a:solidFill>
+                          <a:latin typeface="Graphik TH" pitchFamily="34" charset="0"/>
+                          <a:ea typeface="Graphik TH" pitchFamily="34" charset="-122"/>
+                          <a:cs typeface="Graphik TH" pitchFamily="34" charset="-120"/>
+                        </a:rPr>
+                        <a:t>Medium</a:t>
+                      </a:r>
+                      <a:endParaRPr lang="en-US" sz="950" dirty="0">
+                        <a:latin typeface="Graphik TH" charset="0"/>
+                        <a:ea typeface="Graphik TH" charset="0"/>
+                        <a:cs typeface="Graphik TH" charset="0"/>
+                      </a:endParaRPr>
+                    </a:p>
+                  </a:txBody>
+                  <a:tcPr marL="73152" marR="73152" marT="18288" marB="18288" anchor="ctr">
+                    <a:lnL w="6350" cap="flat" cmpd="sng" algn="ctr">
+                      <a:solidFill>
+                        <a:srgbClr val="D8DFE9"/>
+                      </a:solidFill>
+                      <a:prstDash val="solid"/>
+                      <a:round/>
+                      <a:headEnd type="none" w="med" len="med"/>
+                      <a:tailEnd type="none" w="med" len="med"/>
+                    </a:lnL>
+                    <a:lnR w="6350" cap="flat" cmpd="sng" algn="ctr">
+                      <a:solidFill>
+                        <a:srgbClr val="D8DFE9"/>
+                      </a:solidFill>
+                      <a:prstDash val="solid"/>
+                      <a:round/>
+                      <a:headEnd type="none" w="med" len="med"/>
+                      <a:tailEnd type="none" w="med" len="med"/>
+                    </a:lnR>
+                    <a:lnT w="6350" cap="flat" cmpd="sng" algn="ctr">
+                      <a:solidFill>
+                        <a:srgbClr val="D8DFE9"/>
+                      </a:solidFill>
+                      <a:prstDash val="solid"/>
+                      <a:round/>
+                      <a:headEnd type="none" w="med" len="med"/>
+                      <a:tailEnd type="none" w="med" len="med"/>
+                    </a:lnT>
+                    <a:lnB w="6350" cap="flat" cmpd="sng" algn="ctr">
+                      <a:solidFill>
+                        <a:srgbClr val="D8DFE9"/>
+                      </a:solidFill>
+                      <a:prstDash val="solid"/>
+                      <a:round/>
+                      <a:headEnd type="none" w="med" len="med"/>
+                      <a:tailEnd type="none" w="med" len="med"/>
+                    </a:lnB>
+                    <a:solidFill>
+                      <a:srgbClr val="F1F4F9"/>
+                    </a:solidFill>
+                  </a:tcPr>
+                </a:tc>
+                <a:tc>
+                  <a:txBody>
+                    <a:bodyPr/>
+                    <a:lstStyle/>
+                    <a:p>
+                      <a:pPr algn="r" indent="0" marL="0">
+                        <a:buNone/>
+                      </a:pPr>
+                      <a:r>
+                        <a:rPr lang="en-US" sz="950" dirty="0">
+                          <a:solidFill>
+                            <a:srgbClr val="16233D"/>
+                          </a:solidFill>
+                          <a:latin typeface="Graphik TH" pitchFamily="34" charset="0"/>
+                          <a:ea typeface="Graphik TH" pitchFamily="34" charset="-122"/>
+                          <a:cs typeface="Graphik TH" pitchFamily="34" charset="-120"/>
+                        </a:rPr>
+                        <a:t>41.2</a:t>
+                      </a:r>
+                      <a:endParaRPr lang="en-US" sz="950" dirty="0">
+                        <a:latin typeface="Graphik TH" charset="0"/>
+                        <a:ea typeface="Graphik TH" charset="0"/>
+                        <a:cs typeface="Graphik TH" charset="0"/>
+                      </a:endParaRPr>
+                    </a:p>
+                  </a:txBody>
+                  <a:tcPr marL="73152" marR="73152" marT="18288" marB="18288" anchor="ctr">
+                    <a:lnL w="6350" cap="flat" cmpd="sng" algn="ctr">
+                      <a:solidFill>
+                        <a:srgbClr val="D8DFE9"/>
+                      </a:solidFill>
+                      <a:prstDash val="solid"/>
+                      <a:round/>
+                      <a:headEnd type="none" w="med" len="med"/>
+                      <a:tailEnd type="none" w="med" len="med"/>
+                    </a:lnL>
+                    <a:lnR w="6350" cap="flat" cmpd="sng" algn="ctr">
+                      <a:solidFill>
+                        <a:srgbClr val="D8DFE9"/>
+                      </a:solidFill>
+                      <a:prstDash val="solid"/>
+                      <a:round/>
+                      <a:headEnd type="none" w="med" len="med"/>
+                      <a:tailEnd type="none" w="med" len="med"/>
+                    </a:lnR>
+                    <a:lnT w="6350" cap="flat" cmpd="sng" algn="ctr">
+                      <a:solidFill>
+                        <a:srgbClr val="D8DFE9"/>
+                      </a:solidFill>
+                      <a:prstDash val="solid"/>
+                      <a:round/>
+                      <a:headEnd type="none" w="med" len="med"/>
+                      <a:tailEnd type="none" w="med" len="med"/>
+                    </a:lnT>
+                    <a:lnB w="6350" cap="flat" cmpd="sng" algn="ctr">
+                      <a:solidFill>
+                        <a:srgbClr val="D8DFE9"/>
+                      </a:solidFill>
+                      <a:prstDash val="solid"/>
+                      <a:round/>
+                      <a:headEnd type="none" w="med" len="med"/>
+                      <a:tailEnd type="none" w="med" len="med"/>
+                    </a:lnB>
+                    <a:solidFill>
+                      <a:srgbClr val="FFFFFF"/>
+                    </a:solidFill>
+                  </a:tcPr>
+                </a:tc>
+                <a:tc>
+                  <a:txBody>
+                    <a:bodyPr/>
+                    <a:lstStyle/>
+                    <a:p>
+                      <a:pPr algn="r" indent="0" marL="0">
+                        <a:buNone/>
+                      </a:pPr>
+                      <a:r>
+                        <a:rPr lang="en-US" sz="950" dirty="0">
+                          <a:solidFill>
+                            <a:srgbClr val="16233D"/>
+                          </a:solidFill>
+                          <a:latin typeface="Graphik TH" pitchFamily="34" charset="0"/>
+                          <a:ea typeface="Graphik TH" pitchFamily="34" charset="-122"/>
+                          <a:cs typeface="Graphik TH" pitchFamily="34" charset="-120"/>
+                        </a:rPr>
+                        <a:t>74.0</a:t>
+                      </a:r>
+                      <a:endParaRPr lang="en-US" sz="950" dirty="0">
+                        <a:latin typeface="Graphik TH" charset="0"/>
+                        <a:ea typeface="Graphik TH" charset="0"/>
+                        <a:cs typeface="Graphik TH" charset="0"/>
+                      </a:endParaRPr>
+                    </a:p>
+                  </a:txBody>
+                  <a:tcPr marL="73152" marR="73152" marT="18288" marB="18288" anchor="ctr">
+                    <a:lnL w="6350" cap="flat" cmpd="sng" algn="ctr">
+                      <a:solidFill>
+                        <a:srgbClr val="D8DFE9"/>
+                      </a:solidFill>
+                      <a:prstDash val="solid"/>
+                      <a:round/>
+                      <a:headEnd type="none" w="med" len="med"/>
+                      <a:tailEnd type="none" w="med" len="med"/>
+                    </a:lnL>
+                    <a:lnR w="6350" cap="flat" cmpd="sng" algn="ctr">
+                      <a:solidFill>
+                        <a:srgbClr val="D8DFE9"/>
+                      </a:solidFill>
+                      <a:prstDash val="solid"/>
+                      <a:round/>
+                      <a:headEnd type="none" w="med" len="med"/>
+                      <a:tailEnd type="none" w="med" len="med"/>
+                    </a:lnR>
+                    <a:lnT w="6350" cap="flat" cmpd="sng" algn="ctr">
+                      <a:solidFill>
+                        <a:srgbClr val="D8DFE9"/>
+                      </a:solidFill>
+                      <a:prstDash val="solid"/>
+                      <a:round/>
+                      <a:headEnd type="none" w="med" len="med"/>
+                      <a:tailEnd type="none" w="med" len="med"/>
+                    </a:lnT>
+                    <a:lnB w="6350" cap="flat" cmpd="sng" algn="ctr">
+                      <a:solidFill>
+                        <a:srgbClr val="D8DFE9"/>
+                      </a:solidFill>
+                      <a:prstDash val="solid"/>
+                      <a:round/>
+                      <a:headEnd type="none" w="med" len="med"/>
+                      <a:tailEnd type="none" w="med" len="med"/>
+                    </a:lnB>
+                    <a:solidFill>
+                      <a:srgbClr val="FFFFFF"/>
+                    </a:solidFill>
+                  </a:tcPr>
+                </a:tc>
+                <a:tc>
+                  <a:txBody>
+                    <a:bodyPr/>
+                    <a:lstStyle/>
+                    <a:p>
+                      <a:pPr algn="r" indent="0" marL="0">
+                        <a:buNone/>
+                      </a:pPr>
+                      <a:r>
+                        <a:rPr lang="en-US" sz="950" dirty="0">
+                          <a:solidFill>
+                            <a:srgbClr val="16233D"/>
+                          </a:solidFill>
+                          <a:latin typeface="Graphik TH" pitchFamily="34" charset="0"/>
+                          <a:ea typeface="Graphik TH" pitchFamily="34" charset="-122"/>
+                          <a:cs typeface="Graphik TH" pitchFamily="34" charset="-120"/>
+                        </a:rPr>
+                        <a:t>0.0</a:t>
+                      </a:r>
+                      <a:endParaRPr lang="en-US" sz="950" dirty="0">
+                        <a:latin typeface="Graphik TH" charset="0"/>
+                        <a:ea typeface="Graphik TH" charset="0"/>
+                        <a:cs typeface="Graphik TH" charset="0"/>
+                      </a:endParaRPr>
+                    </a:p>
+                  </a:txBody>
+                  <a:tcPr marL="73152" marR="73152" marT="18288" marB="18288" anchor="ctr">
+                    <a:lnL w="6350" cap="flat" cmpd="sng" algn="ctr">
+                      <a:solidFill>
+                        <a:srgbClr val="D8DFE9"/>
+                      </a:solidFill>
+                      <a:prstDash val="solid"/>
+                      <a:round/>
+                      <a:headEnd type="none" w="med" len="med"/>
+                      <a:tailEnd type="none" w="med" len="med"/>
+                    </a:lnL>
+                    <a:lnR w="6350" cap="flat" cmpd="sng" algn="ctr">
+                      <a:solidFill>
+                        <a:srgbClr val="D8DFE9"/>
+                      </a:solidFill>
+                      <a:prstDash val="solid"/>
+                      <a:round/>
+                      <a:headEnd type="none" w="med" len="med"/>
+                      <a:tailEnd type="none" w="med" len="med"/>
+                    </a:lnR>
+                    <a:lnT w="6350" cap="flat" cmpd="sng" algn="ctr">
+                      <a:solidFill>
+                        <a:srgbClr val="D8DFE9"/>
+                      </a:solidFill>
+                      <a:prstDash val="solid"/>
+                      <a:round/>
+                      <a:headEnd type="none" w="med" len="med"/>
+                      <a:tailEnd type="none" w="med" len="med"/>
+                    </a:lnT>
+                    <a:lnB w="6350" cap="flat" cmpd="sng" algn="ctr">
+                      <a:solidFill>
+                        <a:srgbClr val="D8DFE9"/>
+                      </a:solidFill>
+                      <a:prstDash val="solid"/>
+                      <a:round/>
+                      <a:headEnd type="none" w="med" len="med"/>
+                      <a:tailEnd type="none" w="med" len="med"/>
+                    </a:lnB>
+                    <a:solidFill>
+                      <a:srgbClr val="FFFFFF"/>
+                    </a:solidFill>
+                  </a:tcPr>
+                </a:tc>
+                <a:tc>
+                  <a:txBody>
+                    <a:bodyPr/>
+                    <a:lstStyle/>
+                    <a:p>
+                      <a:pPr algn="r" indent="0" marL="0">
+                        <a:buNone/>
+                      </a:pPr>
+                      <a:r>
+                        <a:rPr lang="en-US" sz="950" b="1" dirty="0">
+                          <a:solidFill>
+                            <a:srgbClr val="C00000"/>
+                          </a:solidFill>
+                          <a:latin typeface="Graphik TH" pitchFamily="34" charset="0"/>
+                          <a:ea typeface="Graphik TH" pitchFamily="34" charset="-122"/>
+                          <a:cs typeface="Graphik TH" pitchFamily="34" charset="-120"/>
+                        </a:rPr>
+                        <a:t>11.1</a:t>
+                      </a:r>
+                      <a:endParaRPr lang="en-US" sz="950" dirty="0">
+                        <a:latin typeface="Graphik TH" charset="0"/>
+                        <a:ea typeface="Graphik TH" charset="0"/>
+                        <a:cs typeface="Graphik TH" charset="0"/>
+                      </a:endParaRPr>
+                    </a:p>
+                  </a:txBody>
+                  <a:tcPr marL="73152" marR="73152" marT="18288" marB="18288" anchor="ctr">
+                    <a:lnL w="6350" cap="flat" cmpd="sng" algn="ctr">
+                      <a:solidFill>
+                        <a:srgbClr val="D8DFE9"/>
+                      </a:solidFill>
+                      <a:prstDash val="solid"/>
+                      <a:round/>
+                      <a:headEnd type="none" w="med" len="med"/>
+                      <a:tailEnd type="none" w="med" len="med"/>
+                    </a:lnL>
+                    <a:lnR w="6350" cap="flat" cmpd="sng" algn="ctr">
+                      <a:solidFill>
+                        <a:srgbClr val="D8DFE9"/>
+                      </a:solidFill>
+                      <a:prstDash val="solid"/>
+                      <a:round/>
+                      <a:headEnd type="none" w="med" len="med"/>
+                      <a:tailEnd type="none" w="med" len="med"/>
+                    </a:lnR>
+                    <a:lnT w="6350" cap="flat" cmpd="sng" algn="ctr">
+                      <a:solidFill>
+                        <a:srgbClr val="D8DFE9"/>
+                      </a:solidFill>
+                      <a:prstDash val="solid"/>
+                      <a:round/>
+                      <a:headEnd type="none" w="med" len="med"/>
+                      <a:tailEnd type="none" w="med" len="med"/>
+                    </a:lnT>
+                    <a:lnB w="6350" cap="flat" cmpd="sng" algn="ctr">
+                      <a:solidFill>
+                        <a:srgbClr val="D8DFE9"/>
+                      </a:solidFill>
+                      <a:prstDash val="solid"/>
+                      <a:round/>
+                      <a:headEnd type="none" w="med" len="med"/>
+                      <a:tailEnd type="none" w="med" len="med"/>
+                    </a:lnB>
+                    <a:solidFill>
+                      <a:srgbClr val="F7DEDE"/>
+                    </a:solidFill>
+                  </a:tcPr>
+                </a:tc>
+                <a:tc>
+                  <a:txBody>
+                    <a:bodyPr/>
+                    <a:lstStyle/>
+                    <a:p>
+                      <a:pPr algn="r" indent="0" marL="0">
+                        <a:buNone/>
+                      </a:pPr>
+                      <a:r>
+                        <a:rPr lang="en-US" sz="950" b="1" dirty="0">
+                          <a:solidFill>
+                            <a:srgbClr val="C00000"/>
+                          </a:solidFill>
+                          <a:latin typeface="Graphik TH" pitchFamily="34" charset="0"/>
+                          <a:ea typeface="Graphik TH" pitchFamily="34" charset="-122"/>
+                          <a:cs typeface="Graphik TH" pitchFamily="34" charset="-120"/>
+                        </a:rPr>
+                        <a:t>85.1</a:t>
+                      </a:r>
+                      <a:endParaRPr lang="en-US" sz="950" dirty="0">
+                        <a:latin typeface="Graphik TH" charset="0"/>
+                        <a:ea typeface="Graphik TH" charset="0"/>
+                        <a:cs typeface="Graphik TH" charset="0"/>
+                      </a:endParaRPr>
+                    </a:p>
+                  </a:txBody>
+                  <a:tcPr marL="73152" marR="73152" marT="18288" marB="18288" anchor="ctr">
+                    <a:lnL w="6350" cap="flat" cmpd="sng" algn="ctr">
+                      <a:solidFill>
+                        <a:srgbClr val="D8DFE9"/>
+                      </a:solidFill>
+                      <a:prstDash val="solid"/>
+                      <a:round/>
+                      <a:headEnd type="none" w="med" len="med"/>
+                      <a:tailEnd type="none" w="med" len="med"/>
+                    </a:lnL>
+                    <a:lnR w="6350" cap="flat" cmpd="sng" algn="ctr">
+                      <a:solidFill>
+                        <a:srgbClr val="D8DFE9"/>
+                      </a:solidFill>
+                      <a:prstDash val="solid"/>
+                      <a:round/>
+                      <a:headEnd type="none" w="med" len="med"/>
+                      <a:tailEnd type="none" w="med" len="med"/>
+                    </a:lnR>
+                    <a:lnT w="6350" cap="flat" cmpd="sng" algn="ctr">
+                      <a:solidFill>
+                        <a:srgbClr val="D8DFE9"/>
+                      </a:solidFill>
+                      <a:prstDash val="solid"/>
+                      <a:round/>
+                      <a:headEnd type="none" w="med" len="med"/>
+                      <a:tailEnd type="none" w="med" len="med"/>
+                    </a:lnT>
+                    <a:lnB w="6350" cap="flat" cmpd="sng" algn="ctr">
+                      <a:solidFill>
+                        <a:srgbClr val="D8DFE9"/>
+                      </a:solidFill>
+                      <a:prstDash val="solid"/>
+                      <a:round/>
+                      <a:headEnd type="none" w="med" len="med"/>
+                      <a:tailEnd type="none" w="med" len="med"/>
+                    </a:lnB>
+                    <a:solidFill>
+                      <a:srgbClr val="F7DEDE"/>
+                    </a:solidFill>
+                  </a:tcPr>
+                </a:tc>
+              </a:tr>
+              <a:tr h="274320">
+                <a:tc>
+                  <a:txBody>
+                    <a:bodyPr/>
+                    <a:lstStyle/>
+                    <a:p>
+                      <a:pPr algn="l" indent="0" marL="0">
+                        <a:buNone/>
+                      </a:pPr>
+                      <a:r>
+                        <a:rPr lang="en-US" sz="950" b="1" dirty="0">
+                          <a:solidFill>
+                            <a:srgbClr val="16233D"/>
+                          </a:solidFill>
+                          <a:latin typeface="Graphik TH" pitchFamily="34" charset="0"/>
+                          <a:ea typeface="Graphik TH" pitchFamily="34" charset="-122"/>
+                          <a:cs typeface="Graphik TH" pitchFamily="34" charset="-120"/>
+                        </a:rPr>
+                        <a:t>Low</a:t>
+                      </a:r>
+                      <a:endParaRPr lang="en-US" sz="950" dirty="0">
+                        <a:latin typeface="Graphik TH" charset="0"/>
+                        <a:ea typeface="Graphik TH" charset="0"/>
+                        <a:cs typeface="Graphik TH" charset="0"/>
+                      </a:endParaRPr>
+                    </a:p>
+                  </a:txBody>
+                  <a:tcPr marL="73152" marR="73152" marT="18288" marB="18288" anchor="ctr">
+                    <a:lnL w="6350" cap="flat" cmpd="sng" algn="ctr">
+                      <a:solidFill>
+                        <a:srgbClr val="D8DFE9"/>
+                      </a:solidFill>
+                      <a:prstDash val="solid"/>
+                      <a:round/>
+                      <a:headEnd type="none" w="med" len="med"/>
+                      <a:tailEnd type="none" w="med" len="med"/>
+                    </a:lnL>
+                    <a:lnR w="6350" cap="flat" cmpd="sng" algn="ctr">
+                      <a:solidFill>
+                        <a:srgbClr val="D8DFE9"/>
+                      </a:solidFill>
+                      <a:prstDash val="solid"/>
+                      <a:round/>
+                      <a:headEnd type="none" w="med" len="med"/>
+                      <a:tailEnd type="none" w="med" len="med"/>
+                    </a:lnR>
+                    <a:lnT w="6350" cap="flat" cmpd="sng" algn="ctr">
+                      <a:solidFill>
+                        <a:srgbClr val="D8DFE9"/>
+                      </a:solidFill>
+                      <a:prstDash val="solid"/>
+                      <a:round/>
+                      <a:headEnd type="none" w="med" len="med"/>
+                      <a:tailEnd type="none" w="med" len="med"/>
+                    </a:lnT>
+                    <a:lnB w="6350" cap="flat" cmpd="sng" algn="ctr">
+                      <a:solidFill>
+                        <a:srgbClr val="D8DFE9"/>
+                      </a:solidFill>
+                      <a:prstDash val="solid"/>
+                      <a:round/>
+                      <a:headEnd type="none" w="med" len="med"/>
+                      <a:tailEnd type="none" w="med" len="med"/>
+                    </a:lnB>
+                    <a:solidFill>
+                      <a:srgbClr val="F1F4F9"/>
+                    </a:solidFill>
+                  </a:tcPr>
+                </a:tc>
+                <a:tc>
+                  <a:txBody>
+                    <a:bodyPr/>
+                    <a:lstStyle/>
+                    <a:p>
+                      <a:pPr algn="r" indent="0" marL="0">
+                        <a:buNone/>
+                      </a:pPr>
+                      <a:r>
+                        <a:rPr lang="en-US" sz="950" dirty="0">
+                          <a:solidFill>
+                            <a:srgbClr val="16233D"/>
+                          </a:solidFill>
+                          <a:latin typeface="Graphik TH" pitchFamily="34" charset="0"/>
+                          <a:ea typeface="Graphik TH" pitchFamily="34" charset="-122"/>
+                          <a:cs typeface="Graphik TH" pitchFamily="34" charset="-120"/>
+                        </a:rPr>
+                        <a:t>6.0</a:t>
+                      </a:r>
+                      <a:endParaRPr lang="en-US" sz="950" dirty="0">
+                        <a:latin typeface="Graphik TH" charset="0"/>
+                        <a:ea typeface="Graphik TH" charset="0"/>
+                        <a:cs typeface="Graphik TH" charset="0"/>
+                      </a:endParaRPr>
+                    </a:p>
+                  </a:txBody>
+                  <a:tcPr marL="73152" marR="73152" marT="18288" marB="18288" anchor="ctr">
+                    <a:lnL w="6350" cap="flat" cmpd="sng" algn="ctr">
+                      <a:solidFill>
+                        <a:srgbClr val="D8DFE9"/>
+                      </a:solidFill>
+                      <a:prstDash val="solid"/>
+                      <a:round/>
+                      <a:headEnd type="none" w="med" len="med"/>
+                      <a:tailEnd type="none" w="med" len="med"/>
+                    </a:lnL>
+                    <a:lnR w="6350" cap="flat" cmpd="sng" algn="ctr">
+                      <a:solidFill>
+                        <a:srgbClr val="D8DFE9"/>
+                      </a:solidFill>
+                      <a:prstDash val="solid"/>
+                      <a:round/>
+                      <a:headEnd type="none" w="med" len="med"/>
+                      <a:tailEnd type="none" w="med" len="med"/>
+                    </a:lnR>
+                    <a:lnT w="6350" cap="flat" cmpd="sng" algn="ctr">
+                      <a:solidFill>
+                        <a:srgbClr val="D8DFE9"/>
+                      </a:solidFill>
+                      <a:prstDash val="solid"/>
+                      <a:round/>
+                      <a:headEnd type="none" w="med" len="med"/>
+                      <a:tailEnd type="none" w="med" len="med"/>
+                    </a:lnT>
+                    <a:lnB w="6350" cap="flat" cmpd="sng" algn="ctr">
+                      <a:solidFill>
+                        <a:srgbClr val="D8DFE9"/>
+                      </a:solidFill>
+                      <a:prstDash val="solid"/>
+                      <a:round/>
+                      <a:headEnd type="none" w="med" len="med"/>
+                      <a:tailEnd type="none" w="med" len="med"/>
+                    </a:lnB>
+                    <a:solidFill>
+                      <a:srgbClr val="FFFFFF"/>
+                    </a:solidFill>
+                  </a:tcPr>
+                </a:tc>
+                <a:tc>
+                  <a:txBody>
+                    <a:bodyPr/>
+                    <a:lstStyle/>
+                    <a:p>
+                      <a:pPr algn="r" indent="0" marL="0">
+                        <a:buNone/>
+                      </a:pPr>
+                      <a:r>
+                        <a:rPr lang="en-US" sz="950" dirty="0">
+                          <a:solidFill>
+                            <a:srgbClr val="16233D"/>
+                          </a:solidFill>
+                          <a:latin typeface="Graphik TH" pitchFamily="34" charset="0"/>
+                          <a:ea typeface="Graphik TH" pitchFamily="34" charset="-122"/>
+                          <a:cs typeface="Graphik TH" pitchFamily="34" charset="-120"/>
+                        </a:rPr>
+                        <a:t>4.0</a:t>
+                      </a:r>
+                      <a:endParaRPr lang="en-US" sz="950" dirty="0">
+                        <a:latin typeface="Graphik TH" charset="0"/>
+                        <a:ea typeface="Graphik TH" charset="0"/>
+                        <a:cs typeface="Graphik TH" charset="0"/>
+                      </a:endParaRPr>
+                    </a:p>
+                  </a:txBody>
+                  <a:tcPr marL="73152" marR="73152" marT="18288" marB="18288" anchor="ctr">
+                    <a:lnL w="6350" cap="flat" cmpd="sng" algn="ctr">
+                      <a:solidFill>
+                        <a:srgbClr val="D8DFE9"/>
+                      </a:solidFill>
+                      <a:prstDash val="solid"/>
+                      <a:round/>
+                      <a:headEnd type="none" w="med" len="med"/>
+                      <a:tailEnd type="none" w="med" len="med"/>
+                    </a:lnL>
+                    <a:lnR w="6350" cap="flat" cmpd="sng" algn="ctr">
+                      <a:solidFill>
+                        <a:srgbClr val="D8DFE9"/>
+                      </a:solidFill>
+                      <a:prstDash val="solid"/>
+                      <a:round/>
+                      <a:headEnd type="none" w="med" len="med"/>
+                      <a:tailEnd type="none" w="med" len="med"/>
+                    </a:lnR>
+                    <a:lnT w="6350" cap="flat" cmpd="sng" algn="ctr">
+                      <a:solidFill>
+                        <a:srgbClr val="D8DFE9"/>
+                      </a:solidFill>
+                      <a:prstDash val="solid"/>
+                      <a:round/>
+                      <a:headEnd type="none" w="med" len="med"/>
+                      <a:tailEnd type="none" w="med" len="med"/>
+                    </a:lnT>
+                    <a:lnB w="6350" cap="flat" cmpd="sng" algn="ctr">
+                      <a:solidFill>
+                        <a:srgbClr val="D8DFE9"/>
+                      </a:solidFill>
+                      <a:prstDash val="solid"/>
+                      <a:round/>
+                      <a:headEnd type="none" w="med" len="med"/>
+                      <a:tailEnd type="none" w="med" len="med"/>
+                    </a:lnB>
+                    <a:solidFill>
+                      <a:srgbClr val="FFFFFF"/>
+                    </a:solidFill>
+                  </a:tcPr>
+                </a:tc>
+                <a:tc>
+                  <a:txBody>
+                    <a:bodyPr/>
+                    <a:lstStyle/>
+                    <a:p>
+                      <a:pPr algn="r" indent="0" marL="0">
+                        <a:buNone/>
+                      </a:pPr>
+                      <a:r>
+                        <a:rPr lang="en-US" sz="950" dirty="0">
+                          <a:solidFill>
+                            <a:srgbClr val="16233D"/>
+                          </a:solidFill>
+                          <a:latin typeface="Graphik TH" pitchFamily="34" charset="0"/>
+                          <a:ea typeface="Graphik TH" pitchFamily="34" charset="-122"/>
+                          <a:cs typeface="Graphik TH" pitchFamily="34" charset="-120"/>
+                        </a:rPr>
+                        <a:t>0.0</a:t>
+                      </a:r>
+                      <a:endParaRPr lang="en-US" sz="950" dirty="0">
+                        <a:latin typeface="Graphik TH" charset="0"/>
+                        <a:ea typeface="Graphik TH" charset="0"/>
+                        <a:cs typeface="Graphik TH" charset="0"/>
+                      </a:endParaRPr>
+                    </a:p>
+                  </a:txBody>
+                  <a:tcPr marL="73152" marR="73152" marT="18288" marB="18288" anchor="ctr">
+                    <a:lnL w="6350" cap="flat" cmpd="sng" algn="ctr">
+                      <a:solidFill>
+                        <a:srgbClr val="D8DFE9"/>
+                      </a:solidFill>
+                      <a:prstDash val="solid"/>
+                      <a:round/>
+                      <a:headEnd type="none" w="med" len="med"/>
+                      <a:tailEnd type="none" w="med" len="med"/>
+                    </a:lnL>
+                    <a:lnR w="6350" cap="flat" cmpd="sng" algn="ctr">
+                      <a:solidFill>
+                        <a:srgbClr val="D8DFE9"/>
+                      </a:solidFill>
+                      <a:prstDash val="solid"/>
+                      <a:round/>
+                      <a:headEnd type="none" w="med" len="med"/>
+                      <a:tailEnd type="none" w="med" len="med"/>
+                    </a:lnR>
+                    <a:lnT w="6350" cap="flat" cmpd="sng" algn="ctr">
+                      <a:solidFill>
+                        <a:srgbClr val="D8DFE9"/>
+                      </a:solidFill>
+                      <a:prstDash val="solid"/>
+                      <a:round/>
+                      <a:headEnd type="none" w="med" len="med"/>
+                      <a:tailEnd type="none" w="med" len="med"/>
+                    </a:lnT>
+                    <a:lnB w="6350" cap="flat" cmpd="sng" algn="ctr">
+                      <a:solidFill>
+                        <a:srgbClr val="D8DFE9"/>
+                      </a:solidFill>
+                      <a:prstDash val="solid"/>
+                      <a:round/>
+                      <a:headEnd type="none" w="med" len="med"/>
+                      <a:tailEnd type="none" w="med" len="med"/>
+                    </a:lnB>
+                    <a:solidFill>
+                      <a:srgbClr val="FFFFFF"/>
+                    </a:solidFill>
+                  </a:tcPr>
+                </a:tc>
+                <a:tc>
+                  <a:txBody>
+                    <a:bodyPr/>
+                    <a:lstStyle/>
+                    <a:p>
+                      <a:pPr algn="r" indent="0" marL="0">
+                        <a:buNone/>
+                      </a:pPr>
+                      <a:r>
+                        <a:rPr lang="en-US" sz="950" b="1" dirty="0">
+                          <a:solidFill>
+                            <a:srgbClr val="C00000"/>
+                          </a:solidFill>
+                          <a:latin typeface="Graphik TH" pitchFamily="34" charset="0"/>
+                          <a:ea typeface="Graphik TH" pitchFamily="34" charset="-122"/>
+                          <a:cs typeface="Graphik TH" pitchFamily="34" charset="-120"/>
+                        </a:rPr>
+                        <a:t>0.0</a:t>
+                      </a:r>
+                      <a:endParaRPr lang="en-US" sz="950" dirty="0">
+                        <a:latin typeface="Graphik TH" charset="0"/>
+                        <a:ea typeface="Graphik TH" charset="0"/>
+                        <a:cs typeface="Graphik TH" charset="0"/>
+                      </a:endParaRPr>
+                    </a:p>
+                  </a:txBody>
+                  <a:tcPr marL="73152" marR="73152" marT="18288" marB="18288" anchor="ctr">
+                    <a:lnL w="6350" cap="flat" cmpd="sng" algn="ctr">
+                      <a:solidFill>
+                        <a:srgbClr val="D8DFE9"/>
+                      </a:solidFill>
+                      <a:prstDash val="solid"/>
+                      <a:round/>
+                      <a:headEnd type="none" w="med" len="med"/>
+                      <a:tailEnd type="none" w="med" len="med"/>
+                    </a:lnL>
+                    <a:lnR w="6350" cap="flat" cmpd="sng" algn="ctr">
+                      <a:solidFill>
+                        <a:srgbClr val="D8DFE9"/>
+                      </a:solidFill>
+                      <a:prstDash val="solid"/>
+                      <a:round/>
+                      <a:headEnd type="none" w="med" len="med"/>
+                      <a:tailEnd type="none" w="med" len="med"/>
+                    </a:lnR>
+                    <a:lnT w="6350" cap="flat" cmpd="sng" algn="ctr">
+                      <a:solidFill>
+                        <a:srgbClr val="D8DFE9"/>
+                      </a:solidFill>
+                      <a:prstDash val="solid"/>
+                      <a:round/>
+                      <a:headEnd type="none" w="med" len="med"/>
+                      <a:tailEnd type="none" w="med" len="med"/>
+                    </a:lnT>
+                    <a:lnB w="6350" cap="flat" cmpd="sng" algn="ctr">
+                      <a:solidFill>
+                        <a:srgbClr val="D8DFE9"/>
+                      </a:solidFill>
+                      <a:prstDash val="solid"/>
+                      <a:round/>
+                      <a:headEnd type="none" w="med" len="med"/>
+                      <a:tailEnd type="none" w="med" len="med"/>
+                    </a:lnB>
+                    <a:solidFill>
+                      <a:srgbClr val="F7DEDE"/>
+                    </a:solidFill>
+                  </a:tcPr>
+                </a:tc>
+                <a:tc>
+                  <a:txBody>
+                    <a:bodyPr/>
+                    <a:lstStyle/>
+                    <a:p>
+                      <a:pPr algn="r" indent="0" marL="0">
+                        <a:buNone/>
+                      </a:pPr>
+                      <a:r>
+                        <a:rPr lang="en-US" sz="950" b="1" dirty="0">
+                          <a:solidFill>
+                            <a:srgbClr val="C00000"/>
+                          </a:solidFill>
+                          <a:latin typeface="Graphik TH" pitchFamily="34" charset="0"/>
+                          <a:ea typeface="Graphik TH" pitchFamily="34" charset="-122"/>
+                          <a:cs typeface="Graphik TH" pitchFamily="34" charset="-120"/>
+                        </a:rPr>
+                        <a:t>1.2</a:t>
+                      </a:r>
+                      <a:endParaRPr lang="en-US" sz="950" dirty="0">
+                        <a:latin typeface="Graphik TH" charset="0"/>
+                        <a:ea typeface="Graphik TH" charset="0"/>
+                        <a:cs typeface="Graphik TH" charset="0"/>
+                      </a:endParaRPr>
+                    </a:p>
+                  </a:txBody>
+                  <a:tcPr marL="73152" marR="73152" marT="18288" marB="18288" anchor="ctr">
+                    <a:lnL w="6350" cap="flat" cmpd="sng" algn="ctr">
+                      <a:solidFill>
+                        <a:srgbClr val="D8DFE9"/>
+                      </a:solidFill>
+                      <a:prstDash val="solid"/>
+                      <a:round/>
+                      <a:headEnd type="none" w="med" len="med"/>
+                      <a:tailEnd type="none" w="med" len="med"/>
+                    </a:lnL>
+                    <a:lnR w="6350" cap="flat" cmpd="sng" algn="ctr">
+                      <a:solidFill>
+                        <a:srgbClr val="D8DFE9"/>
+                      </a:solidFill>
+                      <a:prstDash val="solid"/>
+                      <a:round/>
+                      <a:headEnd type="none" w="med" len="med"/>
+                      <a:tailEnd type="none" w="med" len="med"/>
+                    </a:lnR>
+                    <a:lnT w="6350" cap="flat" cmpd="sng" algn="ctr">
+                      <a:solidFill>
+                        <a:srgbClr val="D8DFE9"/>
+                      </a:solidFill>
+                      <a:prstDash val="solid"/>
+                      <a:round/>
+                      <a:headEnd type="none" w="med" len="med"/>
+                      <a:tailEnd type="none" w="med" len="med"/>
+                    </a:lnT>
+                    <a:lnB w="6350" cap="flat" cmpd="sng" algn="ctr">
+                      <a:solidFill>
+                        <a:srgbClr val="D8DFE9"/>
+                      </a:solidFill>
+                      <a:prstDash val="solid"/>
+                      <a:round/>
+                      <a:headEnd type="none" w="med" len="med"/>
+                      <a:tailEnd type="none" w="med" len="med"/>
+                    </a:lnB>
+                    <a:solidFill>
+                      <a:srgbClr val="F7DEDE"/>
+                    </a:solidFill>
+                  </a:tcPr>
+                </a:tc>
+              </a:tr>
+              <a:tr h="274320">
+                <a:tc>
+                  <a:txBody>
+                    <a:bodyPr/>
+                    <a:lstStyle/>
+                    <a:p>
+                      <a:pPr algn="l" indent="0" marL="0">
+                        <a:buNone/>
+                      </a:pPr>
+                      <a:r>
+                        <a:rPr lang="en-US" sz="950" b="1" dirty="0">
+                          <a:solidFill>
+                            <a:srgbClr val="16233D"/>
+                          </a:solidFill>
+                          <a:latin typeface="Graphik TH" pitchFamily="34" charset="0"/>
+                          <a:ea typeface="Graphik TH" pitchFamily="34" charset="-122"/>
+                          <a:cs typeface="Graphik TH" pitchFamily="34" charset="-120"/>
+                        </a:rPr>
+                        <a:t>Very Low</a:t>
+                      </a:r>
+                      <a:endParaRPr lang="en-US" sz="950" dirty="0">
+                        <a:latin typeface="Graphik TH" charset="0"/>
+                        <a:ea typeface="Graphik TH" charset="0"/>
+                        <a:cs typeface="Graphik TH" charset="0"/>
+                      </a:endParaRPr>
+                    </a:p>
+                  </a:txBody>
+                  <a:tcPr marL="73152" marR="73152" marT="18288" marB="18288" anchor="ctr">
+                    <a:lnL w="6350" cap="flat" cmpd="sng" algn="ctr">
+                      <a:solidFill>
+                        <a:srgbClr val="D8DFE9"/>
+                      </a:solidFill>
+                      <a:prstDash val="solid"/>
+                      <a:round/>
+                      <a:headEnd type="none" w="med" len="med"/>
+                      <a:tailEnd type="none" w="med" len="med"/>
+                    </a:lnL>
+                    <a:lnR w="6350" cap="flat" cmpd="sng" algn="ctr">
+                      <a:solidFill>
+                        <a:srgbClr val="D8DFE9"/>
+                      </a:solidFill>
+                      <a:prstDash val="solid"/>
+                      <a:round/>
+                      <a:headEnd type="none" w="med" len="med"/>
+                      <a:tailEnd type="none" w="med" len="med"/>
+                    </a:lnR>
+                    <a:lnT w="6350" cap="flat" cmpd="sng" algn="ctr">
+                      <a:solidFill>
+                        <a:srgbClr val="D8DFE9"/>
+                      </a:solidFill>
+                      <a:prstDash val="solid"/>
+                      <a:round/>
+                      <a:headEnd type="none" w="med" len="med"/>
+                      <a:tailEnd type="none" w="med" len="med"/>
+                    </a:lnT>
+                    <a:lnB w="6350" cap="flat" cmpd="sng" algn="ctr">
+                      <a:solidFill>
+                        <a:srgbClr val="D8DFE9"/>
+                      </a:solidFill>
+                      <a:prstDash val="solid"/>
+                      <a:round/>
+                      <a:headEnd type="none" w="med" len="med"/>
+                      <a:tailEnd type="none" w="med" len="med"/>
+                    </a:lnB>
+                    <a:solidFill>
+                      <a:srgbClr val="F1F4F9"/>
+                    </a:solidFill>
+                  </a:tcPr>
+                </a:tc>
+                <a:tc>
+                  <a:txBody>
+                    <a:bodyPr/>
+                    <a:lstStyle/>
+                    <a:p>
+                      <a:pPr algn="r" indent="0" marL="0">
+                        <a:buNone/>
+                      </a:pPr>
+                      <a:r>
+                        <a:rPr lang="en-US" sz="950" dirty="0">
+                          <a:solidFill>
+                            <a:srgbClr val="16233D"/>
+                          </a:solidFill>
+                          <a:latin typeface="Graphik TH" pitchFamily="34" charset="0"/>
+                          <a:ea typeface="Graphik TH" pitchFamily="34" charset="-122"/>
+                          <a:cs typeface="Graphik TH" pitchFamily="34" charset="-120"/>
+                        </a:rPr>
+                        <a:t>1.2</a:t>
+                      </a:r>
+                      <a:endParaRPr lang="en-US" sz="950" dirty="0">
+                        <a:latin typeface="Graphik TH" charset="0"/>
+                        <a:ea typeface="Graphik TH" charset="0"/>
+                        <a:cs typeface="Graphik TH" charset="0"/>
+                      </a:endParaRPr>
+                    </a:p>
+                  </a:txBody>
+                  <a:tcPr marL="73152" marR="73152" marT="18288" marB="18288" anchor="ctr">
+                    <a:lnL w="6350" cap="flat" cmpd="sng" algn="ctr">
+                      <a:solidFill>
+                        <a:srgbClr val="D8DFE9"/>
+                      </a:solidFill>
+                      <a:prstDash val="solid"/>
+                      <a:round/>
+                      <a:headEnd type="none" w="med" len="med"/>
+                      <a:tailEnd type="none" w="med" len="med"/>
+                    </a:lnL>
+                    <a:lnR w="6350" cap="flat" cmpd="sng" algn="ctr">
+                      <a:solidFill>
+                        <a:srgbClr val="D8DFE9"/>
+                      </a:solidFill>
+                      <a:prstDash val="solid"/>
+                      <a:round/>
+                      <a:headEnd type="none" w="med" len="med"/>
+                      <a:tailEnd type="none" w="med" len="med"/>
+                    </a:lnR>
+                    <a:lnT w="6350" cap="flat" cmpd="sng" algn="ctr">
+                      <a:solidFill>
+                        <a:srgbClr val="D8DFE9"/>
+                      </a:solidFill>
+                      <a:prstDash val="solid"/>
+                      <a:round/>
+                      <a:headEnd type="none" w="med" len="med"/>
+                      <a:tailEnd type="none" w="med" len="med"/>
+                    </a:lnT>
+                    <a:lnB w="6350" cap="flat" cmpd="sng" algn="ctr">
+                      <a:solidFill>
+                        <a:srgbClr val="D8DFE9"/>
+                      </a:solidFill>
+                      <a:prstDash val="solid"/>
+                      <a:round/>
+                      <a:headEnd type="none" w="med" len="med"/>
+                      <a:tailEnd type="none" w="med" len="med"/>
+                    </a:lnB>
+                    <a:solidFill>
+                      <a:srgbClr val="FFFFFF"/>
+                    </a:solidFill>
+                  </a:tcPr>
+                </a:tc>
+                <a:tc>
+                  <a:txBody>
+                    <a:bodyPr/>
+                    <a:lstStyle/>
+                    <a:p>
+                      <a:pPr algn="r" indent="0" marL="0">
+                        <a:buNone/>
+                      </a:pPr>
+                      <a:r>
+                        <a:rPr lang="en-US" sz="950" dirty="0">
+                          <a:solidFill>
+                            <a:srgbClr val="16233D"/>
+                          </a:solidFill>
+                          <a:latin typeface="Graphik TH" pitchFamily="34" charset="0"/>
+                          <a:ea typeface="Graphik TH" pitchFamily="34" charset="-122"/>
+                          <a:cs typeface="Graphik TH" pitchFamily="34" charset="-120"/>
+                        </a:rPr>
+                        <a:t>2.2</a:t>
+                      </a:r>
+                      <a:endParaRPr lang="en-US" sz="950" dirty="0">
+                        <a:latin typeface="Graphik TH" charset="0"/>
+                        <a:ea typeface="Graphik TH" charset="0"/>
+                        <a:cs typeface="Graphik TH" charset="0"/>
+                      </a:endParaRPr>
+                    </a:p>
+                  </a:txBody>
+                  <a:tcPr marL="73152" marR="73152" marT="18288" marB="18288" anchor="ctr">
+                    <a:lnL w="6350" cap="flat" cmpd="sng" algn="ctr">
+                      <a:solidFill>
+                        <a:srgbClr val="D8DFE9"/>
+                      </a:solidFill>
+                      <a:prstDash val="solid"/>
+                      <a:round/>
+                      <a:headEnd type="none" w="med" len="med"/>
+                      <a:tailEnd type="none" w="med" len="med"/>
+                    </a:lnL>
+                    <a:lnR w="6350" cap="flat" cmpd="sng" algn="ctr">
+                      <a:solidFill>
+                        <a:srgbClr val="D8DFE9"/>
+                      </a:solidFill>
+                      <a:prstDash val="solid"/>
+                      <a:round/>
+                      <a:headEnd type="none" w="med" len="med"/>
+                      <a:tailEnd type="none" w="med" len="med"/>
+                    </a:lnR>
+                    <a:lnT w="6350" cap="flat" cmpd="sng" algn="ctr">
+                      <a:solidFill>
+                        <a:srgbClr val="D8DFE9"/>
+                      </a:solidFill>
+                      <a:prstDash val="solid"/>
+                      <a:round/>
+                      <a:headEnd type="none" w="med" len="med"/>
+                      <a:tailEnd type="none" w="med" len="med"/>
+                    </a:lnT>
+                    <a:lnB w="6350" cap="flat" cmpd="sng" algn="ctr">
+                      <a:solidFill>
+                        <a:srgbClr val="D8DFE9"/>
+                      </a:solidFill>
+                      <a:prstDash val="solid"/>
+                      <a:round/>
+                      <a:headEnd type="none" w="med" len="med"/>
+                      <a:tailEnd type="none" w="med" len="med"/>
+                    </a:lnB>
+                    <a:solidFill>
+                      <a:srgbClr val="FFFFFF"/>
+                    </a:solidFill>
+                  </a:tcPr>
+                </a:tc>
+                <a:tc>
+                  <a:txBody>
+                    <a:bodyPr/>
+                    <a:lstStyle/>
+                    <a:p>
+                      <a:pPr algn="r" indent="0" marL="0">
+                        <a:buNone/>
+                      </a:pPr>
+                      <a:r>
+                        <a:rPr lang="en-US" sz="950" dirty="0">
+                          <a:solidFill>
+                            <a:srgbClr val="16233D"/>
+                          </a:solidFill>
+                          <a:latin typeface="Graphik TH" pitchFamily="34" charset="0"/>
+                          <a:ea typeface="Graphik TH" pitchFamily="34" charset="-122"/>
+                          <a:cs typeface="Graphik TH" pitchFamily="34" charset="-120"/>
+                        </a:rPr>
+                        <a:t>0.0</a:t>
+                      </a:r>
+                      <a:endParaRPr lang="en-US" sz="950" dirty="0">
+                        <a:latin typeface="Graphik TH" charset="0"/>
+                        <a:ea typeface="Graphik TH" charset="0"/>
+                        <a:cs typeface="Graphik TH" charset="0"/>
+                      </a:endParaRPr>
+                    </a:p>
+                  </a:txBody>
+                  <a:tcPr marL="73152" marR="73152" marT="18288" marB="18288" anchor="ctr">
+                    <a:lnL w="6350" cap="flat" cmpd="sng" algn="ctr">
+                      <a:solidFill>
+                        <a:srgbClr val="D8DFE9"/>
+                      </a:solidFill>
+                      <a:prstDash val="solid"/>
+                      <a:round/>
+                      <a:headEnd type="none" w="med" len="med"/>
+                      <a:tailEnd type="none" w="med" len="med"/>
+                    </a:lnL>
+                    <a:lnR w="6350" cap="flat" cmpd="sng" algn="ctr">
+                      <a:solidFill>
+                        <a:srgbClr val="D8DFE9"/>
+                      </a:solidFill>
+                      <a:prstDash val="solid"/>
+                      <a:round/>
+                      <a:headEnd type="none" w="med" len="med"/>
+                      <a:tailEnd type="none" w="med" len="med"/>
+                    </a:lnR>
+                    <a:lnT w="6350" cap="flat" cmpd="sng" algn="ctr">
+                      <a:solidFill>
+                        <a:srgbClr val="D8DFE9"/>
+                      </a:solidFill>
+                      <a:prstDash val="solid"/>
+                      <a:round/>
+                      <a:headEnd type="none" w="med" len="med"/>
+                      <a:tailEnd type="none" w="med" len="med"/>
+                    </a:lnT>
+                    <a:lnB w="6350" cap="flat" cmpd="sng" algn="ctr">
+                      <a:solidFill>
+                        <a:srgbClr val="D8DFE9"/>
+                      </a:solidFill>
+                      <a:prstDash val="solid"/>
+                      <a:round/>
+                      <a:headEnd type="none" w="med" len="med"/>
+                      <a:tailEnd type="none" w="med" len="med"/>
+                    </a:lnB>
+                    <a:solidFill>
+                      <a:srgbClr val="FFFFFF"/>
+                    </a:solidFill>
+                  </a:tcPr>
+                </a:tc>
+                <a:tc>
+                  <a:txBody>
+                    <a:bodyPr/>
+                    <a:lstStyle/>
+                    <a:p>
+                      <a:pPr algn="r" indent="0" marL="0">
+                        <a:buNone/>
+                      </a:pPr>
+                      <a:r>
+                        <a:rPr lang="en-US" sz="950" b="1" dirty="0">
+                          <a:solidFill>
+                            <a:srgbClr val="C00000"/>
+                          </a:solidFill>
+                          <a:latin typeface="Graphik TH" pitchFamily="34" charset="0"/>
+                          <a:ea typeface="Graphik TH" pitchFamily="34" charset="-122"/>
+                          <a:cs typeface="Graphik TH" pitchFamily="34" charset="-120"/>
+                        </a:rPr>
+                        <a:t>0.0</a:t>
+                      </a:r>
+                      <a:endParaRPr lang="en-US" sz="950" dirty="0">
+                        <a:latin typeface="Graphik TH" charset="0"/>
+                        <a:ea typeface="Graphik TH" charset="0"/>
+                        <a:cs typeface="Graphik TH" charset="0"/>
+                      </a:endParaRPr>
+                    </a:p>
+                  </a:txBody>
+                  <a:tcPr marL="73152" marR="73152" marT="18288" marB="18288" anchor="ctr">
+                    <a:lnL w="6350" cap="flat" cmpd="sng" algn="ctr">
+                      <a:solidFill>
+                        <a:srgbClr val="D8DFE9"/>
+                      </a:solidFill>
+                      <a:prstDash val="solid"/>
+                      <a:round/>
+                      <a:headEnd type="none" w="med" len="med"/>
+                      <a:tailEnd type="none" w="med" len="med"/>
+                    </a:lnL>
+                    <a:lnR w="6350" cap="flat" cmpd="sng" algn="ctr">
+                      <a:solidFill>
+                        <a:srgbClr val="D8DFE9"/>
+                      </a:solidFill>
+                      <a:prstDash val="solid"/>
+                      <a:round/>
+                      <a:headEnd type="none" w="med" len="med"/>
+                      <a:tailEnd type="none" w="med" len="med"/>
+                    </a:lnR>
+                    <a:lnT w="6350" cap="flat" cmpd="sng" algn="ctr">
+                      <a:solidFill>
+                        <a:srgbClr val="D8DFE9"/>
+                      </a:solidFill>
+                      <a:prstDash val="solid"/>
+                      <a:round/>
+                      <a:headEnd type="none" w="med" len="med"/>
+                      <a:tailEnd type="none" w="med" len="med"/>
+                    </a:lnT>
+                    <a:lnB w="6350" cap="flat" cmpd="sng" algn="ctr">
+                      <a:solidFill>
+                        <a:srgbClr val="D8DFE9"/>
+                      </a:solidFill>
+                      <a:prstDash val="solid"/>
+                      <a:round/>
+                      <a:headEnd type="none" w="med" len="med"/>
+                      <a:tailEnd type="none" w="med" len="med"/>
+                    </a:lnB>
+                    <a:solidFill>
+                      <a:srgbClr val="F7DEDE"/>
+                    </a:solidFill>
+                  </a:tcPr>
+                </a:tc>
+                <a:tc>
+                  <a:txBody>
+                    <a:bodyPr/>
+                    <a:lstStyle/>
+                    <a:p>
+                      <a:pPr algn="r" indent="0" marL="0">
+                        <a:buNone/>
+                      </a:pPr>
+                      <a:r>
+                        <a:rPr lang="en-US" sz="950" b="1" dirty="0">
+                          <a:solidFill>
+                            <a:srgbClr val="C00000"/>
+                          </a:solidFill>
+                          <a:latin typeface="Graphik TH" pitchFamily="34" charset="0"/>
+                          <a:ea typeface="Graphik TH" pitchFamily="34" charset="-122"/>
+                          <a:cs typeface="Graphik TH" pitchFamily="34" charset="-120"/>
+                        </a:rPr>
+                        <a:t>2.0</a:t>
+                      </a:r>
+                      <a:endParaRPr lang="en-US" sz="950" dirty="0">
+                        <a:latin typeface="Graphik TH" charset="0"/>
+                        <a:ea typeface="Graphik TH" charset="0"/>
+                        <a:cs typeface="Graphik TH" charset="0"/>
+                      </a:endParaRPr>
+                    </a:p>
+                  </a:txBody>
+                  <a:tcPr marL="73152" marR="73152" marT="18288" marB="18288" anchor="ctr">
+                    <a:lnL w="6350" cap="flat" cmpd="sng" algn="ctr">
+                      <a:solidFill>
+                        <a:srgbClr val="D8DFE9"/>
+                      </a:solidFill>
+                      <a:prstDash val="solid"/>
+                      <a:round/>
+                      <a:headEnd type="none" w="med" len="med"/>
+                      <a:tailEnd type="none" w="med" len="med"/>
+                    </a:lnL>
+                    <a:lnR w="6350" cap="flat" cmpd="sng" algn="ctr">
+                      <a:solidFill>
+                        <a:srgbClr val="D8DFE9"/>
+                      </a:solidFill>
+                      <a:prstDash val="solid"/>
+                      <a:round/>
+                      <a:headEnd type="none" w="med" len="med"/>
+                      <a:tailEnd type="none" w="med" len="med"/>
+                    </a:lnR>
+                    <a:lnT w="6350" cap="flat" cmpd="sng" algn="ctr">
+                      <a:solidFill>
+                        <a:srgbClr val="D8DFE9"/>
+                      </a:solidFill>
+                      <a:prstDash val="solid"/>
+                      <a:round/>
+                      <a:headEnd type="none" w="med" len="med"/>
+                      <a:tailEnd type="none" w="med" len="med"/>
+                    </a:lnT>
+                    <a:lnB w="6350" cap="flat" cmpd="sng" algn="ctr">
+                      <a:solidFill>
+                        <a:srgbClr val="D8DFE9"/>
+                      </a:solidFill>
+                      <a:prstDash val="solid"/>
+                      <a:round/>
+                      <a:headEnd type="none" w="med" len="med"/>
+                      <a:tailEnd type="none" w="med" len="med"/>
+                    </a:lnB>
+                    <a:solidFill>
+                      <a:srgbClr val="F7DEDE"/>
+                    </a:solidFill>
+                  </a:tcPr>
+                </a:tc>
+              </a:tr>
+            </a:tbl>
+          </a:graphicData>
+        </a:graphic>
+      </p:graphicFrame>
+      <p:sp>
+        <p:nvSpPr>
+          <p:cNvPr id="26" name="Shape 23"/>
+          <p:cNvSpPr/>
+          <p:nvPr/>
+        </p:nvSpPr>
+        <p:spPr>
+          <a:xfrm>
+            <a:off x="7479792" y="2798064"/>
+            <a:ext cx="4325112" cy="2322576"/>
+          </a:xfrm>
+          <a:prstGeom prst="roundRect">
+            <a:avLst>
+              <a:gd name="adj" fmla="val 3543"/>
+            </a:avLst>
+          </a:prstGeom>
+          <a:solidFill>
+            <a:srgbClr val="F1F4F9"/>
+          </a:solidFill>
+          <a:ln/>
+        </p:spPr>
+      </p:sp>
+      <p:sp>
+        <p:nvSpPr>
+          <p:cNvPr id="27" name="Text 24"/>
+          <p:cNvSpPr/>
+          <p:nvPr/>
+        </p:nvSpPr>
+        <p:spPr>
+          <a:xfrm>
+            <a:off x="7735824" y="2944368"/>
+            <a:ext cx="3813048" cy="274320"/>
+          </a:xfrm>
+          <a:prstGeom prst="rect">
+            <a:avLst/>
+          </a:prstGeom>
+          <a:noFill/>
+          <a:ln/>
+        </p:spPr>
+        <p:txBody>
+          <a:bodyPr wrap="square" lIns="0" tIns="0" rIns="0" bIns="0" rtlCol="0" anchor="ctr"/>
+          <a:lstStyle/>
+          <a:p>
+            <a:pPr indent="0" marL="0">
+              <a:buNone/>
+            </a:pPr>
+            <a:r>
+              <a:rPr lang="en-US" sz="1400" b="1" dirty="0">
+                <a:solidFill>
+                  <a:srgbClr val="16233D"/>
+                </a:solidFill>
+                <a:latin typeface="Cambria" pitchFamily="34" charset="0"/>
+                <a:ea typeface="Cambria" pitchFamily="34" charset="-122"/>
+                <a:cs typeface="Cambria" pitchFamily="34" charset="-120"/>
+              </a:rPr>
+              <a:t>Average balance per customer</a:t>
+            </a:r>
+            <a:endParaRPr lang="en-US" sz="1400" dirty="0"/>
+          </a:p>
+        </p:txBody>
+      </p:sp>
+      <p:sp>
+        <p:nvSpPr>
+          <p:cNvPr id="28" name="Text 25"/>
+          <p:cNvSpPr/>
+          <p:nvPr/>
+        </p:nvSpPr>
+        <p:spPr>
+          <a:xfrm>
+            <a:off x="7735824" y="3218688"/>
+            <a:ext cx="3813048" cy="237744"/>
+          </a:xfrm>
+          <a:prstGeom prst="rect">
+            <a:avLst/>
+          </a:prstGeom>
+          <a:noFill/>
+          <a:ln/>
+        </p:spPr>
+        <p:txBody>
+          <a:bodyPr wrap="square" lIns="0" tIns="0" rIns="0" bIns="0" rtlCol="0" anchor="ctr"/>
+          <a:lstStyle/>
+          <a:p>
+            <a:pPr indent="0" marL="0">
+              <a:buNone/>
+            </a:pPr>
+            <a:r>
+              <a:rPr lang="en-US" sz="950" dirty="0">
+                <a:solidFill>
+                  <a:srgbClr val="6B7A90"/>
+                </a:solidFill>
+                <a:latin typeface="Graphik TH" pitchFamily="34" charset="0"/>
+                <a:ea typeface="Graphik TH" pitchFamily="34" charset="-122"/>
+                <a:cs typeface="Graphik TH" pitchFamily="34" charset="-120"/>
+              </a:rPr>
+              <a:t>Funded customers, by stickiness tier</a:t>
+            </a:r>
+            <a:endParaRPr lang="en-US" sz="950" dirty="0"/>
+          </a:p>
+        </p:txBody>
+      </p:sp>
+      <p:sp>
+        <p:nvSpPr>
+          <p:cNvPr id="29" name="Text 26"/>
+          <p:cNvSpPr/>
+          <p:nvPr/>
+        </p:nvSpPr>
+        <p:spPr>
+          <a:xfrm>
+            <a:off x="7735824" y="3474720"/>
+            <a:ext cx="1051560" cy="256032"/>
+          </a:xfrm>
+          <a:prstGeom prst="rect">
+            <a:avLst/>
+          </a:prstGeom>
+          <a:noFill/>
+          <a:ln/>
+        </p:spPr>
+        <p:txBody>
+          <a:bodyPr wrap="square" lIns="0" tIns="0" rIns="0" bIns="0" rtlCol="0" anchor="ctr"/>
+          <a:lstStyle/>
+          <a:p>
+            <a:pPr indent="0" marL="0">
+              <a:buNone/>
+            </a:pPr>
+            <a:r>
+              <a:rPr lang="en-US" sz="1050" b="1" dirty="0">
+                <a:solidFill>
+                  <a:srgbClr val="16233D"/>
+                </a:solidFill>
+                <a:latin typeface="Graphik TH" pitchFamily="34" charset="0"/>
+                <a:ea typeface="Graphik TH" pitchFamily="34" charset="-122"/>
+                <a:cs typeface="Graphik TH" pitchFamily="34" charset="-120"/>
+              </a:rPr>
+              <a:t>Very High</a:t>
+            </a:r>
+            <a:endParaRPr lang="en-US" sz="1050" dirty="0"/>
+          </a:p>
+        </p:txBody>
+      </p:sp>
+      <p:sp>
+        <p:nvSpPr>
+          <p:cNvPr id="30" name="Shape 27"/>
+          <p:cNvSpPr/>
+          <p:nvPr/>
+        </p:nvSpPr>
+        <p:spPr>
+          <a:xfrm>
+            <a:off x="8851392" y="3520440"/>
+            <a:ext cx="1417320" cy="164592"/>
+          </a:xfrm>
+          <a:prstGeom prst="roundRect">
+            <a:avLst>
+              <a:gd name="adj" fmla="val 16667"/>
+            </a:avLst>
+          </a:prstGeom>
+          <a:solidFill>
+            <a:srgbClr val="165A73"/>
+          </a:solidFill>
+          <a:ln/>
+        </p:spPr>
+      </p:sp>
+      <p:sp>
+        <p:nvSpPr>
+          <p:cNvPr id="31" name="Text 28"/>
+          <p:cNvSpPr/>
+          <p:nvPr/>
+        </p:nvSpPr>
+        <p:spPr>
+          <a:xfrm>
+            <a:off x="10351008" y="3474720"/>
+            <a:ext cx="1197864" cy="256032"/>
+          </a:xfrm>
+          <a:prstGeom prst="rect">
+            <a:avLst/>
+          </a:prstGeom>
+          <a:noFill/>
+          <a:ln/>
+        </p:spPr>
+        <p:txBody>
+          <a:bodyPr wrap="square" lIns="0" tIns="0" rIns="0" bIns="0" rtlCol="0" anchor="ctr"/>
+          <a:lstStyle/>
+          <a:p>
+            <a:pPr algn="r" indent="0" marL="0">
+              <a:buNone/>
+            </a:pPr>
+            <a:r>
+              <a:rPr lang="en-US" sz="1050" b="1" dirty="0">
+                <a:solidFill>
+                  <a:srgbClr val="16233D"/>
+                </a:solidFill>
+                <a:latin typeface="Graphik TH" pitchFamily="34" charset="0"/>
+                <a:ea typeface="Graphik TH" pitchFamily="34" charset="-122"/>
+                <a:cs typeface="Graphik TH" pitchFamily="34" charset="-120"/>
+              </a:rPr>
+              <a:t>THB 49,529</a:t>
+            </a:r>
+            <a:endParaRPr lang="en-US" sz="1050" dirty="0"/>
+          </a:p>
+        </p:txBody>
+      </p:sp>
+      <p:sp>
+        <p:nvSpPr>
+          <p:cNvPr id="32" name="Text 29"/>
+          <p:cNvSpPr/>
+          <p:nvPr/>
+        </p:nvSpPr>
+        <p:spPr>
+          <a:xfrm>
+            <a:off x="7735824" y="3785616"/>
+            <a:ext cx="1051560" cy="256032"/>
+          </a:xfrm>
+          <a:prstGeom prst="rect">
+            <a:avLst/>
+          </a:prstGeom>
+          <a:noFill/>
+          <a:ln/>
+        </p:spPr>
+        <p:txBody>
+          <a:bodyPr wrap="square" lIns="0" tIns="0" rIns="0" bIns="0" rtlCol="0" anchor="ctr"/>
+          <a:lstStyle/>
+          <a:p>
+            <a:pPr indent="0" marL="0">
+              <a:buNone/>
+            </a:pPr>
+            <a:r>
+              <a:rPr lang="en-US" sz="1050" b="1" dirty="0">
+                <a:solidFill>
+                  <a:srgbClr val="16233D"/>
+                </a:solidFill>
+                <a:latin typeface="Graphik TH" pitchFamily="34" charset="0"/>
+                <a:ea typeface="Graphik TH" pitchFamily="34" charset="-122"/>
+                <a:cs typeface="Graphik TH" pitchFamily="34" charset="-120"/>
+              </a:rPr>
+              <a:t>High</a:t>
+            </a:r>
+            <a:endParaRPr lang="en-US" sz="1050" dirty="0"/>
+          </a:p>
+        </p:txBody>
+      </p:sp>
+      <p:sp>
+        <p:nvSpPr>
+          <p:cNvPr id="33" name="Shape 30"/>
+          <p:cNvSpPr/>
+          <p:nvPr/>
+        </p:nvSpPr>
+        <p:spPr>
+          <a:xfrm>
+            <a:off x="8851392" y="3831336"/>
+            <a:ext cx="725350" cy="164592"/>
+          </a:xfrm>
+          <a:prstGeom prst="roundRect">
+            <a:avLst>
+              <a:gd name="adj" fmla="val 16667"/>
+            </a:avLst>
+          </a:prstGeom>
+          <a:solidFill>
+            <a:srgbClr val="1E8E86"/>
+          </a:solidFill>
+          <a:ln/>
+        </p:spPr>
+      </p:sp>
+      <p:sp>
+        <p:nvSpPr>
+          <p:cNvPr id="34" name="Text 31"/>
+          <p:cNvSpPr/>
+          <p:nvPr/>
+        </p:nvSpPr>
+        <p:spPr>
+          <a:xfrm>
+            <a:off x="10351008" y="3785616"/>
+            <a:ext cx="1197864" cy="256032"/>
+          </a:xfrm>
+          <a:prstGeom prst="rect">
+            <a:avLst/>
+          </a:prstGeom>
+          <a:noFill/>
+          <a:ln/>
+        </p:spPr>
+        <p:txBody>
+          <a:bodyPr wrap="square" lIns="0" tIns="0" rIns="0" bIns="0" rtlCol="0" anchor="ctr"/>
+          <a:lstStyle/>
+          <a:p>
+            <a:pPr algn="r" indent="0" marL="0">
+              <a:buNone/>
+            </a:pPr>
+            <a:r>
+              <a:rPr lang="en-US" sz="1050" b="1" dirty="0">
+                <a:solidFill>
+                  <a:srgbClr val="16233D"/>
+                </a:solidFill>
+                <a:latin typeface="Graphik TH" pitchFamily="34" charset="0"/>
+                <a:ea typeface="Graphik TH" pitchFamily="34" charset="-122"/>
+                <a:cs typeface="Graphik TH" pitchFamily="34" charset="-120"/>
+              </a:rPr>
+              <a:t>THB 25,348</a:t>
+            </a:r>
+            <a:endParaRPr lang="en-US" sz="1050" dirty="0"/>
+          </a:p>
+        </p:txBody>
+      </p:sp>
+      <p:sp>
+        <p:nvSpPr>
+          <p:cNvPr id="35" name="Text 32"/>
+          <p:cNvSpPr/>
+          <p:nvPr/>
+        </p:nvSpPr>
+        <p:spPr>
+          <a:xfrm>
+            <a:off x="7735824" y="4096512"/>
+            <a:ext cx="1051560" cy="256032"/>
+          </a:xfrm>
+          <a:prstGeom prst="rect">
+            <a:avLst/>
+          </a:prstGeom>
+          <a:noFill/>
+          <a:ln/>
+        </p:spPr>
+        <p:txBody>
+          <a:bodyPr wrap="square" lIns="0" tIns="0" rIns="0" bIns="0" rtlCol="0" anchor="ctr"/>
+          <a:lstStyle/>
+          <a:p>
+            <a:pPr indent="0" marL="0">
+              <a:buNone/>
+            </a:pPr>
+            <a:r>
+              <a:rPr lang="en-US" sz="1050" b="1" dirty="0">
+                <a:solidFill>
+                  <a:srgbClr val="16233D"/>
+                </a:solidFill>
+                <a:latin typeface="Graphik TH" pitchFamily="34" charset="0"/>
+                <a:ea typeface="Graphik TH" pitchFamily="34" charset="-122"/>
+                <a:cs typeface="Graphik TH" pitchFamily="34" charset="-120"/>
+              </a:rPr>
+              <a:t>Medium</a:t>
+            </a:r>
+            <a:endParaRPr lang="en-US" sz="1050" dirty="0"/>
+          </a:p>
+        </p:txBody>
+      </p:sp>
+      <p:sp>
+        <p:nvSpPr>
+          <p:cNvPr id="36" name="Shape 33"/>
+          <p:cNvSpPr/>
+          <p:nvPr/>
+        </p:nvSpPr>
+        <p:spPr>
+          <a:xfrm>
+            <a:off x="8851392" y="4142232"/>
+            <a:ext cx="62733" cy="164592"/>
+          </a:xfrm>
+          <a:prstGeom prst="roundRect">
+            <a:avLst>
+              <a:gd name="adj" fmla="val 43728"/>
+            </a:avLst>
+          </a:prstGeom>
+          <a:solidFill>
+            <a:srgbClr val="3FB89F"/>
+          </a:solidFill>
+          <a:ln/>
+        </p:spPr>
+      </p:sp>
+      <p:sp>
+        <p:nvSpPr>
+          <p:cNvPr id="37" name="Text 34"/>
+          <p:cNvSpPr/>
+          <p:nvPr/>
+        </p:nvSpPr>
+        <p:spPr>
+          <a:xfrm>
+            <a:off x="10351008" y="4096512"/>
+            <a:ext cx="1197864" cy="256032"/>
+          </a:xfrm>
+          <a:prstGeom prst="rect">
+            <a:avLst/>
+          </a:prstGeom>
+          <a:noFill/>
+          <a:ln/>
+        </p:spPr>
+        <p:txBody>
+          <a:bodyPr wrap="square" lIns="0" tIns="0" rIns="0" bIns="0" rtlCol="0" anchor="ctr"/>
+          <a:lstStyle/>
+          <a:p>
+            <a:pPr algn="r" indent="0" marL="0">
+              <a:buNone/>
+            </a:pPr>
+            <a:r>
+              <a:rPr lang="en-US" sz="1050" b="1" dirty="0">
+                <a:solidFill>
+                  <a:srgbClr val="16233D"/>
+                </a:solidFill>
+                <a:latin typeface="Graphik TH" pitchFamily="34" charset="0"/>
+                <a:ea typeface="Graphik TH" pitchFamily="34" charset="-122"/>
+                <a:cs typeface="Graphik TH" pitchFamily="34" charset="-120"/>
+              </a:rPr>
+              <a:t>THB 2,192</a:t>
+            </a:r>
+            <a:endParaRPr lang="en-US" sz="1050" dirty="0"/>
+          </a:p>
+        </p:txBody>
+      </p:sp>
+      <p:sp>
+        <p:nvSpPr>
+          <p:cNvPr id="38" name="Text 35"/>
+          <p:cNvSpPr/>
+          <p:nvPr/>
+        </p:nvSpPr>
+        <p:spPr>
+          <a:xfrm>
+            <a:off x="7735824" y="4407408"/>
+            <a:ext cx="1051560" cy="256032"/>
+          </a:xfrm>
+          <a:prstGeom prst="rect">
+            <a:avLst/>
+          </a:prstGeom>
+          <a:noFill/>
+          <a:ln/>
+        </p:spPr>
+        <p:txBody>
+          <a:bodyPr wrap="square" lIns="0" tIns="0" rIns="0" bIns="0" rtlCol="0" anchor="ctr"/>
+          <a:lstStyle/>
+          <a:p>
+            <a:pPr indent="0" marL="0">
+              <a:buNone/>
+            </a:pPr>
+            <a:r>
+              <a:rPr lang="en-US" sz="1050" b="1" dirty="0">
+                <a:solidFill>
+                  <a:srgbClr val="16233D"/>
+                </a:solidFill>
+                <a:latin typeface="Graphik TH" pitchFamily="34" charset="0"/>
+                <a:ea typeface="Graphik TH" pitchFamily="34" charset="-122"/>
+                <a:cs typeface="Graphik TH" pitchFamily="34" charset="-120"/>
+              </a:rPr>
+              <a:t>Low</a:t>
+            </a:r>
+            <a:endParaRPr lang="en-US" sz="1050" dirty="0"/>
+          </a:p>
+        </p:txBody>
+      </p:sp>
+      <p:sp>
+        <p:nvSpPr>
+          <p:cNvPr id="39" name="Shape 36"/>
+          <p:cNvSpPr/>
+          <p:nvPr/>
+        </p:nvSpPr>
+        <p:spPr>
+          <a:xfrm>
+            <a:off x="8851392" y="4453128"/>
+            <a:ext cx="36576" cy="164592"/>
+          </a:xfrm>
+          <a:prstGeom prst="roundRect">
+            <a:avLst>
+              <a:gd name="adj" fmla="val 75000"/>
+            </a:avLst>
+          </a:prstGeom>
+          <a:solidFill>
+            <a:srgbClr val="E9A03B"/>
+          </a:solidFill>
+          <a:ln/>
+        </p:spPr>
+      </p:sp>
+      <p:sp>
+        <p:nvSpPr>
+          <p:cNvPr id="40" name="Text 37"/>
+          <p:cNvSpPr/>
+          <p:nvPr/>
+        </p:nvSpPr>
+        <p:spPr>
+          <a:xfrm>
+            <a:off x="10351008" y="4407408"/>
+            <a:ext cx="1197864" cy="256032"/>
+          </a:xfrm>
+          <a:prstGeom prst="rect">
+            <a:avLst/>
+          </a:prstGeom>
+          <a:noFill/>
+          <a:ln/>
+        </p:spPr>
+        <p:txBody>
+          <a:bodyPr wrap="square" lIns="0" tIns="0" rIns="0" bIns="0" rtlCol="0" anchor="ctr"/>
+          <a:lstStyle/>
+          <a:p>
+            <a:pPr algn="r" indent="0" marL="0">
+              <a:buNone/>
+            </a:pPr>
+            <a:r>
+              <a:rPr lang="en-US" sz="1050" b="1" dirty="0">
+                <a:solidFill>
+                  <a:srgbClr val="16233D"/>
+                </a:solidFill>
+                <a:latin typeface="Graphik TH" pitchFamily="34" charset="0"/>
+                <a:ea typeface="Graphik TH" pitchFamily="34" charset="-122"/>
+                <a:cs typeface="Graphik TH" pitchFamily="34" charset="-120"/>
+              </a:rPr>
+              <a:t>THB 370</a:t>
+            </a:r>
+            <a:endParaRPr lang="en-US" sz="1050" dirty="0"/>
+          </a:p>
+        </p:txBody>
+      </p:sp>
+      <p:sp>
+        <p:nvSpPr>
+          <p:cNvPr id="41" name="Text 38"/>
+          <p:cNvSpPr/>
+          <p:nvPr/>
+        </p:nvSpPr>
+        <p:spPr>
+          <a:xfrm>
+            <a:off x="7735824" y="4718304"/>
+            <a:ext cx="1051560" cy="256032"/>
+          </a:xfrm>
+          <a:prstGeom prst="rect">
+            <a:avLst/>
+          </a:prstGeom>
+          <a:noFill/>
+          <a:ln/>
+        </p:spPr>
+        <p:txBody>
+          <a:bodyPr wrap="square" lIns="0" tIns="0" rIns="0" bIns="0" rtlCol="0" anchor="ctr"/>
+          <a:lstStyle/>
+          <a:p>
+            <a:pPr indent="0" marL="0">
+              <a:buNone/>
+            </a:pPr>
+            <a:r>
+              <a:rPr lang="en-US" sz="1050" b="1" dirty="0">
+                <a:solidFill>
+                  <a:srgbClr val="16233D"/>
+                </a:solidFill>
+                <a:latin typeface="Graphik TH" pitchFamily="34" charset="0"/>
+                <a:ea typeface="Graphik TH" pitchFamily="34" charset="-122"/>
+                <a:cs typeface="Graphik TH" pitchFamily="34" charset="-120"/>
+              </a:rPr>
+              <a:t>Very Low</a:t>
+            </a:r>
+            <a:endParaRPr lang="en-US" sz="1050" dirty="0"/>
+          </a:p>
+        </p:txBody>
+      </p:sp>
+      <p:sp>
+        <p:nvSpPr>
+          <p:cNvPr id="42" name="Shape 39"/>
+          <p:cNvSpPr/>
+          <p:nvPr/>
+        </p:nvSpPr>
+        <p:spPr>
+          <a:xfrm>
+            <a:off x="8851392" y="4764024"/>
+            <a:ext cx="36576" cy="164592"/>
+          </a:xfrm>
+          <a:prstGeom prst="roundRect">
+            <a:avLst>
+              <a:gd name="adj" fmla="val 75000"/>
+            </a:avLst>
+          </a:prstGeom>
+          <a:solidFill>
+            <a:srgbClr val="8DA0B8"/>
+          </a:solidFill>
+          <a:ln/>
+        </p:spPr>
+      </p:sp>
+      <p:sp>
+        <p:nvSpPr>
+          <p:cNvPr id="43" name="Text 40"/>
+          <p:cNvSpPr/>
+          <p:nvPr/>
+        </p:nvSpPr>
+        <p:spPr>
+          <a:xfrm>
+            <a:off x="10351008" y="4718304"/>
+            <a:ext cx="1197864" cy="256032"/>
+          </a:xfrm>
+          <a:prstGeom prst="rect">
+            <a:avLst/>
+          </a:prstGeom>
+          <a:noFill/>
+          <a:ln/>
+        </p:spPr>
+        <p:txBody>
+          <a:bodyPr wrap="square" lIns="0" tIns="0" rIns="0" bIns="0" rtlCol="0" anchor="ctr"/>
+          <a:lstStyle/>
+          <a:p>
+            <a:pPr algn="r" indent="0" marL="0">
+              <a:buNone/>
+            </a:pPr>
+            <a:r>
+              <a:rPr lang="en-US" sz="1050" b="1" dirty="0">
+                <a:solidFill>
+                  <a:srgbClr val="16233D"/>
+                </a:solidFill>
+                <a:latin typeface="Graphik TH" pitchFamily="34" charset="0"/>
+                <a:ea typeface="Graphik TH" pitchFamily="34" charset="-122"/>
+                <a:cs typeface="Graphik TH" pitchFamily="34" charset="-120"/>
+              </a:rPr>
+              <a:t>THB 143</a:t>
+            </a:r>
+            <a:endParaRPr lang="en-US" sz="1050" dirty="0"/>
+          </a:p>
+        </p:txBody>
+      </p:sp>
+      <p:sp>
+        <p:nvSpPr>
+          <p:cNvPr id="44" name="Text 41"/>
+          <p:cNvSpPr/>
+          <p:nvPr/>
+        </p:nvSpPr>
+        <p:spPr>
+          <a:xfrm>
+            <a:off x="7735824" y="5084064"/>
+            <a:ext cx="3813048" cy="274320"/>
+          </a:xfrm>
+          <a:prstGeom prst="rect">
+            <a:avLst/>
+          </a:prstGeom>
+          <a:noFill/>
+          <a:ln/>
+        </p:spPr>
+        <p:txBody>
+          <a:bodyPr wrap="square" lIns="0" tIns="0" rIns="0" bIns="0" rtlCol="0" anchor="ctr"/>
+          <a:lstStyle/>
+          <a:p>
+            <a:pPr indent="0" marL="0">
+              <a:buNone/>
+            </a:pPr>
+            <a:r>
+              <a:rPr lang="en-US" sz="900" i="1" dirty="0">
+                <a:solidFill>
+                  <a:srgbClr val="6B7A90"/>
+                </a:solidFill>
+                <a:latin typeface="Graphik TH" pitchFamily="34" charset="0"/>
+                <a:ea typeface="Graphik TH" pitchFamily="34" charset="-122"/>
+                <a:cs typeface="Graphik TH" pitchFamily="34" charset="-120"/>
+              </a:rPr>
+              <a:t>Very High stickiness holds ~346× the balance of Very Low.</a:t>
+            </a:r>
+            <a:endParaRPr lang="en-US" sz="900" dirty="0"/>
+          </a:p>
+        </p:txBody>
+      </p:sp>
+      <p:sp>
+        <p:nvSpPr>
+          <p:cNvPr id="45" name="Shape 42"/>
+          <p:cNvSpPr/>
+          <p:nvPr/>
+        </p:nvSpPr>
+        <p:spPr>
+          <a:xfrm>
+            <a:off x="530352" y="5285232"/>
+            <a:ext cx="11274552" cy="786384"/>
+          </a:xfrm>
+          <a:prstGeom prst="roundRect">
+            <a:avLst>
+              <a:gd name="adj" fmla="val 10465"/>
+            </a:avLst>
+          </a:prstGeom>
+          <a:solidFill>
+            <a:srgbClr val="FBF0E6"/>
+          </a:solidFill>
+          <a:ln/>
+        </p:spPr>
+      </p:sp>
+      <p:sp>
+        <p:nvSpPr>
+          <p:cNvPr id="46" name="Text 43"/>
+          <p:cNvSpPr/>
+          <p:nvPr/>
+        </p:nvSpPr>
+        <p:spPr>
+          <a:xfrm>
+            <a:off x="804672" y="5285232"/>
+            <a:ext cx="10725912" cy="786384"/>
+          </a:xfrm>
+          <a:prstGeom prst="rect">
+            <a:avLst/>
+          </a:prstGeom>
+          <a:noFill/>
+          <a:ln/>
+        </p:spPr>
+        <p:txBody>
+          <a:bodyPr wrap="square" lIns="0" tIns="0" rIns="0" bIns="0" rtlCol="0" anchor="ctr"/>
+          <a:lstStyle/>
+          <a:p>
+            <a:pPr indent="0" marL="0">
+              <a:buNone/>
+            </a:pPr>
+            <a:r>
+              <a:rPr lang="en-US" sz="1100" b="1" dirty="0">
+                <a:solidFill>
+                  <a:srgbClr val="C00000"/>
+                </a:solidFill>
+                <a:latin typeface="Graphik TH" pitchFamily="34" charset="0"/>
+                <a:ea typeface="Graphik TH" pitchFamily="34" charset="-122"/>
+                <a:cs typeface="Graphik TH" pitchFamily="34" charset="-120"/>
+              </a:rPr>
+              <a:t>97% of the rate-sensitive balance sits with High / Very High stickiness customers</a:t>
+            </a:r>
+            <a:pPr indent="0" marL="0">
+              <a:buNone/>
+            </a:pPr>
+            <a:r>
+              <a:rPr lang="en-US" sz="1100" dirty="0">
+                <a:solidFill>
+                  <a:srgbClr val="16233D"/>
+                </a:solidFill>
+                <a:latin typeface="Graphik TH" pitchFamily="34" charset="0"/>
+                <a:ea typeface="Graphik TH" pitchFamily="34" charset="-122"/>
+                <a:cs typeface="Graphik TH" pitchFamily="34" charset="-120"/>
+              </a:rPr>
+              <a:t>  —  the same pattern as Save Max, at eight times the size. The genuinely fragile slice is THB 99m: customers who are neither sticky nor indifferent to price.</a:t>
+            </a:r>
+            <a:endParaRPr lang="en-US" sz="1100" dirty="0"/>
+          </a:p>
+        </p:txBody>
+      </p:sp>
+    </p:spTree>
+  </p:cSld>
+  <p:clrMapOvr>
+    <a:masterClrMapping/>
+  </p:clrMapOvr>
+</p:sld>
+</file>
+
 <file path=ppt/theme/theme1.xml><?xml version="1.0" encoding="utf-8"?>
 <a:theme xmlns:a="http://schemas.openxmlformats.org/drawingml/2006/main" name="Office Theme">
   <a:themeElements>

</xml_diff>

<commit_message>
Add slide 8: customers vs balance at risk across both risk lenses
Combines the funded-count grid (slide 6) with the funded-balance grid
(slide 7) into a single at-risk read. Four stat tiles carry the key
messages: 67.9k low-stickiness customers holding THB 16.7m, and 25.0k
high-rate-sensitivity customers holding THB 3.83bn. Paired proportion
bars visualise the asymmetry - low stickiness is 21.2% of customers but
0.3% of balance, high rate sensitivity is 7.8% of customers but 69.9% of
balance. A side card isolates the overlap of the two lenses (370
customers, THB 99m) as the priority watchlist.

Co-Authored-By: Claude Opus 5 <noreply@anthropic.com>
Claude-Session: https://claude.ai/code/session_01VKpfo226Go9vQJYa4eoC1d
</commit_message>
<xml_diff>
--- a/Deposit_Stickiness_Framework.pptx
+++ b/Deposit_Stickiness_Framework.pptx
@@ -12,9 +12,10 @@
     <p:sldId id="260" r:id="rId6"/>
     <p:sldId id="261" r:id="rId7"/>
     <p:sldId id="262" r:id="rId8"/>
+    <p:sldId id="263" r:id="rId9"/>
   </p:sldIdLst>
   <p:notesMasterIdLst>
-    <p:notesMasterId r:id="rId9"/>
+    <p:notesMasterId r:id="rId10"/>
   </p:notesMasterIdLst>
   <p:sldSz cx="12192000" cy="6858000"/>
   <p:notesSz cx="6858000" cy="12192000"/>
@@ -1060,6 +1061,94 @@
             <a:fld id="{F7021451-1387-4CA6-816F-3879F97B5CBC}" type="slidenum">
               <a:rPr lang="en-US"/>
               <a:t>7</a:t>
+            </a:fld>
+            <a:endParaRPr lang="en-US"/>
+          </a:p>
+        </p:txBody>
+      </p:sp>
+    </p:spTree>
+    <p:extLst>
+      <p:ext uri="{BB962C8B-B14F-4D97-AF65-F5344CB8AC3E}">
+        <p14:creationId xmlns:p14="http://schemas.microsoft.com/office/powerpoint/2010/main" val="1024086991"/>
+      </p:ext>
+    </p:extLst>
+  </p:cSld>
+  <p:clrMapOvr>
+    <a:masterClrMapping/>
+  </p:clrMapOvr>
+</p:notes>
+</file>
+
+<file path=ppt/notesSlides/notesSlide8.xml><?xml version="1.0" encoding="utf-8"?>
+<p:notes xmlns:a="http://schemas.openxmlformats.org/drawingml/2006/main" xmlns:r="http://schemas.openxmlformats.org/officeDocument/2006/relationships" xmlns:p="http://schemas.openxmlformats.org/presentationml/2006/main">
+  <p:cSld>
+    <p:spTree>
+      <p:nvGrpSpPr>
+        <p:cNvPr id="1" name=""/>
+        <p:cNvGrpSpPr/>
+        <p:nvPr/>
+      </p:nvGrpSpPr>
+      <p:grpSpPr>
+        <a:xfrm>
+          <a:off x="0" y="0"/>
+          <a:ext cx="0" cy="0"/>
+          <a:chOff x="0" y="0"/>
+          <a:chExt cx="0" cy="0"/>
+        </a:xfrm>
+      </p:grpSpPr>
+      <p:sp>
+        <p:nvSpPr>
+          <p:cNvPr id="2" name="Slide Image Placeholder 1"/>
+          <p:cNvSpPr>
+            <a:spLocks noGrp="1" noRot="1" noChangeAspect="1"/>
+          </p:cNvSpPr>
+          <p:nvPr>
+            <p:ph type="sldImg"/>
+          </p:nvPr>
+        </p:nvSpPr>
+        <p:spPr/>
+      </p:sp>
+      <p:sp>
+        <p:nvSpPr>
+          <p:cNvPr id="3" name="Notes Placeholder 2"/>
+          <p:cNvSpPr>
+            <a:spLocks noGrp="1"/>
+          </p:cNvSpPr>
+          <p:nvPr>
+            <p:ph type="body" idx="1"/>
+          </p:nvPr>
+        </p:nvSpPr>
+        <p:spPr/>
+        <p:txBody>
+          <a:bodyPr/>
+          <a:lstStyle/>
+          <a:p>
+            <a:r>
+              <a:rPr lang="en-US" dirty="0"/>
+              <a:t>Funded base 320,109 customers holding THB 5,477,500,353. Low stickiness (Low + Very Low) is 67,895 customers, 21.2% of the funded base, but only THB 16,672,796 - 0.3% of the book. High rate sensitivity (High + Very High) is 24,971 customers, 7.8%, holding THB 3,830,436,985 - 70% of the book. Widening the stickiness lens to score &lt; 60 adds the Medium band: 164,321 customers (51.3%) and THB 228,061,333 (4.2%). The overlap of the two lenses - stickiness &lt; 60 and rate sensitivity &gt;= 60 - is 370 customers and THB 99,437,034, the priority watchlist. The remaining 97% of rate-sensitive balance sits with customers who currently score High or Very High stickiness, which is exactly the stickiness maturity will test.</a:t>
+            </a:r>
+            <a:endParaRPr lang="en-US" dirty="0"/>
+          </a:p>
+        </p:txBody>
+      </p:sp>
+      <p:sp>
+        <p:nvSpPr>
+          <p:cNvPr id="4" name="Slide Number Placeholder 3"/>
+          <p:cNvSpPr>
+            <a:spLocks noGrp="1"/>
+          </p:cNvSpPr>
+          <p:nvPr>
+            <p:ph type="sldNum" sz="quarter" idx="10"/>
+          </p:nvPr>
+        </p:nvSpPr>
+        <p:spPr/>
+        <p:txBody>
+          <a:bodyPr/>
+          <a:lstStyle/>
+          <a:p>
+            <a:fld id="{F7021451-1387-4CA6-816F-3879F97B5CBC}" type="slidenum">
+              <a:rPr lang="en-US"/>
+              <a:t>8</a:t>
             </a:fld>
             <a:endParaRPr lang="en-US"/>
           </a:p>
@@ -25157,6 +25246,1808 @@
 </p:sld>
 </file>
 
+<file path=ppt/slides/slide8.xml><?xml version="1.0" encoding="utf-8"?>
+<p:sld xmlns:a="http://schemas.openxmlformats.org/drawingml/2006/main" xmlns:r="http://schemas.openxmlformats.org/officeDocument/2006/relationships" xmlns:p="http://schemas.openxmlformats.org/presentationml/2006/main">
+  <p:cSld name="Slide 8">
+    <p:bg>
+      <p:bgPr>
+        <a:solidFill>
+          <a:srgbClr val="FFFFFF"/>
+        </a:solidFill>
+      </p:bgPr>
+    </p:bg>
+    <p:spTree>
+      <p:nvGrpSpPr>
+        <p:cNvPr id="1" name=""/>
+        <p:cNvGrpSpPr/>
+        <p:nvPr/>
+      </p:nvGrpSpPr>
+      <p:grpSpPr>
+        <a:xfrm>
+          <a:off x="0" y="0"/>
+          <a:ext cx="0" cy="0"/>
+          <a:chOff x="0" y="0"/>
+          <a:chExt cx="0" cy="0"/>
+        </a:xfrm>
+      </p:grpSpPr>
+      <p:sp>
+        <p:nvSpPr>
+          <p:cNvPr id="2" name="Text 0"/>
+          <p:cNvSpPr/>
+          <p:nvPr/>
+        </p:nvSpPr>
+        <p:spPr>
+          <a:xfrm>
+            <a:off x="530352" y="283464"/>
+            <a:ext cx="11274552" cy="384048"/>
+          </a:xfrm>
+          <a:prstGeom prst="rect">
+            <a:avLst/>
+          </a:prstGeom>
+          <a:noFill/>
+          <a:ln/>
+        </p:spPr>
+        <p:txBody>
+          <a:bodyPr wrap="square" lIns="0" tIns="0" rIns="0" bIns="0" rtlCol="0" anchor="ctr"/>
+          <a:lstStyle/>
+          <a:p>
+            <a:pPr indent="0" marL="0">
+              <a:buNone/>
+            </a:pPr>
+            <a:r>
+              <a:rPr lang="en-US" sz="2200" b="1" dirty="0">
+                <a:solidFill>
+                  <a:srgbClr val="045D66"/>
+                </a:solidFill>
+                <a:latin typeface="Graphik TH" pitchFamily="34" charset="0"/>
+                <a:ea typeface="Graphik TH" pitchFamily="34" charset="-122"/>
+                <a:cs typeface="Graphik TH" pitchFamily="34" charset="-120"/>
+              </a:rPr>
+              <a:t>Two risk lenses : low stickiness and high rate sensitivity</a:t>
+            </a:r>
+            <a:endParaRPr lang="en-US" sz="2200" dirty="0"/>
+          </a:p>
+        </p:txBody>
+      </p:sp>
+      <p:sp>
+        <p:nvSpPr>
+          <p:cNvPr id="3" name="Text 1"/>
+          <p:cNvSpPr/>
+          <p:nvPr/>
+        </p:nvSpPr>
+        <p:spPr>
+          <a:xfrm>
+            <a:off x="530352" y="713232"/>
+            <a:ext cx="11274552" cy="237744"/>
+          </a:xfrm>
+          <a:prstGeom prst="rect">
+            <a:avLst/>
+          </a:prstGeom>
+          <a:noFill/>
+          <a:ln/>
+        </p:spPr>
+        <p:txBody>
+          <a:bodyPr wrap="square" lIns="0" tIns="0" rIns="0" bIns="0" rtlCol="0" anchor="ctr"/>
+          <a:lstStyle/>
+          <a:p>
+            <a:pPr indent="0" marL="0">
+              <a:buNone/>
+            </a:pPr>
+            <a:r>
+              <a:rPr lang="en-US" sz="1150" i="1" dirty="0">
+                <a:solidFill>
+                  <a:srgbClr val="6B6B6B"/>
+                </a:solidFill>
+                <a:latin typeface="Graphik TH" pitchFamily="34" charset="0"/>
+                <a:ea typeface="Graphik TH" pitchFamily="34" charset="-122"/>
+                <a:cs typeface="Graphik TH" pitchFamily="34" charset="-120"/>
+              </a:rPr>
+              <a:t>*Funded base only (balance &gt; 0). Low stickiness = score &lt; 40 (Low + Very Low bands) · high rate sensitivity = score ≥ 60 (High + Very High bands).</a:t>
+            </a:r>
+            <a:endParaRPr lang="en-US" sz="1150" dirty="0"/>
+          </a:p>
+        </p:txBody>
+      </p:sp>
+      <p:sp>
+        <p:nvSpPr>
+          <p:cNvPr id="4" name="Text 2"/>
+          <p:cNvSpPr/>
+          <p:nvPr/>
+        </p:nvSpPr>
+        <p:spPr>
+          <a:xfrm>
+            <a:off x="548640" y="996696"/>
+            <a:ext cx="11064240" cy="237744"/>
+          </a:xfrm>
+          <a:prstGeom prst="rect">
+            <a:avLst/>
+          </a:prstGeom>
+          <a:noFill/>
+          <a:ln/>
+        </p:spPr>
+        <p:txBody>
+          <a:bodyPr wrap="square" lIns="0" tIns="0" rIns="0" bIns="0" rtlCol="0" anchor="ctr"/>
+          <a:lstStyle/>
+          <a:p>
+            <a:pPr indent="0" marL="0">
+              <a:buNone/>
+            </a:pPr>
+            <a:r>
+              <a:rPr lang="en-US" sz="1300" b="1" dirty="0">
+                <a:solidFill>
+                  <a:srgbClr val="045D66"/>
+                </a:solidFill>
+                <a:latin typeface="Graphik TH" pitchFamily="34" charset="0"/>
+                <a:ea typeface="Graphik TH" pitchFamily="34" charset="-122"/>
+                <a:cs typeface="Graphik TH" pitchFamily="34" charset="-120"/>
+              </a:rPr>
+              <a:t>Funded 320.1k · THB 5.48bn   ·   Low stickiness 67.9k → THB 16.7m   ·   High rate sensitivity 25.0k → THB 3.83bn</a:t>
+            </a:r>
+            <a:endParaRPr lang="en-US" sz="1300" dirty="0"/>
+          </a:p>
+        </p:txBody>
+      </p:sp>
+      <p:sp>
+        <p:nvSpPr>
+          <p:cNvPr id="5" name="Text 3"/>
+          <p:cNvSpPr/>
+          <p:nvPr/>
+        </p:nvSpPr>
+        <p:spPr>
+          <a:xfrm>
+            <a:off x="548640" y="1280160"/>
+            <a:ext cx="11064240" cy="274320"/>
+          </a:xfrm>
+          <a:prstGeom prst="rect">
+            <a:avLst/>
+          </a:prstGeom>
+          <a:noFill/>
+          <a:ln/>
+        </p:spPr>
+        <p:txBody>
+          <a:bodyPr wrap="square" lIns="0" tIns="0" rIns="0" bIns="0" rtlCol="0" anchor="ctr"/>
+          <a:lstStyle/>
+          <a:p>
+            <a:pPr indent="0" marL="0">
+              <a:buNone/>
+            </a:pPr>
+            <a:r>
+              <a:rPr lang="en-US" sz="1400" dirty="0">
+                <a:solidFill>
+                  <a:srgbClr val="16233D"/>
+                </a:solidFill>
+                <a:latin typeface="Graphik TH" pitchFamily="34" charset="0"/>
+                <a:ea typeface="Graphik TH" pitchFamily="34" charset="-122"/>
+                <a:cs typeface="Graphik TH" pitchFamily="34" charset="-120"/>
+              </a:rPr>
+              <a:t>Low-stickiness customers are numerous but barely funded; rate-sensitive customers are few but hold seven baht in ten.</a:t>
+            </a:r>
+            <a:endParaRPr lang="en-US" sz="1400" dirty="0"/>
+          </a:p>
+        </p:txBody>
+      </p:sp>
+      <p:sp>
+        <p:nvSpPr>
+          <p:cNvPr id="6" name="Shape 4"/>
+          <p:cNvSpPr/>
+          <p:nvPr/>
+        </p:nvSpPr>
+        <p:spPr>
+          <a:xfrm>
+            <a:off x="530352" y="1645920"/>
+            <a:ext cx="2647188" cy="987552"/>
+          </a:xfrm>
+          <a:prstGeom prst="roundRect">
+            <a:avLst>
+              <a:gd name="adj" fmla="val 8333"/>
+            </a:avLst>
+          </a:prstGeom>
+          <a:solidFill>
+            <a:srgbClr val="F1F4F9"/>
+          </a:solidFill>
+          <a:ln/>
+        </p:spPr>
+      </p:sp>
+      <p:sp>
+        <p:nvSpPr>
+          <p:cNvPr id="7" name="Text 5"/>
+          <p:cNvSpPr/>
+          <p:nvPr/>
+        </p:nvSpPr>
+        <p:spPr>
+          <a:xfrm>
+            <a:off x="749808" y="1719072"/>
+            <a:ext cx="2208276" cy="402336"/>
+          </a:xfrm>
+          <a:prstGeom prst="rect">
+            <a:avLst/>
+          </a:prstGeom>
+          <a:noFill/>
+          <a:ln/>
+        </p:spPr>
+        <p:txBody>
+          <a:bodyPr wrap="square" lIns="0" tIns="0" rIns="0" bIns="0" rtlCol="0" anchor="ctr"/>
+          <a:lstStyle/>
+          <a:p>
+            <a:pPr indent="0" marL="0">
+              <a:buNone/>
+            </a:pPr>
+            <a:r>
+              <a:rPr lang="en-US" sz="2400" b="1" dirty="0">
+                <a:solidFill>
+                  <a:srgbClr val="E9A03B"/>
+                </a:solidFill>
+                <a:latin typeface="Graphik TH" pitchFamily="34" charset="0"/>
+                <a:ea typeface="Graphik TH" pitchFamily="34" charset="-122"/>
+                <a:cs typeface="Graphik TH" pitchFamily="34" charset="-120"/>
+              </a:rPr>
+              <a:t>67.9k</a:t>
+            </a:r>
+            <a:endParaRPr lang="en-US" sz="2400" dirty="0"/>
+          </a:p>
+        </p:txBody>
+      </p:sp>
+      <p:sp>
+        <p:nvSpPr>
+          <p:cNvPr id="8" name="Text 6"/>
+          <p:cNvSpPr/>
+          <p:nvPr/>
+        </p:nvSpPr>
+        <p:spPr>
+          <a:xfrm>
+            <a:off x="749808" y="2121408"/>
+            <a:ext cx="2208276" cy="237744"/>
+          </a:xfrm>
+          <a:prstGeom prst="rect">
+            <a:avLst/>
+          </a:prstGeom>
+          <a:noFill/>
+          <a:ln/>
+        </p:spPr>
+        <p:txBody>
+          <a:bodyPr wrap="square" lIns="0" tIns="0" rIns="0" bIns="0" rtlCol="0" anchor="t"/>
+          <a:lstStyle/>
+          <a:p>
+            <a:pPr indent="0" marL="0">
+              <a:buNone/>
+            </a:pPr>
+            <a:r>
+              <a:rPr lang="en-US" sz="1150" b="1" dirty="0">
+                <a:solidFill>
+                  <a:srgbClr val="16233D"/>
+                </a:solidFill>
+                <a:latin typeface="Graphik TH" pitchFamily="34" charset="0"/>
+                <a:ea typeface="Graphik TH" pitchFamily="34" charset="-122"/>
+                <a:cs typeface="Graphik TH" pitchFamily="34" charset="-120"/>
+              </a:rPr>
+              <a:t>low-stickiness customers</a:t>
+            </a:r>
+            <a:endParaRPr lang="en-US" sz="1150" dirty="0"/>
+          </a:p>
+        </p:txBody>
+      </p:sp>
+      <p:sp>
+        <p:nvSpPr>
+          <p:cNvPr id="9" name="Text 7"/>
+          <p:cNvSpPr/>
+          <p:nvPr/>
+        </p:nvSpPr>
+        <p:spPr>
+          <a:xfrm>
+            <a:off x="749808" y="2350008"/>
+            <a:ext cx="2208276" cy="237744"/>
+          </a:xfrm>
+          <a:prstGeom prst="rect">
+            <a:avLst/>
+          </a:prstGeom>
+          <a:noFill/>
+          <a:ln/>
+        </p:spPr>
+        <p:txBody>
+          <a:bodyPr wrap="square" lIns="0" tIns="0" rIns="0" bIns="0" rtlCol="0" anchor="t"/>
+          <a:lstStyle/>
+          <a:p>
+            <a:pPr indent="0" marL="0">
+              <a:buNone/>
+            </a:pPr>
+            <a:r>
+              <a:rPr lang="en-US" sz="950" dirty="0">
+                <a:solidFill>
+                  <a:srgbClr val="6B7A90"/>
+                </a:solidFill>
+                <a:latin typeface="Graphik TH" pitchFamily="34" charset="0"/>
+                <a:ea typeface="Graphik TH" pitchFamily="34" charset="-122"/>
+                <a:cs typeface="Graphik TH" pitchFamily="34" charset="-120"/>
+              </a:rPr>
+              <a:t>21.2% of the funded base</a:t>
+            </a:r>
+            <a:endParaRPr lang="en-US" sz="950" dirty="0"/>
+          </a:p>
+        </p:txBody>
+      </p:sp>
+      <p:sp>
+        <p:nvSpPr>
+          <p:cNvPr id="10" name="Shape 8"/>
+          <p:cNvSpPr/>
+          <p:nvPr/>
+        </p:nvSpPr>
+        <p:spPr>
+          <a:xfrm>
+            <a:off x="3406140" y="1645920"/>
+            <a:ext cx="2647188" cy="987552"/>
+          </a:xfrm>
+          <a:prstGeom prst="roundRect">
+            <a:avLst>
+              <a:gd name="adj" fmla="val 8333"/>
+            </a:avLst>
+          </a:prstGeom>
+          <a:solidFill>
+            <a:srgbClr val="F1F4F9"/>
+          </a:solidFill>
+          <a:ln/>
+        </p:spPr>
+      </p:sp>
+      <p:sp>
+        <p:nvSpPr>
+          <p:cNvPr id="11" name="Text 9"/>
+          <p:cNvSpPr/>
+          <p:nvPr/>
+        </p:nvSpPr>
+        <p:spPr>
+          <a:xfrm>
+            <a:off x="3625596" y="1719072"/>
+            <a:ext cx="2208276" cy="402336"/>
+          </a:xfrm>
+          <a:prstGeom prst="rect">
+            <a:avLst/>
+          </a:prstGeom>
+          <a:noFill/>
+          <a:ln/>
+        </p:spPr>
+        <p:txBody>
+          <a:bodyPr wrap="square" lIns="0" tIns="0" rIns="0" bIns="0" rtlCol="0" anchor="ctr"/>
+          <a:lstStyle/>
+          <a:p>
+            <a:pPr indent="0" marL="0">
+              <a:buNone/>
+            </a:pPr>
+            <a:r>
+              <a:rPr lang="en-US" sz="2400" b="1" dirty="0">
+                <a:solidFill>
+                  <a:srgbClr val="E9A03B"/>
+                </a:solidFill>
+                <a:latin typeface="Graphik TH" pitchFamily="34" charset="0"/>
+                <a:ea typeface="Graphik TH" pitchFamily="34" charset="-122"/>
+                <a:cs typeface="Graphik TH" pitchFamily="34" charset="-120"/>
+              </a:rPr>
+              <a:t>THB 16.7m</a:t>
+            </a:r>
+            <a:endParaRPr lang="en-US" sz="2400" dirty="0"/>
+          </a:p>
+        </p:txBody>
+      </p:sp>
+      <p:sp>
+        <p:nvSpPr>
+          <p:cNvPr id="12" name="Text 10"/>
+          <p:cNvSpPr/>
+          <p:nvPr/>
+        </p:nvSpPr>
+        <p:spPr>
+          <a:xfrm>
+            <a:off x="3625596" y="2121408"/>
+            <a:ext cx="2208276" cy="237744"/>
+          </a:xfrm>
+          <a:prstGeom prst="rect">
+            <a:avLst/>
+          </a:prstGeom>
+          <a:noFill/>
+          <a:ln/>
+        </p:spPr>
+        <p:txBody>
+          <a:bodyPr wrap="square" lIns="0" tIns="0" rIns="0" bIns="0" rtlCol="0" anchor="t"/>
+          <a:lstStyle/>
+          <a:p>
+            <a:pPr indent="0" marL="0">
+              <a:buNone/>
+            </a:pPr>
+            <a:r>
+              <a:rPr lang="en-US" sz="1150" b="1" dirty="0">
+                <a:solidFill>
+                  <a:srgbClr val="16233D"/>
+                </a:solidFill>
+                <a:latin typeface="Graphik TH" pitchFamily="34" charset="0"/>
+                <a:ea typeface="Graphik TH" pitchFamily="34" charset="-122"/>
+                <a:cs typeface="Graphik TH" pitchFamily="34" charset="-120"/>
+              </a:rPr>
+              <a:t>balance they hold</a:t>
+            </a:r>
+            <a:endParaRPr lang="en-US" sz="1150" dirty="0"/>
+          </a:p>
+        </p:txBody>
+      </p:sp>
+      <p:sp>
+        <p:nvSpPr>
+          <p:cNvPr id="13" name="Text 11"/>
+          <p:cNvSpPr/>
+          <p:nvPr/>
+        </p:nvSpPr>
+        <p:spPr>
+          <a:xfrm>
+            <a:off x="3625596" y="2350008"/>
+            <a:ext cx="2208276" cy="237744"/>
+          </a:xfrm>
+          <a:prstGeom prst="rect">
+            <a:avLst/>
+          </a:prstGeom>
+          <a:noFill/>
+          <a:ln/>
+        </p:spPr>
+        <p:txBody>
+          <a:bodyPr wrap="square" lIns="0" tIns="0" rIns="0" bIns="0" rtlCol="0" anchor="t"/>
+          <a:lstStyle/>
+          <a:p>
+            <a:pPr indent="0" marL="0">
+              <a:buNone/>
+            </a:pPr>
+            <a:r>
+              <a:rPr lang="en-US" sz="950" dirty="0">
+                <a:solidFill>
+                  <a:srgbClr val="6B7A90"/>
+                </a:solidFill>
+                <a:latin typeface="Graphik TH" pitchFamily="34" charset="0"/>
+                <a:ea typeface="Graphik TH" pitchFamily="34" charset="-122"/>
+                <a:cs typeface="Graphik TH" pitchFamily="34" charset="-120"/>
+              </a:rPr>
+              <a:t>0.3% of the deposit book</a:t>
+            </a:r>
+            <a:endParaRPr lang="en-US" sz="950" dirty="0"/>
+          </a:p>
+        </p:txBody>
+      </p:sp>
+      <p:sp>
+        <p:nvSpPr>
+          <p:cNvPr id="14" name="Shape 12"/>
+          <p:cNvSpPr/>
+          <p:nvPr/>
+        </p:nvSpPr>
+        <p:spPr>
+          <a:xfrm>
+            <a:off x="6281928" y="1645920"/>
+            <a:ext cx="2647188" cy="987552"/>
+          </a:xfrm>
+          <a:prstGeom prst="roundRect">
+            <a:avLst>
+              <a:gd name="adj" fmla="val 8333"/>
+            </a:avLst>
+          </a:prstGeom>
+          <a:solidFill>
+            <a:srgbClr val="F1F4F9"/>
+          </a:solidFill>
+          <a:ln/>
+        </p:spPr>
+      </p:sp>
+      <p:sp>
+        <p:nvSpPr>
+          <p:cNvPr id="15" name="Text 13"/>
+          <p:cNvSpPr/>
+          <p:nvPr/>
+        </p:nvSpPr>
+        <p:spPr>
+          <a:xfrm>
+            <a:off x="6501384" y="1719072"/>
+            <a:ext cx="2208276" cy="402336"/>
+          </a:xfrm>
+          <a:prstGeom prst="rect">
+            <a:avLst/>
+          </a:prstGeom>
+          <a:noFill/>
+          <a:ln/>
+        </p:spPr>
+        <p:txBody>
+          <a:bodyPr wrap="square" lIns="0" tIns="0" rIns="0" bIns="0" rtlCol="0" anchor="ctr"/>
+          <a:lstStyle/>
+          <a:p>
+            <a:pPr indent="0" marL="0">
+              <a:buNone/>
+            </a:pPr>
+            <a:r>
+              <a:rPr lang="en-US" sz="2400" b="1" dirty="0">
+                <a:solidFill>
+                  <a:srgbClr val="C00000"/>
+                </a:solidFill>
+                <a:latin typeface="Graphik TH" pitchFamily="34" charset="0"/>
+                <a:ea typeface="Graphik TH" pitchFamily="34" charset="-122"/>
+                <a:cs typeface="Graphik TH" pitchFamily="34" charset="-120"/>
+              </a:rPr>
+              <a:t>25.0k</a:t>
+            </a:r>
+            <a:endParaRPr lang="en-US" sz="2400" dirty="0"/>
+          </a:p>
+        </p:txBody>
+      </p:sp>
+      <p:sp>
+        <p:nvSpPr>
+          <p:cNvPr id="16" name="Text 14"/>
+          <p:cNvSpPr/>
+          <p:nvPr/>
+        </p:nvSpPr>
+        <p:spPr>
+          <a:xfrm>
+            <a:off x="6501384" y="2121408"/>
+            <a:ext cx="2208276" cy="237744"/>
+          </a:xfrm>
+          <a:prstGeom prst="rect">
+            <a:avLst/>
+          </a:prstGeom>
+          <a:noFill/>
+          <a:ln/>
+        </p:spPr>
+        <p:txBody>
+          <a:bodyPr wrap="square" lIns="0" tIns="0" rIns="0" bIns="0" rtlCol="0" anchor="t"/>
+          <a:lstStyle/>
+          <a:p>
+            <a:pPr indent="0" marL="0">
+              <a:buNone/>
+            </a:pPr>
+            <a:r>
+              <a:rPr lang="en-US" sz="1150" b="1" dirty="0">
+                <a:solidFill>
+                  <a:srgbClr val="16233D"/>
+                </a:solidFill>
+                <a:latin typeface="Graphik TH" pitchFamily="34" charset="0"/>
+                <a:ea typeface="Graphik TH" pitchFamily="34" charset="-122"/>
+                <a:cs typeface="Graphik TH" pitchFamily="34" charset="-120"/>
+              </a:rPr>
+              <a:t>rate-sensitive customers</a:t>
+            </a:r>
+            <a:endParaRPr lang="en-US" sz="1150" dirty="0"/>
+          </a:p>
+        </p:txBody>
+      </p:sp>
+      <p:sp>
+        <p:nvSpPr>
+          <p:cNvPr id="17" name="Text 15"/>
+          <p:cNvSpPr/>
+          <p:nvPr/>
+        </p:nvSpPr>
+        <p:spPr>
+          <a:xfrm>
+            <a:off x="6501384" y="2350008"/>
+            <a:ext cx="2208276" cy="237744"/>
+          </a:xfrm>
+          <a:prstGeom prst="rect">
+            <a:avLst/>
+          </a:prstGeom>
+          <a:noFill/>
+          <a:ln/>
+        </p:spPr>
+        <p:txBody>
+          <a:bodyPr wrap="square" lIns="0" tIns="0" rIns="0" bIns="0" rtlCol="0" anchor="t"/>
+          <a:lstStyle/>
+          <a:p>
+            <a:pPr indent="0" marL="0">
+              <a:buNone/>
+            </a:pPr>
+            <a:r>
+              <a:rPr lang="en-US" sz="950" dirty="0">
+                <a:solidFill>
+                  <a:srgbClr val="6B7A90"/>
+                </a:solidFill>
+                <a:latin typeface="Graphik TH" pitchFamily="34" charset="0"/>
+                <a:ea typeface="Graphik TH" pitchFamily="34" charset="-122"/>
+                <a:cs typeface="Graphik TH" pitchFamily="34" charset="-120"/>
+              </a:rPr>
+              <a:t>7.8% of the funded base · RS ≥ 60</a:t>
+            </a:r>
+            <a:endParaRPr lang="en-US" sz="950" dirty="0"/>
+          </a:p>
+        </p:txBody>
+      </p:sp>
+      <p:sp>
+        <p:nvSpPr>
+          <p:cNvPr id="18" name="Shape 16"/>
+          <p:cNvSpPr/>
+          <p:nvPr/>
+        </p:nvSpPr>
+        <p:spPr>
+          <a:xfrm>
+            <a:off x="9157716" y="1645920"/>
+            <a:ext cx="2647188" cy="987552"/>
+          </a:xfrm>
+          <a:prstGeom prst="roundRect">
+            <a:avLst>
+              <a:gd name="adj" fmla="val 8333"/>
+            </a:avLst>
+          </a:prstGeom>
+          <a:solidFill>
+            <a:srgbClr val="F1F4F9"/>
+          </a:solidFill>
+          <a:ln/>
+        </p:spPr>
+      </p:sp>
+      <p:sp>
+        <p:nvSpPr>
+          <p:cNvPr id="19" name="Text 17"/>
+          <p:cNvSpPr/>
+          <p:nvPr/>
+        </p:nvSpPr>
+        <p:spPr>
+          <a:xfrm>
+            <a:off x="9377172" y="1719072"/>
+            <a:ext cx="2208276" cy="402336"/>
+          </a:xfrm>
+          <a:prstGeom prst="rect">
+            <a:avLst/>
+          </a:prstGeom>
+          <a:noFill/>
+          <a:ln/>
+        </p:spPr>
+        <p:txBody>
+          <a:bodyPr wrap="square" lIns="0" tIns="0" rIns="0" bIns="0" rtlCol="0" anchor="ctr"/>
+          <a:lstStyle/>
+          <a:p>
+            <a:pPr indent="0" marL="0">
+              <a:buNone/>
+            </a:pPr>
+            <a:r>
+              <a:rPr lang="en-US" sz="2400" b="1" dirty="0">
+                <a:solidFill>
+                  <a:srgbClr val="C00000"/>
+                </a:solidFill>
+                <a:latin typeface="Graphik TH" pitchFamily="34" charset="0"/>
+                <a:ea typeface="Graphik TH" pitchFamily="34" charset="-122"/>
+                <a:cs typeface="Graphik TH" pitchFamily="34" charset="-120"/>
+              </a:rPr>
+              <a:t>THB 3.83bn</a:t>
+            </a:r>
+            <a:endParaRPr lang="en-US" sz="2400" dirty="0"/>
+          </a:p>
+        </p:txBody>
+      </p:sp>
+      <p:sp>
+        <p:nvSpPr>
+          <p:cNvPr id="20" name="Text 18"/>
+          <p:cNvSpPr/>
+          <p:nvPr/>
+        </p:nvSpPr>
+        <p:spPr>
+          <a:xfrm>
+            <a:off x="9377172" y="2121408"/>
+            <a:ext cx="2208276" cy="237744"/>
+          </a:xfrm>
+          <a:prstGeom prst="rect">
+            <a:avLst/>
+          </a:prstGeom>
+          <a:noFill/>
+          <a:ln/>
+        </p:spPr>
+        <p:txBody>
+          <a:bodyPr wrap="square" lIns="0" tIns="0" rIns="0" bIns="0" rtlCol="0" anchor="t"/>
+          <a:lstStyle/>
+          <a:p>
+            <a:pPr indent="0" marL="0">
+              <a:buNone/>
+            </a:pPr>
+            <a:r>
+              <a:rPr lang="en-US" sz="1150" b="1" dirty="0">
+                <a:solidFill>
+                  <a:srgbClr val="16233D"/>
+                </a:solidFill>
+                <a:latin typeface="Graphik TH" pitchFamily="34" charset="0"/>
+                <a:ea typeface="Graphik TH" pitchFamily="34" charset="-122"/>
+                <a:cs typeface="Graphik TH" pitchFamily="34" charset="-120"/>
+              </a:rPr>
+              <a:t>balance at risk</a:t>
+            </a:r>
+            <a:endParaRPr lang="en-US" sz="1150" dirty="0"/>
+          </a:p>
+        </p:txBody>
+      </p:sp>
+      <p:sp>
+        <p:nvSpPr>
+          <p:cNvPr id="21" name="Text 19"/>
+          <p:cNvSpPr/>
+          <p:nvPr/>
+        </p:nvSpPr>
+        <p:spPr>
+          <a:xfrm>
+            <a:off x="9377172" y="2350008"/>
+            <a:ext cx="2208276" cy="237744"/>
+          </a:xfrm>
+          <a:prstGeom prst="rect">
+            <a:avLst/>
+          </a:prstGeom>
+          <a:noFill/>
+          <a:ln/>
+        </p:spPr>
+        <p:txBody>
+          <a:bodyPr wrap="square" lIns="0" tIns="0" rIns="0" bIns="0" rtlCol="0" anchor="t"/>
+          <a:lstStyle/>
+          <a:p>
+            <a:pPr indent="0" marL="0">
+              <a:buNone/>
+            </a:pPr>
+            <a:r>
+              <a:rPr lang="en-US" sz="950" dirty="0">
+                <a:solidFill>
+                  <a:srgbClr val="6B7A90"/>
+                </a:solidFill>
+                <a:latin typeface="Graphik TH" pitchFamily="34" charset="0"/>
+                <a:ea typeface="Graphik TH" pitchFamily="34" charset="-122"/>
+                <a:cs typeface="Graphik TH" pitchFamily="34" charset="-120"/>
+              </a:rPr>
+              <a:t>70% of the deposit book</a:t>
+            </a:r>
+            <a:endParaRPr lang="en-US" sz="950" dirty="0"/>
+          </a:p>
+        </p:txBody>
+      </p:sp>
+      <p:sp>
+        <p:nvSpPr>
+          <p:cNvPr id="22" name="Shape 20"/>
+          <p:cNvSpPr/>
+          <p:nvPr/>
+        </p:nvSpPr>
+        <p:spPr>
+          <a:xfrm>
+            <a:off x="530352" y="2798064"/>
+            <a:ext cx="6720840" cy="2322576"/>
+          </a:xfrm>
+          <a:prstGeom prst="roundRect">
+            <a:avLst>
+              <a:gd name="adj" fmla="val 3543"/>
+            </a:avLst>
+          </a:prstGeom>
+          <a:solidFill>
+            <a:srgbClr val="F1F4F9"/>
+          </a:solidFill>
+          <a:ln/>
+        </p:spPr>
+      </p:sp>
+      <p:sp>
+        <p:nvSpPr>
+          <p:cNvPr id="23" name="Text 21"/>
+          <p:cNvSpPr/>
+          <p:nvPr/>
+        </p:nvSpPr>
+        <p:spPr>
+          <a:xfrm>
+            <a:off x="786384" y="2944368"/>
+            <a:ext cx="6208776" cy="274320"/>
+          </a:xfrm>
+          <a:prstGeom prst="rect">
+            <a:avLst/>
+          </a:prstGeom>
+          <a:noFill/>
+          <a:ln/>
+        </p:spPr>
+        <p:txBody>
+          <a:bodyPr wrap="square" lIns="0" tIns="0" rIns="0" bIns="0" rtlCol="0" anchor="ctr"/>
+          <a:lstStyle/>
+          <a:p>
+            <a:pPr indent="0" marL="0">
+              <a:buNone/>
+            </a:pPr>
+            <a:r>
+              <a:rPr lang="en-US" sz="1400" b="1" dirty="0">
+                <a:solidFill>
+                  <a:srgbClr val="16233D"/>
+                </a:solidFill>
+                <a:latin typeface="Cambria" pitchFamily="34" charset="0"/>
+                <a:ea typeface="Cambria" pitchFamily="34" charset="-122"/>
+                <a:cs typeface="Cambria" pitchFamily="34" charset="-120"/>
+              </a:rPr>
+              <a:t>Share of customers against share of balance</a:t>
+            </a:r>
+            <a:endParaRPr lang="en-US" sz="1400" dirty="0"/>
+          </a:p>
+        </p:txBody>
+      </p:sp>
+      <p:sp>
+        <p:nvSpPr>
+          <p:cNvPr id="24" name="Text 22"/>
+          <p:cNvSpPr/>
+          <p:nvPr/>
+        </p:nvSpPr>
+        <p:spPr>
+          <a:xfrm>
+            <a:off x="786384" y="3218688"/>
+            <a:ext cx="6208776" cy="237744"/>
+          </a:xfrm>
+          <a:prstGeom prst="rect">
+            <a:avLst/>
+          </a:prstGeom>
+          <a:noFill/>
+          <a:ln/>
+        </p:spPr>
+        <p:txBody>
+          <a:bodyPr wrap="square" lIns="0" tIns="0" rIns="0" bIns="0" rtlCol="0" anchor="ctr"/>
+          <a:lstStyle/>
+          <a:p>
+            <a:pPr indent="0" marL="0">
+              <a:buNone/>
+            </a:pPr>
+            <a:r>
+              <a:rPr lang="en-US" sz="950" dirty="0">
+                <a:solidFill>
+                  <a:srgbClr val="6B7A90"/>
+                </a:solidFill>
+                <a:latin typeface="Graphik TH" pitchFamily="34" charset="0"/>
+                <a:ea typeface="Graphik TH" pitchFamily="34" charset="-122"/>
+                <a:cs typeface="Graphik TH" pitchFamily="34" charset="-120"/>
+              </a:rPr>
+              <a:t>Each bar is a percentage of the funded base · full track = 100%</a:t>
+            </a:r>
+            <a:endParaRPr lang="en-US" sz="950" dirty="0"/>
+          </a:p>
+        </p:txBody>
+      </p:sp>
+      <p:sp>
+        <p:nvSpPr>
+          <p:cNvPr id="25" name="Text 23"/>
+          <p:cNvSpPr/>
+          <p:nvPr/>
+        </p:nvSpPr>
+        <p:spPr>
+          <a:xfrm>
+            <a:off x="786384" y="3401568"/>
+            <a:ext cx="6217920" cy="219456"/>
+          </a:xfrm>
+          <a:prstGeom prst="rect">
+            <a:avLst/>
+          </a:prstGeom>
+          <a:noFill/>
+          <a:ln/>
+        </p:spPr>
+        <p:txBody>
+          <a:bodyPr wrap="square" lIns="0" tIns="0" rIns="0" bIns="0" rtlCol="0" anchor="ctr"/>
+          <a:lstStyle/>
+          <a:p>
+            <a:pPr indent="0" marL="0">
+              <a:buNone/>
+            </a:pPr>
+            <a:r>
+              <a:rPr lang="en-US" sz="1050" b="1" dirty="0">
+                <a:solidFill>
+                  <a:srgbClr val="E9A03B"/>
+                </a:solidFill>
+                <a:latin typeface="Graphik TH" pitchFamily="34" charset="0"/>
+                <a:ea typeface="Graphik TH" pitchFamily="34" charset="-122"/>
+                <a:cs typeface="Graphik TH" pitchFamily="34" charset="-120"/>
+              </a:rPr>
+              <a:t>Low stickiness  ·  score &lt; 40</a:t>
+            </a:r>
+            <a:endParaRPr lang="en-US" sz="1050" dirty="0"/>
+          </a:p>
+        </p:txBody>
+      </p:sp>
+      <p:sp>
+        <p:nvSpPr>
+          <p:cNvPr id="26" name="Text 24"/>
+          <p:cNvSpPr/>
+          <p:nvPr/>
+        </p:nvSpPr>
+        <p:spPr>
+          <a:xfrm>
+            <a:off x="786384" y="3639312"/>
+            <a:ext cx="1828800" cy="256032"/>
+          </a:xfrm>
+          <a:prstGeom prst="rect">
+            <a:avLst/>
+          </a:prstGeom>
+          <a:noFill/>
+          <a:ln/>
+        </p:spPr>
+        <p:txBody>
+          <a:bodyPr wrap="square" lIns="0" tIns="0" rIns="0" bIns="0" rtlCol="0" anchor="ctr"/>
+          <a:lstStyle/>
+          <a:p>
+            <a:pPr indent="0" marL="0">
+              <a:buNone/>
+            </a:pPr>
+            <a:r>
+              <a:rPr lang="en-US" sz="1000" dirty="0">
+                <a:solidFill>
+                  <a:srgbClr val="16233D"/>
+                </a:solidFill>
+                <a:latin typeface="Graphik TH" pitchFamily="34" charset="0"/>
+                <a:ea typeface="Graphik TH" pitchFamily="34" charset="-122"/>
+                <a:cs typeface="Graphik TH" pitchFamily="34" charset="-120"/>
+              </a:rPr>
+              <a:t>Share of customers</a:t>
+            </a:r>
+            <a:endParaRPr lang="en-US" sz="1000" dirty="0"/>
+          </a:p>
+        </p:txBody>
+      </p:sp>
+      <p:sp>
+        <p:nvSpPr>
+          <p:cNvPr id="27" name="Shape 25"/>
+          <p:cNvSpPr/>
+          <p:nvPr/>
+        </p:nvSpPr>
+        <p:spPr>
+          <a:xfrm>
+            <a:off x="2670048" y="3675888"/>
+            <a:ext cx="3154680" cy="182880"/>
+          </a:xfrm>
+          <a:prstGeom prst="roundRect">
+            <a:avLst>
+              <a:gd name="adj" fmla="val 15000"/>
+            </a:avLst>
+          </a:prstGeom>
+          <a:solidFill>
+            <a:srgbClr val="E4E9F0"/>
+          </a:solidFill>
+          <a:ln/>
+        </p:spPr>
+      </p:sp>
+      <p:sp>
+        <p:nvSpPr>
+          <p:cNvPr id="28" name="Shape 26"/>
+          <p:cNvSpPr/>
+          <p:nvPr/>
+        </p:nvSpPr>
+        <p:spPr>
+          <a:xfrm>
+            <a:off x="2670048" y="3675888"/>
+            <a:ext cx="669106" cy="182880"/>
+          </a:xfrm>
+          <a:prstGeom prst="roundRect">
+            <a:avLst>
+              <a:gd name="adj" fmla="val 15000"/>
+            </a:avLst>
+          </a:prstGeom>
+          <a:solidFill>
+            <a:srgbClr val="E9A03B"/>
+          </a:solidFill>
+          <a:ln/>
+        </p:spPr>
+      </p:sp>
+      <p:sp>
+        <p:nvSpPr>
+          <p:cNvPr id="29" name="Text 27"/>
+          <p:cNvSpPr/>
+          <p:nvPr/>
+        </p:nvSpPr>
+        <p:spPr>
+          <a:xfrm>
+            <a:off x="5925312" y="3639312"/>
+            <a:ext cx="1088136" cy="256032"/>
+          </a:xfrm>
+          <a:prstGeom prst="rect">
+            <a:avLst/>
+          </a:prstGeom>
+          <a:noFill/>
+          <a:ln/>
+        </p:spPr>
+        <p:txBody>
+          <a:bodyPr wrap="square" lIns="0" tIns="0" rIns="0" bIns="0" rtlCol="0" anchor="ctr"/>
+          <a:lstStyle/>
+          <a:p>
+            <a:pPr algn="r" indent="0" marL="0">
+              <a:buNone/>
+            </a:pPr>
+            <a:r>
+              <a:rPr lang="en-US" sz="1050" b="1" dirty="0">
+                <a:solidFill>
+                  <a:srgbClr val="E9A03B"/>
+                </a:solidFill>
+                <a:latin typeface="Graphik TH" pitchFamily="34" charset="0"/>
+                <a:ea typeface="Graphik TH" pitchFamily="34" charset="-122"/>
+                <a:cs typeface="Graphik TH" pitchFamily="34" charset="-120"/>
+              </a:rPr>
+              <a:t>21.2%</a:t>
+            </a:r>
+            <a:endParaRPr lang="en-US" sz="1050" dirty="0"/>
+          </a:p>
+        </p:txBody>
+      </p:sp>
+      <p:sp>
+        <p:nvSpPr>
+          <p:cNvPr id="30" name="Text 28"/>
+          <p:cNvSpPr/>
+          <p:nvPr/>
+        </p:nvSpPr>
+        <p:spPr>
+          <a:xfrm>
+            <a:off x="786384" y="3931920"/>
+            <a:ext cx="1828800" cy="256032"/>
+          </a:xfrm>
+          <a:prstGeom prst="rect">
+            <a:avLst/>
+          </a:prstGeom>
+          <a:noFill/>
+          <a:ln/>
+        </p:spPr>
+        <p:txBody>
+          <a:bodyPr wrap="square" lIns="0" tIns="0" rIns="0" bIns="0" rtlCol="0" anchor="ctr"/>
+          <a:lstStyle/>
+          <a:p>
+            <a:pPr indent="0" marL="0">
+              <a:buNone/>
+            </a:pPr>
+            <a:r>
+              <a:rPr lang="en-US" sz="1000" dirty="0">
+                <a:solidFill>
+                  <a:srgbClr val="16233D"/>
+                </a:solidFill>
+                <a:latin typeface="Graphik TH" pitchFamily="34" charset="0"/>
+                <a:ea typeface="Graphik TH" pitchFamily="34" charset="-122"/>
+                <a:cs typeface="Graphik TH" pitchFamily="34" charset="-120"/>
+              </a:rPr>
+              <a:t>Share of balance</a:t>
+            </a:r>
+            <a:endParaRPr lang="en-US" sz="1000" dirty="0"/>
+          </a:p>
+        </p:txBody>
+      </p:sp>
+      <p:sp>
+        <p:nvSpPr>
+          <p:cNvPr id="31" name="Shape 29"/>
+          <p:cNvSpPr/>
+          <p:nvPr/>
+        </p:nvSpPr>
+        <p:spPr>
+          <a:xfrm>
+            <a:off x="2670048" y="3968496"/>
+            <a:ext cx="3154680" cy="182880"/>
+          </a:xfrm>
+          <a:prstGeom prst="roundRect">
+            <a:avLst>
+              <a:gd name="adj" fmla="val 15000"/>
+            </a:avLst>
+          </a:prstGeom>
+          <a:solidFill>
+            <a:srgbClr val="E4E9F0"/>
+          </a:solidFill>
+          <a:ln/>
+        </p:spPr>
+      </p:sp>
+      <p:sp>
+        <p:nvSpPr>
+          <p:cNvPr id="32" name="Shape 30"/>
+          <p:cNvSpPr/>
+          <p:nvPr/>
+        </p:nvSpPr>
+        <p:spPr>
+          <a:xfrm>
+            <a:off x="2670048" y="3968496"/>
+            <a:ext cx="45720" cy="182880"/>
+          </a:xfrm>
+          <a:prstGeom prst="roundRect">
+            <a:avLst>
+              <a:gd name="adj" fmla="val 60000"/>
+            </a:avLst>
+          </a:prstGeom>
+          <a:solidFill>
+            <a:srgbClr val="E9A03B"/>
+          </a:solidFill>
+          <a:ln/>
+        </p:spPr>
+      </p:sp>
+      <p:sp>
+        <p:nvSpPr>
+          <p:cNvPr id="33" name="Text 31"/>
+          <p:cNvSpPr/>
+          <p:nvPr/>
+        </p:nvSpPr>
+        <p:spPr>
+          <a:xfrm>
+            <a:off x="5925312" y="3931920"/>
+            <a:ext cx="1088136" cy="256032"/>
+          </a:xfrm>
+          <a:prstGeom prst="rect">
+            <a:avLst/>
+          </a:prstGeom>
+          <a:noFill/>
+          <a:ln/>
+        </p:spPr>
+        <p:txBody>
+          <a:bodyPr wrap="square" lIns="0" tIns="0" rIns="0" bIns="0" rtlCol="0" anchor="ctr"/>
+          <a:lstStyle/>
+          <a:p>
+            <a:pPr algn="r" indent="0" marL="0">
+              <a:buNone/>
+            </a:pPr>
+            <a:r>
+              <a:rPr lang="en-US" sz="1050" b="1" dirty="0">
+                <a:solidFill>
+                  <a:srgbClr val="E9A03B"/>
+                </a:solidFill>
+                <a:latin typeface="Graphik TH" pitchFamily="34" charset="0"/>
+                <a:ea typeface="Graphik TH" pitchFamily="34" charset="-122"/>
+                <a:cs typeface="Graphik TH" pitchFamily="34" charset="-120"/>
+              </a:rPr>
+              <a:t>0.3%</a:t>
+            </a:r>
+            <a:endParaRPr lang="en-US" sz="1050" dirty="0"/>
+          </a:p>
+        </p:txBody>
+      </p:sp>
+      <p:sp>
+        <p:nvSpPr>
+          <p:cNvPr id="34" name="Text 32"/>
+          <p:cNvSpPr/>
+          <p:nvPr/>
+        </p:nvSpPr>
+        <p:spPr>
+          <a:xfrm>
+            <a:off x="786384" y="4261104"/>
+            <a:ext cx="6217920" cy="219456"/>
+          </a:xfrm>
+          <a:prstGeom prst="rect">
+            <a:avLst/>
+          </a:prstGeom>
+          <a:noFill/>
+          <a:ln/>
+        </p:spPr>
+        <p:txBody>
+          <a:bodyPr wrap="square" lIns="0" tIns="0" rIns="0" bIns="0" rtlCol="0" anchor="ctr"/>
+          <a:lstStyle/>
+          <a:p>
+            <a:pPr indent="0" marL="0">
+              <a:buNone/>
+            </a:pPr>
+            <a:r>
+              <a:rPr lang="en-US" sz="1050" b="1" dirty="0">
+                <a:solidFill>
+                  <a:srgbClr val="C00000"/>
+                </a:solidFill>
+                <a:latin typeface="Graphik TH" pitchFamily="34" charset="0"/>
+                <a:ea typeface="Graphik TH" pitchFamily="34" charset="-122"/>
+                <a:cs typeface="Graphik TH" pitchFamily="34" charset="-120"/>
+              </a:rPr>
+              <a:t>High rate sensitivity  ·  score ≥ 60</a:t>
+            </a:r>
+            <a:endParaRPr lang="en-US" sz="1050" dirty="0"/>
+          </a:p>
+        </p:txBody>
+      </p:sp>
+      <p:sp>
+        <p:nvSpPr>
+          <p:cNvPr id="35" name="Text 33"/>
+          <p:cNvSpPr/>
+          <p:nvPr/>
+        </p:nvSpPr>
+        <p:spPr>
+          <a:xfrm>
+            <a:off x="786384" y="4498848"/>
+            <a:ext cx="1828800" cy="256032"/>
+          </a:xfrm>
+          <a:prstGeom prst="rect">
+            <a:avLst/>
+          </a:prstGeom>
+          <a:noFill/>
+          <a:ln/>
+        </p:spPr>
+        <p:txBody>
+          <a:bodyPr wrap="square" lIns="0" tIns="0" rIns="0" bIns="0" rtlCol="0" anchor="ctr"/>
+          <a:lstStyle/>
+          <a:p>
+            <a:pPr indent="0" marL="0">
+              <a:buNone/>
+            </a:pPr>
+            <a:r>
+              <a:rPr lang="en-US" sz="1000" dirty="0">
+                <a:solidFill>
+                  <a:srgbClr val="16233D"/>
+                </a:solidFill>
+                <a:latin typeface="Graphik TH" pitchFamily="34" charset="0"/>
+                <a:ea typeface="Graphik TH" pitchFamily="34" charset="-122"/>
+                <a:cs typeface="Graphik TH" pitchFamily="34" charset="-120"/>
+              </a:rPr>
+              <a:t>Share of customers</a:t>
+            </a:r>
+            <a:endParaRPr lang="en-US" sz="1000" dirty="0"/>
+          </a:p>
+        </p:txBody>
+      </p:sp>
+      <p:sp>
+        <p:nvSpPr>
+          <p:cNvPr id="36" name="Shape 34"/>
+          <p:cNvSpPr/>
+          <p:nvPr/>
+        </p:nvSpPr>
+        <p:spPr>
+          <a:xfrm>
+            <a:off x="2670048" y="4535424"/>
+            <a:ext cx="3154680" cy="182880"/>
+          </a:xfrm>
+          <a:prstGeom prst="roundRect">
+            <a:avLst>
+              <a:gd name="adj" fmla="val 15000"/>
+            </a:avLst>
+          </a:prstGeom>
+          <a:solidFill>
+            <a:srgbClr val="E4E9F0"/>
+          </a:solidFill>
+          <a:ln/>
+        </p:spPr>
+      </p:sp>
+      <p:sp>
+        <p:nvSpPr>
+          <p:cNvPr id="37" name="Shape 35"/>
+          <p:cNvSpPr/>
+          <p:nvPr/>
+        </p:nvSpPr>
+        <p:spPr>
+          <a:xfrm>
+            <a:off x="2670048" y="4535424"/>
+            <a:ext cx="246090" cy="182880"/>
+          </a:xfrm>
+          <a:prstGeom prst="roundRect">
+            <a:avLst>
+              <a:gd name="adj" fmla="val 15000"/>
+            </a:avLst>
+          </a:prstGeom>
+          <a:solidFill>
+            <a:srgbClr val="C00000"/>
+          </a:solidFill>
+          <a:ln/>
+        </p:spPr>
+      </p:sp>
+      <p:sp>
+        <p:nvSpPr>
+          <p:cNvPr id="38" name="Text 36"/>
+          <p:cNvSpPr/>
+          <p:nvPr/>
+        </p:nvSpPr>
+        <p:spPr>
+          <a:xfrm>
+            <a:off x="5925312" y="4498848"/>
+            <a:ext cx="1088136" cy="256032"/>
+          </a:xfrm>
+          <a:prstGeom prst="rect">
+            <a:avLst/>
+          </a:prstGeom>
+          <a:noFill/>
+          <a:ln/>
+        </p:spPr>
+        <p:txBody>
+          <a:bodyPr wrap="square" lIns="0" tIns="0" rIns="0" bIns="0" rtlCol="0" anchor="ctr"/>
+          <a:lstStyle/>
+          <a:p>
+            <a:pPr algn="r" indent="0" marL="0">
+              <a:buNone/>
+            </a:pPr>
+            <a:r>
+              <a:rPr lang="en-US" sz="1050" b="1" dirty="0">
+                <a:solidFill>
+                  <a:srgbClr val="C00000"/>
+                </a:solidFill>
+                <a:latin typeface="Graphik TH" pitchFamily="34" charset="0"/>
+                <a:ea typeface="Graphik TH" pitchFamily="34" charset="-122"/>
+                <a:cs typeface="Graphik TH" pitchFamily="34" charset="-120"/>
+              </a:rPr>
+              <a:t>7.8%</a:t>
+            </a:r>
+            <a:endParaRPr lang="en-US" sz="1050" dirty="0"/>
+          </a:p>
+        </p:txBody>
+      </p:sp>
+      <p:sp>
+        <p:nvSpPr>
+          <p:cNvPr id="39" name="Text 37"/>
+          <p:cNvSpPr/>
+          <p:nvPr/>
+        </p:nvSpPr>
+        <p:spPr>
+          <a:xfrm>
+            <a:off x="786384" y="4791456"/>
+            <a:ext cx="1828800" cy="256032"/>
+          </a:xfrm>
+          <a:prstGeom prst="rect">
+            <a:avLst/>
+          </a:prstGeom>
+          <a:noFill/>
+          <a:ln/>
+        </p:spPr>
+        <p:txBody>
+          <a:bodyPr wrap="square" lIns="0" tIns="0" rIns="0" bIns="0" rtlCol="0" anchor="ctr"/>
+          <a:lstStyle/>
+          <a:p>
+            <a:pPr indent="0" marL="0">
+              <a:buNone/>
+            </a:pPr>
+            <a:r>
+              <a:rPr lang="en-US" sz="1000" dirty="0">
+                <a:solidFill>
+                  <a:srgbClr val="16233D"/>
+                </a:solidFill>
+                <a:latin typeface="Graphik TH" pitchFamily="34" charset="0"/>
+                <a:ea typeface="Graphik TH" pitchFamily="34" charset="-122"/>
+                <a:cs typeface="Graphik TH" pitchFamily="34" charset="-120"/>
+              </a:rPr>
+              <a:t>Share of balance</a:t>
+            </a:r>
+            <a:endParaRPr lang="en-US" sz="1000" dirty="0"/>
+          </a:p>
+        </p:txBody>
+      </p:sp>
+      <p:sp>
+        <p:nvSpPr>
+          <p:cNvPr id="40" name="Shape 38"/>
+          <p:cNvSpPr/>
+          <p:nvPr/>
+        </p:nvSpPr>
+        <p:spPr>
+          <a:xfrm>
+            <a:off x="2670048" y="4828032"/>
+            <a:ext cx="3154680" cy="182880"/>
+          </a:xfrm>
+          <a:prstGeom prst="roundRect">
+            <a:avLst>
+              <a:gd name="adj" fmla="val 15000"/>
+            </a:avLst>
+          </a:prstGeom>
+          <a:solidFill>
+            <a:srgbClr val="E4E9F0"/>
+          </a:solidFill>
+          <a:ln/>
+        </p:spPr>
+      </p:sp>
+      <p:sp>
+        <p:nvSpPr>
+          <p:cNvPr id="41" name="Shape 39"/>
+          <p:cNvSpPr/>
+          <p:nvPr/>
+        </p:nvSpPr>
+        <p:spPr>
+          <a:xfrm>
+            <a:off x="2670048" y="4828032"/>
+            <a:ext cx="2206080" cy="182880"/>
+          </a:xfrm>
+          <a:prstGeom prst="roundRect">
+            <a:avLst>
+              <a:gd name="adj" fmla="val 15000"/>
+            </a:avLst>
+          </a:prstGeom>
+          <a:solidFill>
+            <a:srgbClr val="C00000"/>
+          </a:solidFill>
+          <a:ln/>
+        </p:spPr>
+      </p:sp>
+      <p:sp>
+        <p:nvSpPr>
+          <p:cNvPr id="42" name="Text 40"/>
+          <p:cNvSpPr/>
+          <p:nvPr/>
+        </p:nvSpPr>
+        <p:spPr>
+          <a:xfrm>
+            <a:off x="5925312" y="4791456"/>
+            <a:ext cx="1088136" cy="256032"/>
+          </a:xfrm>
+          <a:prstGeom prst="rect">
+            <a:avLst/>
+          </a:prstGeom>
+          <a:noFill/>
+          <a:ln/>
+        </p:spPr>
+        <p:txBody>
+          <a:bodyPr wrap="square" lIns="0" tIns="0" rIns="0" bIns="0" rtlCol="0" anchor="ctr"/>
+          <a:lstStyle/>
+          <a:p>
+            <a:pPr algn="r" indent="0" marL="0">
+              <a:buNone/>
+            </a:pPr>
+            <a:r>
+              <a:rPr lang="en-US" sz="1050" b="1" dirty="0">
+                <a:solidFill>
+                  <a:srgbClr val="C00000"/>
+                </a:solidFill>
+                <a:latin typeface="Graphik TH" pitchFamily="34" charset="0"/>
+                <a:ea typeface="Graphik TH" pitchFamily="34" charset="-122"/>
+                <a:cs typeface="Graphik TH" pitchFamily="34" charset="-120"/>
+              </a:rPr>
+              <a:t>69.9%</a:t>
+            </a:r>
+            <a:endParaRPr lang="en-US" sz="1050" dirty="0"/>
+          </a:p>
+        </p:txBody>
+      </p:sp>
+      <p:sp>
+        <p:nvSpPr>
+          <p:cNvPr id="43" name="Shape 41"/>
+          <p:cNvSpPr/>
+          <p:nvPr/>
+        </p:nvSpPr>
+        <p:spPr>
+          <a:xfrm>
+            <a:off x="7479792" y="2798064"/>
+            <a:ext cx="4325112" cy="2322576"/>
+          </a:xfrm>
+          <a:prstGeom prst="roundRect">
+            <a:avLst>
+              <a:gd name="adj" fmla="val 3543"/>
+            </a:avLst>
+          </a:prstGeom>
+          <a:solidFill>
+            <a:srgbClr val="F1F4F9"/>
+          </a:solidFill>
+          <a:ln/>
+        </p:spPr>
+      </p:sp>
+      <p:sp>
+        <p:nvSpPr>
+          <p:cNvPr id="44" name="Text 42"/>
+          <p:cNvSpPr/>
+          <p:nvPr/>
+        </p:nvSpPr>
+        <p:spPr>
+          <a:xfrm>
+            <a:off x="7735824" y="2944368"/>
+            <a:ext cx="3813048" cy="274320"/>
+          </a:xfrm>
+          <a:prstGeom prst="rect">
+            <a:avLst/>
+          </a:prstGeom>
+          <a:noFill/>
+          <a:ln/>
+        </p:spPr>
+        <p:txBody>
+          <a:bodyPr wrap="square" lIns="0" tIns="0" rIns="0" bIns="0" rtlCol="0" anchor="ctr"/>
+          <a:lstStyle/>
+          <a:p>
+            <a:pPr indent="0" marL="0">
+              <a:buNone/>
+            </a:pPr>
+            <a:r>
+              <a:rPr lang="en-US" sz="1400" b="1" dirty="0">
+                <a:solidFill>
+                  <a:srgbClr val="16233D"/>
+                </a:solidFill>
+                <a:latin typeface="Cambria" pitchFamily="34" charset="0"/>
+                <a:ea typeface="Cambria" pitchFamily="34" charset="-122"/>
+                <a:cs typeface="Cambria" pitchFamily="34" charset="-120"/>
+              </a:rPr>
+              <a:t>Where the two lenses overlap</a:t>
+            </a:r>
+            <a:endParaRPr lang="en-US" sz="1400" dirty="0"/>
+          </a:p>
+        </p:txBody>
+      </p:sp>
+      <p:sp>
+        <p:nvSpPr>
+          <p:cNvPr id="45" name="Text 43"/>
+          <p:cNvSpPr/>
+          <p:nvPr/>
+        </p:nvSpPr>
+        <p:spPr>
+          <a:xfrm>
+            <a:off x="7735824" y="3218688"/>
+            <a:ext cx="3813048" cy="237744"/>
+          </a:xfrm>
+          <a:prstGeom prst="rect">
+            <a:avLst/>
+          </a:prstGeom>
+          <a:noFill/>
+          <a:ln/>
+        </p:spPr>
+        <p:txBody>
+          <a:bodyPr wrap="square" lIns="0" tIns="0" rIns="0" bIns="0" rtlCol="0" anchor="ctr"/>
+          <a:lstStyle/>
+          <a:p>
+            <a:pPr indent="0" marL="0">
+              <a:buNone/>
+            </a:pPr>
+            <a:r>
+              <a:rPr lang="en-US" sz="950" dirty="0">
+                <a:solidFill>
+                  <a:srgbClr val="6B7A90"/>
+                </a:solidFill>
+                <a:latin typeface="Graphik TH" pitchFamily="34" charset="0"/>
+                <a:ea typeface="Graphik TH" pitchFamily="34" charset="-122"/>
+                <a:cs typeface="Graphik TH" pitchFamily="34" charset="-120"/>
+              </a:rPr>
+              <a:t>Stickiness &lt; 60 and rate sensitivity ≥ 60</a:t>
+            </a:r>
+            <a:endParaRPr lang="en-US" sz="950" dirty="0"/>
+          </a:p>
+        </p:txBody>
+      </p:sp>
+      <p:sp>
+        <p:nvSpPr>
+          <p:cNvPr id="46" name="Text 44"/>
+          <p:cNvSpPr/>
+          <p:nvPr/>
+        </p:nvSpPr>
+        <p:spPr>
+          <a:xfrm>
+            <a:off x="7735824" y="3438144"/>
+            <a:ext cx="2011680" cy="402336"/>
+          </a:xfrm>
+          <a:prstGeom prst="rect">
+            <a:avLst/>
+          </a:prstGeom>
+          <a:noFill/>
+          <a:ln/>
+        </p:spPr>
+        <p:txBody>
+          <a:bodyPr wrap="square" lIns="0" tIns="0" rIns="0" bIns="0" rtlCol="0" anchor="ctr"/>
+          <a:lstStyle/>
+          <a:p>
+            <a:pPr indent="0" marL="0">
+              <a:buNone/>
+            </a:pPr>
+            <a:r>
+              <a:rPr lang="en-US" sz="2200" b="1" dirty="0">
+                <a:solidFill>
+                  <a:srgbClr val="C00000"/>
+                </a:solidFill>
+                <a:latin typeface="Graphik TH" pitchFamily="34" charset="0"/>
+                <a:ea typeface="Graphik TH" pitchFamily="34" charset="-122"/>
+                <a:cs typeface="Graphik TH" pitchFamily="34" charset="-120"/>
+              </a:rPr>
+              <a:t>370</a:t>
+            </a:r>
+            <a:endParaRPr lang="en-US" sz="2200" dirty="0"/>
+          </a:p>
+        </p:txBody>
+      </p:sp>
+      <p:sp>
+        <p:nvSpPr>
+          <p:cNvPr id="47" name="Text 45"/>
+          <p:cNvSpPr/>
+          <p:nvPr/>
+        </p:nvSpPr>
+        <p:spPr>
+          <a:xfrm>
+            <a:off x="9802368" y="3438144"/>
+            <a:ext cx="1746504" cy="402336"/>
+          </a:xfrm>
+          <a:prstGeom prst="rect">
+            <a:avLst/>
+          </a:prstGeom>
+          <a:noFill/>
+          <a:ln/>
+        </p:spPr>
+        <p:txBody>
+          <a:bodyPr wrap="square" lIns="0" tIns="0" rIns="0" bIns="0" rtlCol="0" anchor="ctr"/>
+          <a:lstStyle/>
+          <a:p>
+            <a:pPr indent="0" marL="0">
+              <a:buNone/>
+            </a:pPr>
+            <a:r>
+              <a:rPr lang="en-US" sz="1100" dirty="0">
+                <a:solidFill>
+                  <a:srgbClr val="16233D"/>
+                </a:solidFill>
+                <a:latin typeface="Graphik TH" pitchFamily="34" charset="0"/>
+                <a:ea typeface="Graphik TH" pitchFamily="34" charset="-122"/>
+                <a:cs typeface="Graphik TH" pitchFamily="34" charset="-120"/>
+              </a:rPr>
+              <a:t>customers</a:t>
+            </a:r>
+            <a:endParaRPr lang="en-US" sz="1100" dirty="0"/>
+          </a:p>
+        </p:txBody>
+      </p:sp>
+      <p:sp>
+        <p:nvSpPr>
+          <p:cNvPr id="48" name="Text 46"/>
+          <p:cNvSpPr/>
+          <p:nvPr/>
+        </p:nvSpPr>
+        <p:spPr>
+          <a:xfrm>
+            <a:off x="7735824" y="3895344"/>
+            <a:ext cx="2011680" cy="402336"/>
+          </a:xfrm>
+          <a:prstGeom prst="rect">
+            <a:avLst/>
+          </a:prstGeom>
+          <a:noFill/>
+          <a:ln/>
+        </p:spPr>
+        <p:txBody>
+          <a:bodyPr wrap="square" lIns="0" tIns="0" rIns="0" bIns="0" rtlCol="0" anchor="ctr"/>
+          <a:lstStyle/>
+          <a:p>
+            <a:pPr indent="0" marL="0">
+              <a:buNone/>
+            </a:pPr>
+            <a:r>
+              <a:rPr lang="en-US" sz="2200" b="1" dirty="0">
+                <a:solidFill>
+                  <a:srgbClr val="C00000"/>
+                </a:solidFill>
+                <a:latin typeface="Graphik TH" pitchFamily="34" charset="0"/>
+                <a:ea typeface="Graphik TH" pitchFamily="34" charset="-122"/>
+                <a:cs typeface="Graphik TH" pitchFamily="34" charset="-120"/>
+              </a:rPr>
+              <a:t>THB 99m</a:t>
+            </a:r>
+            <a:endParaRPr lang="en-US" sz="2200" dirty="0"/>
+          </a:p>
+        </p:txBody>
+      </p:sp>
+      <p:sp>
+        <p:nvSpPr>
+          <p:cNvPr id="49" name="Text 47"/>
+          <p:cNvSpPr/>
+          <p:nvPr/>
+        </p:nvSpPr>
+        <p:spPr>
+          <a:xfrm>
+            <a:off x="9802368" y="3895344"/>
+            <a:ext cx="1746504" cy="402336"/>
+          </a:xfrm>
+          <a:prstGeom prst="rect">
+            <a:avLst/>
+          </a:prstGeom>
+          <a:noFill/>
+          <a:ln/>
+        </p:spPr>
+        <p:txBody>
+          <a:bodyPr wrap="square" lIns="0" tIns="0" rIns="0" bIns="0" rtlCol="0" anchor="ctr"/>
+          <a:lstStyle/>
+          <a:p>
+            <a:pPr indent="0" marL="0">
+              <a:buNone/>
+            </a:pPr>
+            <a:r>
+              <a:rPr lang="en-US" sz="1100" dirty="0">
+                <a:solidFill>
+                  <a:srgbClr val="16233D"/>
+                </a:solidFill>
+                <a:latin typeface="Graphik TH" pitchFamily="34" charset="0"/>
+                <a:ea typeface="Graphik TH" pitchFamily="34" charset="-122"/>
+                <a:cs typeface="Graphik TH" pitchFamily="34" charset="-120"/>
+              </a:rPr>
+              <a:t>balance at risk</a:t>
+            </a:r>
+            <a:endParaRPr lang="en-US" sz="1100" dirty="0"/>
+          </a:p>
+        </p:txBody>
+      </p:sp>
+      <p:sp>
+        <p:nvSpPr>
+          <p:cNvPr id="50" name="Shape 48"/>
+          <p:cNvSpPr/>
+          <p:nvPr/>
+        </p:nvSpPr>
+        <p:spPr>
+          <a:xfrm>
+            <a:off x="7735824" y="4389120"/>
+            <a:ext cx="3813048" cy="658368"/>
+          </a:xfrm>
+          <a:prstGeom prst="roundRect">
+            <a:avLst>
+              <a:gd name="adj" fmla="val 12500"/>
+            </a:avLst>
+          </a:prstGeom>
+          <a:solidFill>
+            <a:srgbClr val="FBF0E6"/>
+          </a:solidFill>
+          <a:ln/>
+        </p:spPr>
+      </p:sp>
+      <p:sp>
+        <p:nvSpPr>
+          <p:cNvPr id="51" name="Text 49"/>
+          <p:cNvSpPr/>
+          <p:nvPr/>
+        </p:nvSpPr>
+        <p:spPr>
+          <a:xfrm>
+            <a:off x="7882128" y="4389120"/>
+            <a:ext cx="3520440" cy="658368"/>
+          </a:xfrm>
+          <a:prstGeom prst="rect">
+            <a:avLst/>
+          </a:prstGeom>
+          <a:noFill/>
+          <a:ln/>
+        </p:spPr>
+        <p:txBody>
+          <a:bodyPr wrap="square" lIns="0" tIns="0" rIns="0" bIns="0" rtlCol="0" anchor="ctr"/>
+          <a:lstStyle/>
+          <a:p>
+            <a:pPr indent="0" marL="0">
+              <a:buNone/>
+            </a:pPr>
+            <a:r>
+              <a:rPr lang="en-US" sz="950" dirty="0">
+                <a:solidFill>
+                  <a:srgbClr val="16233D"/>
+                </a:solidFill>
+                <a:latin typeface="Graphik TH" pitchFamily="34" charset="0"/>
+                <a:ea typeface="Graphik TH" pitchFamily="34" charset="-122"/>
+                <a:cs typeface="Graphik TH" pitchFamily="34" charset="-120"/>
+              </a:rPr>
+              <a:t>The other 97% of rate-sensitive balance — THB 3.73bn — sits with High / Very High stickiness customers.</a:t>
+            </a:r>
+            <a:endParaRPr lang="en-US" sz="950" dirty="0"/>
+          </a:p>
+        </p:txBody>
+      </p:sp>
+      <p:sp>
+        <p:nvSpPr>
+          <p:cNvPr id="52" name="Shape 50"/>
+          <p:cNvSpPr/>
+          <p:nvPr/>
+        </p:nvSpPr>
+        <p:spPr>
+          <a:xfrm>
+            <a:off x="530352" y="5285232"/>
+            <a:ext cx="11274552" cy="786384"/>
+          </a:xfrm>
+          <a:prstGeom prst="roundRect">
+            <a:avLst>
+              <a:gd name="adj" fmla="val 10465"/>
+            </a:avLst>
+          </a:prstGeom>
+          <a:solidFill>
+            <a:srgbClr val="FBF0E6"/>
+          </a:solidFill>
+          <a:ln/>
+        </p:spPr>
+      </p:sp>
+      <p:sp>
+        <p:nvSpPr>
+          <p:cNvPr id="53" name="Text 51"/>
+          <p:cNvSpPr/>
+          <p:nvPr/>
+        </p:nvSpPr>
+        <p:spPr>
+          <a:xfrm>
+            <a:off x="804672" y="5285232"/>
+            <a:ext cx="10725912" cy="786384"/>
+          </a:xfrm>
+          <a:prstGeom prst="rect">
+            <a:avLst/>
+          </a:prstGeom>
+          <a:noFill/>
+          <a:ln/>
+        </p:spPr>
+        <p:txBody>
+          <a:bodyPr wrap="square" lIns="0" tIns="0" rIns="0" bIns="0" rtlCol="0" anchor="ctr"/>
+          <a:lstStyle/>
+          <a:p>
+            <a:pPr indent="0" marL="0">
+              <a:buNone/>
+            </a:pPr>
+            <a:r>
+              <a:rPr lang="en-US" sz="1100" b="1" dirty="0">
+                <a:solidFill>
+                  <a:srgbClr val="C00000"/>
+                </a:solidFill>
+                <a:latin typeface="Graphik TH" pitchFamily="34" charset="0"/>
+                <a:ea typeface="Graphik TH" pitchFamily="34" charset="-122"/>
+                <a:cs typeface="Graphik TH" pitchFamily="34" charset="-120"/>
+              </a:rPr>
+              <a:t>The balance at risk is not with the disengaged — it is with the rate-optimisers</a:t>
+            </a:r>
+            <a:pPr indent="0" marL="0">
+              <a:buNone/>
+            </a:pPr>
+            <a:r>
+              <a:rPr lang="en-US" sz="1100" dirty="0">
+                <a:solidFill>
+                  <a:srgbClr val="16233D"/>
+                </a:solidFill>
+                <a:latin typeface="Graphik TH" pitchFamily="34" charset="0"/>
+                <a:ea typeface="Graphik TH" pitchFamily="34" charset="-122"/>
+                <a:cs typeface="Graphik TH" pitchFamily="34" charset="-120"/>
+              </a:rPr>
+              <a:t>  —  67.9k low-stickiness customers hold only THB 16.7m, while 25.0k rate-sensitive customers hold THB 3.83bn. Retention spend belongs with the second group; activation and funding with the first.</a:t>
+            </a:r>
+            <a:endParaRPr lang="en-US" sz="1100" dirty="0"/>
+          </a:p>
+        </p:txBody>
+      </p:sp>
+    </p:spTree>
+  </p:cSld>
+  <p:clrMapOvr>
+    <a:masterClrMapping/>
+  </p:clrMapOvr>
+</p:sld>
+</file>
+
 <file path=ppt/theme/theme1.xml><?xml version="1.0" encoding="utf-8"?>
 <a:theme xmlns:a="http://schemas.openxmlformats.org/drawingml/2006/main" name="Office Theme">
   <a:themeElements>

</xml_diff>

<commit_message>
Add Save Max and Save More holding flags to the worked examples
Each promotional pocket tile on the worked-example slide now carries a
FLAG Y/N chip, derived from whether the customer holds balance in that
pocket. Main Pocket is not promotional and carries no flag.

Co-Authored-By: Claude Opus 5 <noreply@anthropic.com>
Claude-Session: https://claude.ai/code/session_01VKpfo226Go9vQJYa4eoC1d
</commit_message>
<xml_diff>
--- a/Deposit_Stickiness_Framework.pptx
+++ b/Deposit_Stickiness_Framework.pptx
@@ -9702,7 +9702,7 @@
         <p:spPr>
           <a:xfrm>
             <a:off x="2651760" y="2331720"/>
-            <a:ext cx="1280160" cy="182880"/>
+            <a:ext cx="914400" cy="182880"/>
           </a:xfrm>
           <a:prstGeom prst="rect">
             <a:avLst/>
@@ -9734,7 +9734,68 @@
       </p:sp>
       <p:sp>
         <p:nvSpPr>
-          <p:cNvPr id="15" name="Text 13"/>
+          <p:cNvPr id="15" name="Shape 13"/>
+          <p:cNvSpPr/>
+          <p:nvPr/>
+        </p:nvSpPr>
+        <p:spPr>
+          <a:xfrm>
+            <a:off x="3456432" y="2327148"/>
+            <a:ext cx="475488" cy="192024"/>
+          </a:xfrm>
+          <a:prstGeom prst="roundRect">
+            <a:avLst>
+              <a:gd name="adj" fmla="val 23810"/>
+            </a:avLst>
+          </a:prstGeom>
+          <a:solidFill>
+            <a:srgbClr val="1E8E86"/>
+          </a:solidFill>
+          <a:ln/>
+        </p:spPr>
+      </p:sp>
+      <p:sp>
+        <p:nvSpPr>
+          <p:cNvPr id="16" name="Text 14"/>
+          <p:cNvSpPr/>
+          <p:nvPr/>
+        </p:nvSpPr>
+        <p:spPr>
+          <a:xfrm>
+            <a:off x="3456432" y="2327148"/>
+            <a:ext cx="475488" cy="192024"/>
+          </a:xfrm>
+          <a:prstGeom prst="rect">
+            <a:avLst/>
+          </a:prstGeom>
+          <a:noFill/>
+          <a:ln/>
+        </p:spPr>
+        <p:txBody>
+          <a:bodyPr wrap="square" lIns="0" tIns="0" rIns="0" bIns="0" rtlCol="0" anchor="ctr"/>
+          <a:lstStyle/>
+          <a:p>
+            <a:pPr algn="ctr" indent="0" marL="0">
+              <a:buNone/>
+            </a:pPr>
+            <a:r>
+              <a:rPr lang="en-US" sz="700" b="1" dirty="0">
+                <a:solidFill>
+                  <a:srgbClr val="FFFFFF"/>
+                </a:solidFill>
+                <a:latin typeface="Graphik TH" pitchFamily="34" charset="0"/>
+                <a:ea typeface="Graphik TH" pitchFamily="34" charset="-122"/>
+                <a:cs typeface="Graphik TH" pitchFamily="34" charset="-120"/>
+              </a:rPr>
+              <a:t>FLAG Y</a:t>
+            </a:r>
+            <a:endParaRPr lang="en-US" sz="700" dirty="0"/>
+          </a:p>
+        </p:txBody>
+      </p:sp>
+      <p:sp>
+        <p:nvSpPr>
+          <p:cNvPr id="17" name="Text 15"/>
           <p:cNvSpPr/>
           <p:nvPr/>
         </p:nvSpPr>
@@ -9773,7 +9834,7 @@
       </p:sp>
       <p:sp>
         <p:nvSpPr>
-          <p:cNvPr id="16" name="Shape 14"/>
+          <p:cNvPr id="18" name="Shape 16"/>
           <p:cNvSpPr/>
           <p:nvPr/>
         </p:nvSpPr>
@@ -9795,14 +9856,14 @@
       </p:sp>
       <p:sp>
         <p:nvSpPr>
-          <p:cNvPr id="17" name="Text 15"/>
+          <p:cNvPr id="19" name="Text 17"/>
           <p:cNvSpPr/>
           <p:nvPr/>
         </p:nvSpPr>
         <p:spPr>
           <a:xfrm>
             <a:off x="4370832" y="2331720"/>
-            <a:ext cx="1280160" cy="182880"/>
+            <a:ext cx="914400" cy="182880"/>
           </a:xfrm>
           <a:prstGeom prst="rect">
             <a:avLst/>
@@ -9834,7 +9895,68 @@
       </p:sp>
       <p:sp>
         <p:nvSpPr>
-          <p:cNvPr id="18" name="Text 16"/>
+          <p:cNvPr id="20" name="Shape 18"/>
+          <p:cNvSpPr/>
+          <p:nvPr/>
+        </p:nvSpPr>
+        <p:spPr>
+          <a:xfrm>
+            <a:off x="5175504" y="2327148"/>
+            <a:ext cx="475488" cy="192024"/>
+          </a:xfrm>
+          <a:prstGeom prst="roundRect">
+            <a:avLst>
+              <a:gd name="adj" fmla="val 23810"/>
+            </a:avLst>
+          </a:prstGeom>
+          <a:solidFill>
+            <a:srgbClr val="1E8E86"/>
+          </a:solidFill>
+          <a:ln/>
+        </p:spPr>
+      </p:sp>
+      <p:sp>
+        <p:nvSpPr>
+          <p:cNvPr id="21" name="Text 19"/>
+          <p:cNvSpPr/>
+          <p:nvPr/>
+        </p:nvSpPr>
+        <p:spPr>
+          <a:xfrm>
+            <a:off x="5175504" y="2327148"/>
+            <a:ext cx="475488" cy="192024"/>
+          </a:xfrm>
+          <a:prstGeom prst="rect">
+            <a:avLst/>
+          </a:prstGeom>
+          <a:noFill/>
+          <a:ln/>
+        </p:spPr>
+        <p:txBody>
+          <a:bodyPr wrap="square" lIns="0" tIns="0" rIns="0" bIns="0" rtlCol="0" anchor="ctr"/>
+          <a:lstStyle/>
+          <a:p>
+            <a:pPr algn="ctr" indent="0" marL="0">
+              <a:buNone/>
+            </a:pPr>
+            <a:r>
+              <a:rPr lang="en-US" sz="700" b="1" dirty="0">
+                <a:solidFill>
+                  <a:srgbClr val="FFFFFF"/>
+                </a:solidFill>
+                <a:latin typeface="Graphik TH" pitchFamily="34" charset="0"/>
+                <a:ea typeface="Graphik TH" pitchFamily="34" charset="-122"/>
+                <a:cs typeface="Graphik TH" pitchFamily="34" charset="-120"/>
+              </a:rPr>
+              <a:t>FLAG Y</a:t>
+            </a:r>
+            <a:endParaRPr lang="en-US" sz="700" dirty="0"/>
+          </a:p>
+        </p:txBody>
+      </p:sp>
+      <p:sp>
+        <p:nvSpPr>
+          <p:cNvPr id="22" name="Text 20"/>
           <p:cNvSpPr/>
           <p:nvPr/>
         </p:nvSpPr>
@@ -9873,7 +9995,7 @@
       </p:sp>
       <p:sp>
         <p:nvSpPr>
-          <p:cNvPr id="19" name="Text 17"/>
+          <p:cNvPr id="23" name="Text 21"/>
           <p:cNvSpPr/>
           <p:nvPr/>
         </p:nvSpPr>
@@ -9912,7 +10034,7 @@
       </p:sp>
       <p:sp>
         <p:nvSpPr>
-          <p:cNvPr id="20" name="Text 18"/>
+          <p:cNvPr id="24" name="Text 22"/>
           <p:cNvSpPr/>
           <p:nvPr/>
         </p:nvSpPr>
@@ -9951,7 +10073,7 @@
       </p:sp>
       <p:sp>
         <p:nvSpPr>
-          <p:cNvPr id="21" name="Text 19"/>
+          <p:cNvPr id="25" name="Text 23"/>
           <p:cNvSpPr/>
           <p:nvPr/>
         </p:nvSpPr>
@@ -9990,7 +10112,7 @@
       </p:sp>
       <p:sp>
         <p:nvSpPr>
-          <p:cNvPr id="22" name="Shape 20"/>
+          <p:cNvPr id="26" name="Shape 24"/>
           <p:cNvSpPr/>
           <p:nvPr/>
         </p:nvSpPr>
@@ -10012,7 +10134,7 @@
       </p:sp>
       <p:sp>
         <p:nvSpPr>
-          <p:cNvPr id="23" name="Text 21"/>
+          <p:cNvPr id="27" name="Text 25"/>
           <p:cNvSpPr/>
           <p:nvPr/>
         </p:nvSpPr>
@@ -10051,7 +10173,7 @@
       </p:sp>
       <p:sp>
         <p:nvSpPr>
-          <p:cNvPr id="24" name="Text 22"/>
+          <p:cNvPr id="28" name="Text 26"/>
           <p:cNvSpPr/>
           <p:nvPr/>
         </p:nvSpPr>
@@ -10090,7 +10212,7 @@
       </p:sp>
       <p:sp>
         <p:nvSpPr>
-          <p:cNvPr id="25" name="Text 23"/>
+          <p:cNvPr id="29" name="Text 27"/>
           <p:cNvSpPr/>
           <p:nvPr/>
         </p:nvSpPr>
@@ -10129,7 +10251,7 @@
       </p:sp>
       <p:sp>
         <p:nvSpPr>
-          <p:cNvPr id="26" name="Shape 24"/>
+          <p:cNvPr id="30" name="Shape 28"/>
           <p:cNvSpPr/>
           <p:nvPr/>
         </p:nvSpPr>
@@ -10151,7 +10273,7 @@
       </p:sp>
       <p:sp>
         <p:nvSpPr>
-          <p:cNvPr id="27" name="Text 25"/>
+          <p:cNvPr id="31" name="Text 29"/>
           <p:cNvSpPr/>
           <p:nvPr/>
         </p:nvSpPr>
@@ -10190,7 +10312,7 @@
       </p:sp>
       <p:sp>
         <p:nvSpPr>
-          <p:cNvPr id="28" name="Text 26"/>
+          <p:cNvPr id="32" name="Text 30"/>
           <p:cNvSpPr/>
           <p:nvPr/>
         </p:nvSpPr>
@@ -10229,7 +10351,7 @@
       </p:sp>
       <p:sp>
         <p:nvSpPr>
-          <p:cNvPr id="29" name="Text 27"/>
+          <p:cNvPr id="33" name="Text 31"/>
           <p:cNvSpPr/>
           <p:nvPr/>
         </p:nvSpPr>
@@ -10268,7 +10390,7 @@
       </p:sp>
       <p:sp>
         <p:nvSpPr>
-          <p:cNvPr id="30" name="Shape 28"/>
+          <p:cNvPr id="34" name="Shape 32"/>
           <p:cNvSpPr/>
           <p:nvPr/>
         </p:nvSpPr>
@@ -10290,7 +10412,7 @@
       </p:sp>
       <p:sp>
         <p:nvSpPr>
-          <p:cNvPr id="31" name="Text 29"/>
+          <p:cNvPr id="35" name="Text 33"/>
           <p:cNvSpPr/>
           <p:nvPr/>
         </p:nvSpPr>
@@ -10329,7 +10451,7 @@
       </p:sp>
       <p:sp>
         <p:nvSpPr>
-          <p:cNvPr id="32" name="Text 30"/>
+          <p:cNvPr id="36" name="Text 34"/>
           <p:cNvSpPr/>
           <p:nvPr/>
         </p:nvSpPr>
@@ -10368,7 +10490,7 @@
       </p:sp>
       <p:sp>
         <p:nvSpPr>
-          <p:cNvPr id="33" name="Text 31"/>
+          <p:cNvPr id="37" name="Text 35"/>
           <p:cNvSpPr/>
           <p:nvPr/>
         </p:nvSpPr>
@@ -10407,7 +10529,7 @@
       </p:sp>
       <p:sp>
         <p:nvSpPr>
-          <p:cNvPr id="34" name="Shape 32"/>
+          <p:cNvPr id="38" name="Shape 36"/>
           <p:cNvSpPr/>
           <p:nvPr/>
         </p:nvSpPr>
@@ -10429,7 +10551,7 @@
       </p:sp>
       <p:sp>
         <p:nvSpPr>
-          <p:cNvPr id="35" name="Text 33"/>
+          <p:cNvPr id="39" name="Text 37"/>
           <p:cNvSpPr/>
           <p:nvPr/>
         </p:nvSpPr>
@@ -10468,7 +10590,7 @@
       </p:sp>
       <p:sp>
         <p:nvSpPr>
-          <p:cNvPr id="36" name="Shape 34"/>
+          <p:cNvPr id="40" name="Shape 38"/>
           <p:cNvSpPr/>
           <p:nvPr/>
         </p:nvSpPr>
@@ -10488,7 +10610,7 @@
       </p:sp>
       <p:sp>
         <p:nvSpPr>
-          <p:cNvPr id="37" name="Text 35"/>
+          <p:cNvPr id="41" name="Text 39"/>
           <p:cNvSpPr/>
           <p:nvPr/>
         </p:nvSpPr>
@@ -10527,7 +10649,7 @@
       </p:sp>
       <p:sp>
         <p:nvSpPr>
-          <p:cNvPr id="38" name="Text 36"/>
+          <p:cNvPr id="42" name="Text 40"/>
           <p:cNvSpPr/>
           <p:nvPr/>
         </p:nvSpPr>
@@ -10566,7 +10688,7 @@
       </p:sp>
       <p:sp>
         <p:nvSpPr>
-          <p:cNvPr id="39" name="Shape 37"/>
+          <p:cNvPr id="43" name="Shape 41"/>
           <p:cNvSpPr/>
           <p:nvPr/>
         </p:nvSpPr>
@@ -10588,7 +10710,7 @@
       </p:sp>
       <p:sp>
         <p:nvSpPr>
-          <p:cNvPr id="40" name="Text 38"/>
+          <p:cNvPr id="44" name="Text 42"/>
           <p:cNvSpPr/>
           <p:nvPr/>
         </p:nvSpPr>
@@ -10627,7 +10749,7 @@
       </p:sp>
       <p:sp>
         <p:nvSpPr>
-          <p:cNvPr id="41" name="Text 39"/>
+          <p:cNvPr id="45" name="Text 43"/>
           <p:cNvSpPr/>
           <p:nvPr/>
         </p:nvSpPr>
@@ -10666,7 +10788,7 @@
       </p:sp>
       <p:sp>
         <p:nvSpPr>
-          <p:cNvPr id="42" name="Text 40"/>
+          <p:cNvPr id="46" name="Text 44"/>
           <p:cNvSpPr/>
           <p:nvPr/>
         </p:nvSpPr>
@@ -10705,7 +10827,7 @@
       </p:sp>
       <p:sp>
         <p:nvSpPr>
-          <p:cNvPr id="43" name="Shape 41"/>
+          <p:cNvPr id="47" name="Shape 45"/>
           <p:cNvSpPr/>
           <p:nvPr/>
         </p:nvSpPr>
@@ -10727,7 +10849,7 @@
       </p:sp>
       <p:sp>
         <p:nvSpPr>
-          <p:cNvPr id="44" name="Text 42"/>
+          <p:cNvPr id="48" name="Text 46"/>
           <p:cNvSpPr/>
           <p:nvPr/>
         </p:nvSpPr>
@@ -10766,7 +10888,7 @@
       </p:sp>
       <p:sp>
         <p:nvSpPr>
-          <p:cNvPr id="45" name="Shape 43"/>
+          <p:cNvPr id="49" name="Shape 47"/>
           <p:cNvSpPr/>
           <p:nvPr/>
         </p:nvSpPr>
@@ -10788,7 +10910,7 @@
       </p:sp>
       <p:sp>
         <p:nvSpPr>
-          <p:cNvPr id="46" name="Text 44"/>
+          <p:cNvPr id="50" name="Text 48"/>
           <p:cNvSpPr/>
           <p:nvPr/>
         </p:nvSpPr>
@@ -10827,7 +10949,7 @@
       </p:sp>
       <p:sp>
         <p:nvSpPr>
-          <p:cNvPr id="47" name="Shape 45"/>
+          <p:cNvPr id="51" name="Shape 49"/>
           <p:cNvSpPr/>
           <p:nvPr/>
         </p:nvSpPr>
@@ -10849,7 +10971,7 @@
       </p:sp>
       <p:sp>
         <p:nvSpPr>
-          <p:cNvPr id="48" name="Text 46"/>
+          <p:cNvPr id="52" name="Text 50"/>
           <p:cNvSpPr/>
           <p:nvPr/>
         </p:nvSpPr>
@@ -10888,7 +11010,7 @@
       </p:sp>
       <p:sp>
         <p:nvSpPr>
-          <p:cNvPr id="49" name="Shape 47"/>
+          <p:cNvPr id="53" name="Shape 51"/>
           <p:cNvSpPr/>
           <p:nvPr/>
         </p:nvSpPr>
@@ -10910,7 +11032,7 @@
       </p:sp>
       <p:sp>
         <p:nvSpPr>
-          <p:cNvPr id="50" name="Text 48"/>
+          <p:cNvPr id="54" name="Text 52"/>
           <p:cNvSpPr/>
           <p:nvPr/>
         </p:nvSpPr>
@@ -10949,7 +11071,7 @@
       </p:sp>
       <p:sp>
         <p:nvSpPr>
-          <p:cNvPr id="51" name="Text 49"/>
+          <p:cNvPr id="55" name="Text 53"/>
           <p:cNvSpPr/>
           <p:nvPr/>
         </p:nvSpPr>
@@ -10988,7 +11110,7 @@
       </p:sp>
       <p:sp>
         <p:nvSpPr>
-          <p:cNvPr id="52" name="Shape 50"/>
+          <p:cNvPr id="56" name="Shape 54"/>
           <p:cNvSpPr/>
           <p:nvPr/>
         </p:nvSpPr>
@@ -11010,7 +11132,7 @@
       </p:sp>
       <p:sp>
         <p:nvSpPr>
-          <p:cNvPr id="53" name="Text 51"/>
+          <p:cNvPr id="57" name="Text 55"/>
           <p:cNvSpPr/>
           <p:nvPr/>
         </p:nvSpPr>
@@ -11049,7 +11171,7 @@
       </p:sp>
       <p:sp>
         <p:nvSpPr>
-          <p:cNvPr id="54" name="Text 52"/>
+          <p:cNvPr id="58" name="Text 56"/>
           <p:cNvSpPr/>
           <p:nvPr/>
         </p:nvSpPr>
@@ -11088,7 +11210,7 @@
       </p:sp>
       <p:sp>
         <p:nvSpPr>
-          <p:cNvPr id="55" name="Shape 53"/>
+          <p:cNvPr id="59" name="Shape 57"/>
           <p:cNvSpPr/>
           <p:nvPr/>
         </p:nvSpPr>
@@ -11110,14 +11232,14 @@
       </p:sp>
       <p:sp>
         <p:nvSpPr>
-          <p:cNvPr id="56" name="Text 54"/>
+          <p:cNvPr id="60" name="Text 58"/>
           <p:cNvSpPr/>
           <p:nvPr/>
         </p:nvSpPr>
         <p:spPr>
           <a:xfrm>
             <a:off x="8403336" y="2331720"/>
-            <a:ext cx="1280160" cy="182880"/>
+            <a:ext cx="914400" cy="182880"/>
           </a:xfrm>
           <a:prstGeom prst="rect">
             <a:avLst/>
@@ -11149,7 +11271,68 @@
       </p:sp>
       <p:sp>
         <p:nvSpPr>
-          <p:cNvPr id="57" name="Text 55"/>
+          <p:cNvPr id="61" name="Shape 59"/>
+          <p:cNvSpPr/>
+          <p:nvPr/>
+        </p:nvSpPr>
+        <p:spPr>
+          <a:xfrm>
+            <a:off x="9208008" y="2327148"/>
+            <a:ext cx="475488" cy="192024"/>
+          </a:xfrm>
+          <a:prstGeom prst="roundRect">
+            <a:avLst>
+              <a:gd name="adj" fmla="val 23810"/>
+            </a:avLst>
+          </a:prstGeom>
+          <a:solidFill>
+            <a:srgbClr val="1E8E86"/>
+          </a:solidFill>
+          <a:ln/>
+        </p:spPr>
+      </p:sp>
+      <p:sp>
+        <p:nvSpPr>
+          <p:cNvPr id="62" name="Text 60"/>
+          <p:cNvSpPr/>
+          <p:nvPr/>
+        </p:nvSpPr>
+        <p:spPr>
+          <a:xfrm>
+            <a:off x="9208008" y="2327148"/>
+            <a:ext cx="475488" cy="192024"/>
+          </a:xfrm>
+          <a:prstGeom prst="rect">
+            <a:avLst/>
+          </a:prstGeom>
+          <a:noFill/>
+          <a:ln/>
+        </p:spPr>
+        <p:txBody>
+          <a:bodyPr wrap="square" lIns="0" tIns="0" rIns="0" bIns="0" rtlCol="0" anchor="ctr"/>
+          <a:lstStyle/>
+          <a:p>
+            <a:pPr algn="ctr" indent="0" marL="0">
+              <a:buNone/>
+            </a:pPr>
+            <a:r>
+              <a:rPr lang="en-US" sz="700" b="1" dirty="0">
+                <a:solidFill>
+                  <a:srgbClr val="FFFFFF"/>
+                </a:solidFill>
+                <a:latin typeface="Graphik TH" pitchFamily="34" charset="0"/>
+                <a:ea typeface="Graphik TH" pitchFamily="34" charset="-122"/>
+                <a:cs typeface="Graphik TH" pitchFamily="34" charset="-120"/>
+              </a:rPr>
+              <a:t>FLAG Y</a:t>
+            </a:r>
+            <a:endParaRPr lang="en-US" sz="700" dirty="0"/>
+          </a:p>
+        </p:txBody>
+      </p:sp>
+      <p:sp>
+        <p:nvSpPr>
+          <p:cNvPr id="63" name="Text 61"/>
           <p:cNvSpPr/>
           <p:nvPr/>
         </p:nvSpPr>
@@ -11188,7 +11371,7 @@
       </p:sp>
       <p:sp>
         <p:nvSpPr>
-          <p:cNvPr id="58" name="Shape 56"/>
+          <p:cNvPr id="64" name="Shape 62"/>
           <p:cNvSpPr/>
           <p:nvPr/>
         </p:nvSpPr>
@@ -11210,14 +11393,14 @@
       </p:sp>
       <p:sp>
         <p:nvSpPr>
-          <p:cNvPr id="59" name="Text 57"/>
+          <p:cNvPr id="65" name="Text 63"/>
           <p:cNvSpPr/>
           <p:nvPr/>
         </p:nvSpPr>
         <p:spPr>
           <a:xfrm>
             <a:off x="10122408" y="2331720"/>
-            <a:ext cx="1280160" cy="182880"/>
+            <a:ext cx="914400" cy="182880"/>
           </a:xfrm>
           <a:prstGeom prst="rect">
             <a:avLst/>
@@ -11249,7 +11432,68 @@
       </p:sp>
       <p:sp>
         <p:nvSpPr>
-          <p:cNvPr id="60" name="Text 58"/>
+          <p:cNvPr id="66" name="Shape 64"/>
+          <p:cNvSpPr/>
+          <p:nvPr/>
+        </p:nvSpPr>
+        <p:spPr>
+          <a:xfrm>
+            <a:off x="10927080" y="2327148"/>
+            <a:ext cx="475488" cy="192024"/>
+          </a:xfrm>
+          <a:prstGeom prst="roundRect">
+            <a:avLst>
+              <a:gd name="adj" fmla="val 23810"/>
+            </a:avLst>
+          </a:prstGeom>
+          <a:solidFill>
+            <a:srgbClr val="1E8E86"/>
+          </a:solidFill>
+          <a:ln/>
+        </p:spPr>
+      </p:sp>
+      <p:sp>
+        <p:nvSpPr>
+          <p:cNvPr id="67" name="Text 65"/>
+          <p:cNvSpPr/>
+          <p:nvPr/>
+        </p:nvSpPr>
+        <p:spPr>
+          <a:xfrm>
+            <a:off x="10927080" y="2327148"/>
+            <a:ext cx="475488" cy="192024"/>
+          </a:xfrm>
+          <a:prstGeom prst="rect">
+            <a:avLst/>
+          </a:prstGeom>
+          <a:noFill/>
+          <a:ln/>
+        </p:spPr>
+        <p:txBody>
+          <a:bodyPr wrap="square" lIns="0" tIns="0" rIns="0" bIns="0" rtlCol="0" anchor="ctr"/>
+          <a:lstStyle/>
+          <a:p>
+            <a:pPr algn="ctr" indent="0" marL="0">
+              <a:buNone/>
+            </a:pPr>
+            <a:r>
+              <a:rPr lang="en-US" sz="700" b="1" dirty="0">
+                <a:solidFill>
+                  <a:srgbClr val="FFFFFF"/>
+                </a:solidFill>
+                <a:latin typeface="Graphik TH" pitchFamily="34" charset="0"/>
+                <a:ea typeface="Graphik TH" pitchFamily="34" charset="-122"/>
+                <a:cs typeface="Graphik TH" pitchFamily="34" charset="-120"/>
+              </a:rPr>
+              <a:t>FLAG Y</a:t>
+            </a:r>
+            <a:endParaRPr lang="en-US" sz="700" dirty="0"/>
+          </a:p>
+        </p:txBody>
+      </p:sp>
+      <p:sp>
+        <p:nvSpPr>
+          <p:cNvPr id="68" name="Text 66"/>
           <p:cNvSpPr/>
           <p:nvPr/>
         </p:nvSpPr>
@@ -11288,7 +11532,7 @@
       </p:sp>
       <p:sp>
         <p:nvSpPr>
-          <p:cNvPr id="61" name="Text 59"/>
+          <p:cNvPr id="69" name="Text 67"/>
           <p:cNvSpPr/>
           <p:nvPr/>
         </p:nvSpPr>
@@ -11327,7 +11571,7 @@
       </p:sp>
       <p:sp>
         <p:nvSpPr>
-          <p:cNvPr id="62" name="Text 60"/>
+          <p:cNvPr id="70" name="Text 68"/>
           <p:cNvSpPr/>
           <p:nvPr/>
         </p:nvSpPr>
@@ -11366,7 +11610,7 @@
       </p:sp>
       <p:sp>
         <p:nvSpPr>
-          <p:cNvPr id="63" name="Text 61"/>
+          <p:cNvPr id="71" name="Text 69"/>
           <p:cNvSpPr/>
           <p:nvPr/>
         </p:nvSpPr>
@@ -11405,7 +11649,7 @@
       </p:sp>
       <p:sp>
         <p:nvSpPr>
-          <p:cNvPr id="64" name="Shape 62"/>
+          <p:cNvPr id="72" name="Shape 70"/>
           <p:cNvSpPr/>
           <p:nvPr/>
         </p:nvSpPr>
@@ -11427,7 +11671,7 @@
       </p:sp>
       <p:sp>
         <p:nvSpPr>
-          <p:cNvPr id="65" name="Text 63"/>
+          <p:cNvPr id="73" name="Text 71"/>
           <p:cNvSpPr/>
           <p:nvPr/>
         </p:nvSpPr>
@@ -11466,7 +11710,7 @@
       </p:sp>
       <p:sp>
         <p:nvSpPr>
-          <p:cNvPr id="66" name="Text 64"/>
+          <p:cNvPr id="74" name="Text 72"/>
           <p:cNvSpPr/>
           <p:nvPr/>
         </p:nvSpPr>
@@ -11505,7 +11749,7 @@
       </p:sp>
       <p:sp>
         <p:nvSpPr>
-          <p:cNvPr id="67" name="Text 65"/>
+          <p:cNvPr id="75" name="Text 73"/>
           <p:cNvSpPr/>
           <p:nvPr/>
         </p:nvSpPr>
@@ -11544,7 +11788,7 @@
       </p:sp>
       <p:sp>
         <p:nvSpPr>
-          <p:cNvPr id="68" name="Shape 66"/>
+          <p:cNvPr id="76" name="Shape 74"/>
           <p:cNvSpPr/>
           <p:nvPr/>
         </p:nvSpPr>
@@ -11566,7 +11810,7 @@
       </p:sp>
       <p:sp>
         <p:nvSpPr>
-          <p:cNvPr id="69" name="Text 67"/>
+          <p:cNvPr id="77" name="Text 75"/>
           <p:cNvSpPr/>
           <p:nvPr/>
         </p:nvSpPr>
@@ -11605,7 +11849,7 @@
       </p:sp>
       <p:sp>
         <p:nvSpPr>
-          <p:cNvPr id="70" name="Text 68"/>
+          <p:cNvPr id="78" name="Text 76"/>
           <p:cNvSpPr/>
           <p:nvPr/>
         </p:nvSpPr>
@@ -11644,7 +11888,7 @@
       </p:sp>
       <p:sp>
         <p:nvSpPr>
-          <p:cNvPr id="71" name="Text 69"/>
+          <p:cNvPr id="79" name="Text 77"/>
           <p:cNvSpPr/>
           <p:nvPr/>
         </p:nvSpPr>
@@ -11683,7 +11927,7 @@
       </p:sp>
       <p:sp>
         <p:nvSpPr>
-          <p:cNvPr id="72" name="Shape 70"/>
+          <p:cNvPr id="80" name="Shape 78"/>
           <p:cNvSpPr/>
           <p:nvPr/>
         </p:nvSpPr>
@@ -11705,7 +11949,7 @@
       </p:sp>
       <p:sp>
         <p:nvSpPr>
-          <p:cNvPr id="73" name="Text 71"/>
+          <p:cNvPr id="81" name="Text 79"/>
           <p:cNvSpPr/>
           <p:nvPr/>
         </p:nvSpPr>
@@ -11744,7 +11988,7 @@
       </p:sp>
       <p:sp>
         <p:nvSpPr>
-          <p:cNvPr id="74" name="Text 72"/>
+          <p:cNvPr id="82" name="Text 80"/>
           <p:cNvSpPr/>
           <p:nvPr/>
         </p:nvSpPr>
@@ -11783,7 +12027,7 @@
       </p:sp>
       <p:sp>
         <p:nvSpPr>
-          <p:cNvPr id="75" name="Text 73"/>
+          <p:cNvPr id="83" name="Text 81"/>
           <p:cNvSpPr/>
           <p:nvPr/>
         </p:nvSpPr>
@@ -11822,7 +12066,7 @@
       </p:sp>
       <p:sp>
         <p:nvSpPr>
-          <p:cNvPr id="76" name="Shape 74"/>
+          <p:cNvPr id="84" name="Shape 82"/>
           <p:cNvSpPr/>
           <p:nvPr/>
         </p:nvSpPr>
@@ -11844,7 +12088,7 @@
       </p:sp>
       <p:sp>
         <p:nvSpPr>
-          <p:cNvPr id="77" name="Text 75"/>
+          <p:cNvPr id="85" name="Text 83"/>
           <p:cNvSpPr/>
           <p:nvPr/>
         </p:nvSpPr>
@@ -11883,7 +12127,7 @@
       </p:sp>
       <p:sp>
         <p:nvSpPr>
-          <p:cNvPr id="78" name="Shape 76"/>
+          <p:cNvPr id="86" name="Shape 84"/>
           <p:cNvSpPr/>
           <p:nvPr/>
         </p:nvSpPr>
@@ -11903,7 +12147,7 @@
       </p:sp>
       <p:sp>
         <p:nvSpPr>
-          <p:cNvPr id="79" name="Text 77"/>
+          <p:cNvPr id="87" name="Text 85"/>
           <p:cNvSpPr/>
           <p:nvPr/>
         </p:nvSpPr>
@@ -11942,7 +12186,7 @@
       </p:sp>
       <p:sp>
         <p:nvSpPr>
-          <p:cNvPr id="80" name="Text 78"/>
+          <p:cNvPr id="88" name="Text 86"/>
           <p:cNvSpPr/>
           <p:nvPr/>
         </p:nvSpPr>
@@ -11981,7 +12225,7 @@
       </p:sp>
       <p:sp>
         <p:nvSpPr>
-          <p:cNvPr id="81" name="Shape 79"/>
+          <p:cNvPr id="89" name="Shape 87"/>
           <p:cNvSpPr/>
           <p:nvPr/>
         </p:nvSpPr>
@@ -12003,7 +12247,7 @@
       </p:sp>
       <p:sp>
         <p:nvSpPr>
-          <p:cNvPr id="82" name="Text 80"/>
+          <p:cNvPr id="90" name="Text 88"/>
           <p:cNvSpPr/>
           <p:nvPr/>
         </p:nvSpPr>
@@ -12042,7 +12286,7 @@
       </p:sp>
       <p:sp>
         <p:nvSpPr>
-          <p:cNvPr id="83" name="Text 81"/>
+          <p:cNvPr id="91" name="Text 89"/>
           <p:cNvSpPr/>
           <p:nvPr/>
         </p:nvSpPr>
@@ -12081,7 +12325,7 @@
       </p:sp>
       <p:sp>
         <p:nvSpPr>
-          <p:cNvPr id="84" name="Text 82"/>
+          <p:cNvPr id="92" name="Text 90"/>
           <p:cNvSpPr/>
           <p:nvPr/>
         </p:nvSpPr>
@@ -12120,7 +12364,7 @@
       </p:sp>
       <p:sp>
         <p:nvSpPr>
-          <p:cNvPr id="85" name="Shape 83"/>
+          <p:cNvPr id="93" name="Shape 91"/>
           <p:cNvSpPr/>
           <p:nvPr/>
         </p:nvSpPr>
@@ -12142,7 +12386,7 @@
       </p:sp>
       <p:sp>
         <p:nvSpPr>
-          <p:cNvPr id="86" name="Text 84"/>
+          <p:cNvPr id="94" name="Text 92"/>
           <p:cNvSpPr/>
           <p:nvPr/>
         </p:nvSpPr>
@@ -12181,7 +12425,7 @@
       </p:sp>
       <p:sp>
         <p:nvSpPr>
-          <p:cNvPr id="87" name="Shape 85"/>
+          <p:cNvPr id="95" name="Shape 93"/>
           <p:cNvSpPr/>
           <p:nvPr/>
         </p:nvSpPr>
@@ -12203,7 +12447,7 @@
       </p:sp>
       <p:sp>
         <p:nvSpPr>
-          <p:cNvPr id="88" name="Text 86"/>
+          <p:cNvPr id="96" name="Text 94"/>
           <p:cNvSpPr/>
           <p:nvPr/>
         </p:nvSpPr>
@@ -12242,7 +12486,7 @@
       </p:sp>
       <p:sp>
         <p:nvSpPr>
-          <p:cNvPr id="89" name="Shape 87"/>
+          <p:cNvPr id="97" name="Shape 95"/>
           <p:cNvSpPr/>
           <p:nvPr/>
         </p:nvSpPr>
@@ -12264,7 +12508,7 @@
       </p:sp>
       <p:sp>
         <p:nvSpPr>
-          <p:cNvPr id="90" name="Text 88"/>
+          <p:cNvPr id="98" name="Text 96"/>
           <p:cNvSpPr/>
           <p:nvPr/>
         </p:nvSpPr>

</xml_diff>